<commit_message>
added system diagam slide
</commit_message>
<xml_diff>
--- a/booklets/1835365_RLIOC - Welcome to Mars. Please Don’t Die..pptx
+++ b/booklets/1835365_RLIOC - Welcome to Mars. Please Don’t Die..pptx
@@ -38,30 +38,32 @@
     <p:sldId id="283" r:id="rId33"/>
     <p:sldId id="284" r:id="rId34"/>
     <p:sldId id="285" r:id="rId35"/>
+    <p:sldId id="286" r:id="rId36"/>
+    <p:sldId id="287" r:id="rId37"/>
   </p:sldIdLst>
   <p:sldSz cy="5143500" cx="9144000"/>
   <p:notesSz cx="6858000" cy="9144000"/>
   <p:embeddedFontLst>
     <p:embeddedFont>
       <p:font typeface="Montserrat"/>
-      <p:regular r:id="rId36"/>
-      <p:bold r:id="rId37"/>
-      <p:italic r:id="rId38"/>
-      <p:boldItalic r:id="rId39"/>
+      <p:regular r:id="rId38"/>
+      <p:bold r:id="rId39"/>
+      <p:italic r:id="rId40"/>
+      <p:boldItalic r:id="rId41"/>
     </p:embeddedFont>
     <p:embeddedFont>
       <p:font typeface="Lato"/>
-      <p:regular r:id="rId40"/>
-      <p:bold r:id="rId41"/>
-      <p:italic r:id="rId42"/>
-      <p:boldItalic r:id="rId43"/>
+      <p:regular r:id="rId42"/>
+      <p:bold r:id="rId43"/>
+      <p:italic r:id="rId44"/>
+      <p:boldItalic r:id="rId45"/>
     </p:embeddedFont>
     <p:embeddedFont>
       <p:font typeface="Roboto Mono"/>
-      <p:regular r:id="rId44"/>
-      <p:bold r:id="rId45"/>
-      <p:italic r:id="rId46"/>
-      <p:boldItalic r:id="rId47"/>
+      <p:regular r:id="rId46"/>
+      <p:bold r:id="rId47"/>
+      <p:italic r:id="rId48"/>
+      <p:boldItalic r:id="rId49"/>
     </p:embeddedFont>
   </p:embeddedFontLst>
   <p:defaultTextStyle>
@@ -842,7 +844,7 @@
   <p:cSld>
     <p:spTree>
       <p:nvGrpSpPr>
-        <p:cNvPr id="181" name="Shape 181"/>
+        <p:cNvPr id="182" name="Shape 182"/>
         <p:cNvGrpSpPr/>
         <p:nvPr/>
       </p:nvGrpSpPr>
@@ -856,7 +858,7 @@
       </p:grpSpPr>
       <p:sp>
         <p:nvSpPr>
-          <p:cNvPr id="182" name="Google Shape;182;g3ce994b93ca_0_47:notes"/>
+          <p:cNvPr id="183" name="Google Shape;183;g3ce994b93ca_0_87:notes"/>
           <p:cNvSpPr/>
           <p:nvPr>
             <p:ph idx="2" type="sldImg"/>
@@ -891,7 +893,7 @@
       </p:sp>
       <p:sp>
         <p:nvSpPr>
-          <p:cNvPr id="183" name="Google Shape;183;g3ce994b93ca_0_47:notes"/>
+          <p:cNvPr id="184" name="Google Shape;184;g3ce994b93ca_0_87:notes"/>
           <p:cNvSpPr txBox="1"/>
           <p:nvPr>
             <p:ph idx="1" type="body"/>
@@ -941,7 +943,7 @@
   <p:cSld>
     <p:spTree>
       <p:nvGrpSpPr>
-        <p:cNvPr id="186" name="Shape 186"/>
+        <p:cNvPr id="187" name="Shape 187"/>
         <p:cNvGrpSpPr/>
         <p:nvPr/>
       </p:nvGrpSpPr>
@@ -955,7 +957,7 @@
       </p:grpSpPr>
       <p:sp>
         <p:nvSpPr>
-          <p:cNvPr id="187" name="Google Shape;187;g3ce994b93ca_0_19:notes"/>
+          <p:cNvPr id="188" name="Google Shape;188;g3ce994b93ca_0_8:notes"/>
           <p:cNvSpPr/>
           <p:nvPr>
             <p:ph idx="2" type="sldImg"/>
@@ -990,7 +992,7 @@
       </p:sp>
       <p:sp>
         <p:nvSpPr>
-          <p:cNvPr id="188" name="Google Shape;188;g3ce994b93ca_0_19:notes"/>
+          <p:cNvPr id="189" name="Google Shape;189;g3ce994b93ca_0_8:notes"/>
           <p:cNvSpPr txBox="1"/>
           <p:nvPr>
             <p:ph idx="1" type="body"/>
@@ -1040,7 +1042,7 @@
   <p:cSld>
     <p:spTree>
       <p:nvGrpSpPr>
-        <p:cNvPr id="192" name="Shape 192"/>
+        <p:cNvPr id="193" name="Shape 193"/>
         <p:cNvGrpSpPr/>
         <p:nvPr/>
       </p:nvGrpSpPr>
@@ -1054,7 +1056,7 @@
       </p:grpSpPr>
       <p:sp>
         <p:nvSpPr>
-          <p:cNvPr id="193" name="Google Shape;193;g3ce994b93ca_0_29:notes"/>
+          <p:cNvPr id="194" name="Google Shape;194;g3ce994b93ca_0_47:notes"/>
           <p:cNvSpPr/>
           <p:nvPr>
             <p:ph idx="2" type="sldImg"/>
@@ -1089,7 +1091,7 @@
       </p:sp>
       <p:sp>
         <p:nvSpPr>
-          <p:cNvPr id="194" name="Google Shape;194;g3ce994b93ca_0_29:notes"/>
+          <p:cNvPr id="195" name="Google Shape;195;g3ce994b93ca_0_47:notes"/>
           <p:cNvSpPr txBox="1"/>
           <p:nvPr>
             <p:ph idx="1" type="body"/>
@@ -1139,7 +1141,7 @@
   <p:cSld>
     <p:spTree>
       <p:nvGrpSpPr>
-        <p:cNvPr id="197" name="Shape 197"/>
+        <p:cNvPr id="198" name="Shape 198"/>
         <p:cNvGrpSpPr/>
         <p:nvPr/>
       </p:nvGrpSpPr>
@@ -1153,7 +1155,7 @@
       </p:grpSpPr>
       <p:sp>
         <p:nvSpPr>
-          <p:cNvPr id="198" name="Google Shape;198;g3ce994b93ca_24_6:notes"/>
+          <p:cNvPr id="199" name="Google Shape;199;g3ce994b93ca_0_19:notes"/>
           <p:cNvSpPr/>
           <p:nvPr>
             <p:ph idx="2" type="sldImg"/>
@@ -1188,7 +1190,7 @@
       </p:sp>
       <p:sp>
         <p:nvSpPr>
-          <p:cNvPr id="199" name="Google Shape;199;g3ce994b93ca_24_6:notes"/>
+          <p:cNvPr id="200" name="Google Shape;200;g3ce994b93ca_0_19:notes"/>
           <p:cNvSpPr txBox="1"/>
           <p:nvPr>
             <p:ph idx="1" type="body"/>
@@ -1238,7 +1240,7 @@
   <p:cSld>
     <p:spTree>
       <p:nvGrpSpPr>
-        <p:cNvPr id="203" name="Shape 203"/>
+        <p:cNvPr id="204" name="Shape 204"/>
         <p:cNvGrpSpPr/>
         <p:nvPr/>
       </p:nvGrpSpPr>
@@ -1252,7 +1254,7 @@
       </p:grpSpPr>
       <p:sp>
         <p:nvSpPr>
-          <p:cNvPr id="204" name="Google Shape;204;g3ce994b93ca_0_91:notes"/>
+          <p:cNvPr id="205" name="Google Shape;205;g3ce994b93ca_0_29:notes"/>
           <p:cNvSpPr/>
           <p:nvPr>
             <p:ph idx="2" type="sldImg"/>
@@ -1287,7 +1289,7 @@
       </p:sp>
       <p:sp>
         <p:nvSpPr>
-          <p:cNvPr id="205" name="Google Shape;205;g3ce994b93ca_0_91:notes"/>
+          <p:cNvPr id="206" name="Google Shape;206;g3ce994b93ca_0_29:notes"/>
           <p:cNvSpPr txBox="1"/>
           <p:nvPr>
             <p:ph idx="1" type="body"/>
@@ -1337,7 +1339,7 @@
   <p:cSld>
     <p:spTree>
       <p:nvGrpSpPr>
-        <p:cNvPr id="208" name="Shape 208"/>
+        <p:cNvPr id="209" name="Shape 209"/>
         <p:cNvGrpSpPr/>
         <p:nvPr/>
       </p:nvGrpSpPr>
@@ -1351,7 +1353,7 @@
       </p:grpSpPr>
       <p:sp>
         <p:nvSpPr>
-          <p:cNvPr id="209" name="Google Shape;209;g3ce994b93ca_24_12:notes"/>
+          <p:cNvPr id="210" name="Google Shape;210;g3ce994b93ca_24_6:notes"/>
           <p:cNvSpPr/>
           <p:nvPr>
             <p:ph idx="2" type="sldImg"/>
@@ -1386,7 +1388,7 @@
       </p:sp>
       <p:sp>
         <p:nvSpPr>
-          <p:cNvPr id="210" name="Google Shape;210;g3ce994b93ca_24_12:notes"/>
+          <p:cNvPr id="211" name="Google Shape;211;g3ce994b93ca_24_6:notes"/>
           <p:cNvSpPr txBox="1"/>
           <p:nvPr>
             <p:ph idx="1" type="body"/>
@@ -1436,7 +1438,7 @@
   <p:cSld>
     <p:spTree>
       <p:nvGrpSpPr>
-        <p:cNvPr id="214" name="Shape 214"/>
+        <p:cNvPr id="215" name="Shape 215"/>
         <p:cNvGrpSpPr/>
         <p:nvPr/>
       </p:nvGrpSpPr>
@@ -1450,7 +1452,7 @@
       </p:grpSpPr>
       <p:sp>
         <p:nvSpPr>
-          <p:cNvPr id="215" name="Google Shape;215;g3ce994b93ca_0_95:notes"/>
+          <p:cNvPr id="216" name="Google Shape;216;g3ce994b93ca_0_91:notes"/>
           <p:cNvSpPr/>
           <p:nvPr>
             <p:ph idx="2" type="sldImg"/>
@@ -1485,7 +1487,7 @@
       </p:sp>
       <p:sp>
         <p:nvSpPr>
-          <p:cNvPr id="216" name="Google Shape;216;g3ce994b93ca_0_95:notes"/>
+          <p:cNvPr id="217" name="Google Shape;217;g3ce994b93ca_0_91:notes"/>
           <p:cNvSpPr txBox="1"/>
           <p:nvPr>
             <p:ph idx="1" type="body"/>
@@ -1535,7 +1537,7 @@
   <p:cSld>
     <p:spTree>
       <p:nvGrpSpPr>
-        <p:cNvPr id="219" name="Shape 219"/>
+        <p:cNvPr id="220" name="Shape 220"/>
         <p:cNvGrpSpPr/>
         <p:nvPr/>
       </p:nvGrpSpPr>
@@ -1549,7 +1551,7 @@
       </p:grpSpPr>
       <p:sp>
         <p:nvSpPr>
-          <p:cNvPr id="220" name="Google Shape;220;g3ce994b93ca_24_19:notes"/>
+          <p:cNvPr id="221" name="Google Shape;221;g3ce994b93ca_24_12:notes"/>
           <p:cNvSpPr/>
           <p:nvPr>
             <p:ph idx="2" type="sldImg"/>
@@ -1584,7 +1586,7 @@
       </p:sp>
       <p:sp>
         <p:nvSpPr>
-          <p:cNvPr id="221" name="Google Shape;221;g3ce994b93ca_24_19:notes"/>
+          <p:cNvPr id="222" name="Google Shape;222;g3ce994b93ca_24_12:notes"/>
           <p:cNvSpPr txBox="1"/>
           <p:nvPr>
             <p:ph idx="1" type="body"/>
@@ -1634,7 +1636,7 @@
   <p:cSld>
     <p:spTree>
       <p:nvGrpSpPr>
-        <p:cNvPr id="225" name="Shape 225"/>
+        <p:cNvPr id="226" name="Shape 226"/>
         <p:cNvGrpSpPr/>
         <p:nvPr/>
       </p:nvGrpSpPr>
@@ -1648,7 +1650,7 @@
       </p:grpSpPr>
       <p:sp>
         <p:nvSpPr>
-          <p:cNvPr id="226" name="Google Shape;226;g3ce994b93ca_0_99:notes"/>
+          <p:cNvPr id="227" name="Google Shape;227;g3ce994b93ca_0_95:notes"/>
           <p:cNvSpPr/>
           <p:nvPr>
             <p:ph idx="2" type="sldImg"/>
@@ -1683,7 +1685,7 @@
       </p:sp>
       <p:sp>
         <p:nvSpPr>
-          <p:cNvPr id="227" name="Google Shape;227;g3ce994b93ca_0_99:notes"/>
+          <p:cNvPr id="228" name="Google Shape;228;g3ce994b93ca_0_95:notes"/>
           <p:cNvSpPr txBox="1"/>
           <p:nvPr>
             <p:ph idx="1" type="body"/>
@@ -1733,7 +1735,7 @@
   <p:cSld>
     <p:spTree>
       <p:nvGrpSpPr>
-        <p:cNvPr id="230" name="Shape 230"/>
+        <p:cNvPr id="231" name="Shape 231"/>
         <p:cNvGrpSpPr/>
         <p:nvPr/>
       </p:nvGrpSpPr>
@@ -1747,7 +1749,7 @@
       </p:grpSpPr>
       <p:sp>
         <p:nvSpPr>
-          <p:cNvPr id="231" name="Google Shape;231;g3ce994b93ca_0_33:notes"/>
+          <p:cNvPr id="232" name="Google Shape;232;g3ce994b93ca_24_19:notes"/>
           <p:cNvSpPr/>
           <p:nvPr>
             <p:ph idx="2" type="sldImg"/>
@@ -1782,7 +1784,7 @@
       </p:sp>
       <p:sp>
         <p:nvSpPr>
-          <p:cNvPr id="232" name="Google Shape;232;g3ce994b93ca_0_33:notes"/>
+          <p:cNvPr id="233" name="Google Shape;233;g3ce994b93ca_24_19:notes"/>
           <p:cNvSpPr txBox="1"/>
           <p:nvPr>
             <p:ph idx="1" type="body"/>
@@ -1931,7 +1933,7 @@
   <p:cSld>
     <p:spTree>
       <p:nvGrpSpPr>
-        <p:cNvPr id="236" name="Shape 236"/>
+        <p:cNvPr id="237" name="Shape 237"/>
         <p:cNvGrpSpPr/>
         <p:nvPr/>
       </p:nvGrpSpPr>
@@ -1945,7 +1947,7 @@
       </p:grpSpPr>
       <p:sp>
         <p:nvSpPr>
-          <p:cNvPr id="237" name="Google Shape;237;g3ce994b93ca_0_43:notes"/>
+          <p:cNvPr id="238" name="Google Shape;238;g3ce994b93ca_0_99:notes"/>
           <p:cNvSpPr/>
           <p:nvPr>
             <p:ph idx="2" type="sldImg"/>
@@ -1980,7 +1982,7 @@
       </p:sp>
       <p:sp>
         <p:nvSpPr>
-          <p:cNvPr id="238" name="Google Shape;238;g3ce994b93ca_0_43:notes"/>
+          <p:cNvPr id="239" name="Google Shape;239;g3ce994b93ca_0_99:notes"/>
           <p:cNvSpPr txBox="1"/>
           <p:nvPr>
             <p:ph idx="1" type="body"/>
@@ -2030,7 +2032,7 @@
   <p:cSld>
     <p:spTree>
       <p:nvGrpSpPr>
-        <p:cNvPr id="241" name="Shape 241"/>
+        <p:cNvPr id="242" name="Shape 242"/>
         <p:cNvGrpSpPr/>
         <p:nvPr/>
       </p:nvGrpSpPr>
@@ -2044,7 +2046,7 @@
       </p:grpSpPr>
       <p:sp>
         <p:nvSpPr>
-          <p:cNvPr id="242" name="Google Shape;242;g3ce994b93ca_8_0:notes"/>
+          <p:cNvPr id="243" name="Google Shape;243;g3ce994b93ca_0_33:notes"/>
           <p:cNvSpPr/>
           <p:nvPr>
             <p:ph idx="2" type="sldImg"/>
@@ -2079,7 +2081,7 @@
       </p:sp>
       <p:sp>
         <p:nvSpPr>
-          <p:cNvPr id="243" name="Google Shape;243;g3ce994b93ca_8_0:notes"/>
+          <p:cNvPr id="244" name="Google Shape;244;g3ce994b93ca_0_33:notes"/>
           <p:cNvSpPr txBox="1"/>
           <p:nvPr>
             <p:ph idx="1" type="body"/>
@@ -2129,7 +2131,7 @@
   <p:cSld>
     <p:spTree>
       <p:nvGrpSpPr>
-        <p:cNvPr id="247" name="Shape 247"/>
+        <p:cNvPr id="248" name="Shape 248"/>
         <p:cNvGrpSpPr/>
         <p:nvPr/>
       </p:nvGrpSpPr>
@@ -2143,7 +2145,7 @@
       </p:grpSpPr>
       <p:sp>
         <p:nvSpPr>
-          <p:cNvPr id="248" name="Google Shape;248;g3ce994b93ca_0_51:notes"/>
+          <p:cNvPr id="249" name="Google Shape;249;g3ce994b93ca_0_43:notes"/>
           <p:cNvSpPr/>
           <p:nvPr>
             <p:ph idx="2" type="sldImg"/>
@@ -2178,7 +2180,7 @@
       </p:sp>
       <p:sp>
         <p:nvSpPr>
-          <p:cNvPr id="249" name="Google Shape;249;g3ce994b93ca_0_51:notes"/>
+          <p:cNvPr id="250" name="Google Shape;250;g3ce994b93ca_0_43:notes"/>
           <p:cNvSpPr txBox="1"/>
           <p:nvPr>
             <p:ph idx="1" type="body"/>
@@ -2228,7 +2230,7 @@
   <p:cSld>
     <p:spTree>
       <p:nvGrpSpPr>
-        <p:cNvPr id="252" name="Shape 252"/>
+        <p:cNvPr id="253" name="Shape 253"/>
         <p:cNvGrpSpPr/>
         <p:nvPr/>
       </p:nvGrpSpPr>
@@ -2242,7 +2244,7 @@
       </p:grpSpPr>
       <p:sp>
         <p:nvSpPr>
-          <p:cNvPr id="253" name="Google Shape;253;g3ce994b93ca_8_7:notes"/>
+          <p:cNvPr id="254" name="Google Shape;254;g3ce994b93ca_8_0:notes"/>
           <p:cNvSpPr/>
           <p:nvPr>
             <p:ph idx="2" type="sldImg"/>
@@ -2277,7 +2279,7 @@
       </p:sp>
       <p:sp>
         <p:nvSpPr>
-          <p:cNvPr id="254" name="Google Shape;254;g3ce994b93ca_8_7:notes"/>
+          <p:cNvPr id="255" name="Google Shape;255;g3ce994b93ca_8_0:notes"/>
           <p:cNvSpPr txBox="1"/>
           <p:nvPr>
             <p:ph idx="1" type="body"/>
@@ -2327,7 +2329,7 @@
   <p:cSld>
     <p:spTree>
       <p:nvGrpSpPr>
-        <p:cNvPr id="258" name="Shape 258"/>
+        <p:cNvPr id="259" name="Shape 259"/>
         <p:cNvGrpSpPr/>
         <p:nvPr/>
       </p:nvGrpSpPr>
@@ -2341,7 +2343,7 @@
       </p:grpSpPr>
       <p:sp>
         <p:nvSpPr>
-          <p:cNvPr id="259" name="Google Shape;259;g3ce994b93ca_0_55:notes"/>
+          <p:cNvPr id="260" name="Google Shape;260;g3ce994b93ca_0_51:notes"/>
           <p:cNvSpPr/>
           <p:nvPr>
             <p:ph idx="2" type="sldImg"/>
@@ -2376,7 +2378,7 @@
       </p:sp>
       <p:sp>
         <p:nvSpPr>
-          <p:cNvPr id="260" name="Google Shape;260;g3ce994b93ca_0_55:notes"/>
+          <p:cNvPr id="261" name="Google Shape;261;g3ce994b93ca_0_51:notes"/>
           <p:cNvSpPr txBox="1"/>
           <p:nvPr>
             <p:ph idx="1" type="body"/>
@@ -2426,7 +2428,7 @@
   <p:cSld>
     <p:spTree>
       <p:nvGrpSpPr>
-        <p:cNvPr id="263" name="Shape 263"/>
+        <p:cNvPr id="264" name="Shape 264"/>
         <p:cNvGrpSpPr/>
         <p:nvPr/>
       </p:nvGrpSpPr>
@@ -2440,7 +2442,7 @@
       </p:grpSpPr>
       <p:sp>
         <p:nvSpPr>
-          <p:cNvPr id="264" name="Google Shape;264;g3ce994b93ca_8_13:notes"/>
+          <p:cNvPr id="265" name="Google Shape;265;g3ce994b93ca_8_7:notes"/>
           <p:cNvSpPr/>
           <p:nvPr>
             <p:ph idx="2" type="sldImg"/>
@@ -2475,7 +2477,7 @@
       </p:sp>
       <p:sp>
         <p:nvSpPr>
-          <p:cNvPr id="265" name="Google Shape;265;g3ce994b93ca_8_13:notes"/>
+          <p:cNvPr id="266" name="Google Shape;266;g3ce994b93ca_8_7:notes"/>
           <p:cNvSpPr txBox="1"/>
           <p:nvPr>
             <p:ph idx="1" type="body"/>
@@ -2525,7 +2527,7 @@
   <p:cSld>
     <p:spTree>
       <p:nvGrpSpPr>
-        <p:cNvPr id="269" name="Shape 269"/>
+        <p:cNvPr id="270" name="Shape 270"/>
         <p:cNvGrpSpPr/>
         <p:nvPr/>
       </p:nvGrpSpPr>
@@ -2539,7 +2541,7 @@
       </p:grpSpPr>
       <p:sp>
         <p:nvSpPr>
-          <p:cNvPr id="270" name="Google Shape;270;g3ce994b93ca_0_59:notes"/>
+          <p:cNvPr id="271" name="Google Shape;271;g3ce994b93ca_0_55:notes"/>
           <p:cNvSpPr/>
           <p:nvPr>
             <p:ph idx="2" type="sldImg"/>
@@ -2574,7 +2576,7 @@
       </p:sp>
       <p:sp>
         <p:nvSpPr>
-          <p:cNvPr id="271" name="Google Shape;271;g3ce994b93ca_0_59:notes"/>
+          <p:cNvPr id="272" name="Google Shape;272;g3ce994b93ca_0_55:notes"/>
           <p:cNvSpPr txBox="1"/>
           <p:nvPr>
             <p:ph idx="1" type="body"/>
@@ -2624,7 +2626,7 @@
   <p:cSld>
     <p:spTree>
       <p:nvGrpSpPr>
-        <p:cNvPr id="274" name="Shape 274"/>
+        <p:cNvPr id="275" name="Shape 275"/>
         <p:cNvGrpSpPr/>
         <p:nvPr/>
       </p:nvGrpSpPr>
@@ -2638,7 +2640,7 @@
       </p:grpSpPr>
       <p:sp>
         <p:nvSpPr>
-          <p:cNvPr id="275" name="Google Shape;275;g3ce994b93ca_8_19:notes"/>
+          <p:cNvPr id="276" name="Google Shape;276;g3ce994b93ca_8_13:notes"/>
           <p:cNvSpPr/>
           <p:nvPr>
             <p:ph idx="2" type="sldImg"/>
@@ -2673,7 +2675,7 @@
       </p:sp>
       <p:sp>
         <p:nvSpPr>
-          <p:cNvPr id="276" name="Google Shape;276;g3ce994b93ca_8_19:notes"/>
+          <p:cNvPr id="277" name="Google Shape;277;g3ce994b93ca_8_13:notes"/>
           <p:cNvSpPr txBox="1"/>
           <p:nvPr>
             <p:ph idx="1" type="body"/>
@@ -2723,7 +2725,7 @@
   <p:cSld>
     <p:spTree>
       <p:nvGrpSpPr>
-        <p:cNvPr id="280" name="Shape 280"/>
+        <p:cNvPr id="281" name="Shape 281"/>
         <p:cNvGrpSpPr/>
         <p:nvPr/>
       </p:nvGrpSpPr>
@@ -2737,7 +2739,7 @@
       </p:grpSpPr>
       <p:sp>
         <p:nvSpPr>
-          <p:cNvPr id="281" name="Google Shape;281;g3ce994b93ca_0_63:notes"/>
+          <p:cNvPr id="282" name="Google Shape;282;g3ce994b93ca_0_59:notes"/>
           <p:cNvSpPr/>
           <p:nvPr>
             <p:ph idx="2" type="sldImg"/>
@@ -2772,7 +2774,7 @@
       </p:sp>
       <p:sp>
         <p:nvSpPr>
-          <p:cNvPr id="282" name="Google Shape;282;g3ce994b93ca_0_63:notes"/>
+          <p:cNvPr id="283" name="Google Shape;283;g3ce994b93ca_0_59:notes"/>
           <p:cNvSpPr txBox="1"/>
           <p:nvPr>
             <p:ph idx="1" type="body"/>
@@ -2822,7 +2824,7 @@
   <p:cSld>
     <p:spTree>
       <p:nvGrpSpPr>
-        <p:cNvPr id="285" name="Shape 285"/>
+        <p:cNvPr id="286" name="Shape 286"/>
         <p:cNvGrpSpPr/>
         <p:nvPr/>
       </p:nvGrpSpPr>
@@ -2836,7 +2838,7 @@
       </p:grpSpPr>
       <p:sp>
         <p:nvSpPr>
-          <p:cNvPr id="286" name="Google Shape;286;g3ce994b93ca_8_25:notes"/>
+          <p:cNvPr id="287" name="Google Shape;287;g3ce994b93ca_8_19:notes"/>
           <p:cNvSpPr/>
           <p:nvPr>
             <p:ph idx="2" type="sldImg"/>
@@ -2871,7 +2873,7 @@
       </p:sp>
       <p:sp>
         <p:nvSpPr>
-          <p:cNvPr id="287" name="Google Shape;287;g3ce994b93ca_8_25:notes"/>
+          <p:cNvPr id="288" name="Google Shape;288;g3ce994b93ca_8_19:notes"/>
           <p:cNvSpPr txBox="1"/>
           <p:nvPr>
             <p:ph idx="1" type="body"/>
@@ -2935,7 +2937,7 @@
       </p:grpSpPr>
       <p:sp>
         <p:nvSpPr>
-          <p:cNvPr id="143" name="Google Shape;143;g3ce994b93ca_5_0:notes"/>
+          <p:cNvPr id="143" name="Google Shape;143;g3ce994b93ca_0_103:notes"/>
           <p:cNvSpPr/>
           <p:nvPr>
             <p:ph idx="2" type="sldImg"/>
@@ -2970,7 +2972,7 @@
       </p:sp>
       <p:sp>
         <p:nvSpPr>
-          <p:cNvPr id="144" name="Google Shape;144;g3ce994b93ca_5_0:notes"/>
+          <p:cNvPr id="144" name="Google Shape;144;g3ce994b93ca_0_103:notes"/>
           <p:cNvSpPr txBox="1"/>
           <p:nvPr>
             <p:ph idx="1" type="body"/>
@@ -3020,7 +3022,7 @@
   <p:cSld>
     <p:spTree>
       <p:nvGrpSpPr>
-        <p:cNvPr id="291" name="Shape 291"/>
+        <p:cNvPr id="292" name="Shape 292"/>
         <p:cNvGrpSpPr/>
         <p:nvPr/>
       </p:nvGrpSpPr>
@@ -3034,7 +3036,7 @@
       </p:grpSpPr>
       <p:sp>
         <p:nvSpPr>
-          <p:cNvPr id="292" name="Google Shape;292;g3ce994b93ca_0_67:notes"/>
+          <p:cNvPr id="293" name="Google Shape;293;g3ce994b93ca_0_63:notes"/>
           <p:cNvSpPr/>
           <p:nvPr>
             <p:ph idx="2" type="sldImg"/>
@@ -3069,7 +3071,7 @@
       </p:sp>
       <p:sp>
         <p:nvSpPr>
-          <p:cNvPr id="293" name="Google Shape;293;g3ce994b93ca_0_67:notes"/>
+          <p:cNvPr id="294" name="Google Shape;294;g3ce994b93ca_0_63:notes"/>
           <p:cNvSpPr txBox="1"/>
           <p:nvPr>
             <p:ph idx="1" type="body"/>
@@ -3114,12 +3116,12 @@
 </p:notes>
 </file>
 
-<file path=ppt/notesSlides/notesSlide4.xml><?xml version="1.0" encoding="utf-8"?>
+<file path=ppt/notesSlides/notesSlide31.xml><?xml version="1.0" encoding="utf-8"?>
 <p:notes xmlns:a="http://schemas.openxmlformats.org/drawingml/2006/main" xmlns:r="http://schemas.openxmlformats.org/officeDocument/2006/relationships" xmlns:mc="http://schemas.openxmlformats.org/markup-compatibility/2006" xmlns:mv="urn:schemas-microsoft-com:mac:vml" xmlns:p="http://schemas.openxmlformats.org/presentationml/2006/main" xmlns:c="http://schemas.openxmlformats.org/drawingml/2006/chart" xmlns:dgm="http://schemas.openxmlformats.org/drawingml/2006/diagram" xmlns:o="urn:schemas-microsoft-com:office:office" xmlns:v="urn:schemas-microsoft-com:vml" xmlns:pvml="urn:schemas-microsoft-com:office:powerpoint" xmlns:com="http://schemas.openxmlformats.org/drawingml/2006/compatibility" xmlns:p14="http://schemas.microsoft.com/office/powerpoint/2010/main" xmlns:p15="http://schemas.microsoft.com/office/powerpoint/2012/main" xmlns:ahyp="http://schemas.microsoft.com/office/drawing/2018/hyperlinkcolor" showMasterPhAnim="0" showMasterSp="0">
   <p:cSld>
     <p:spTree>
       <p:nvGrpSpPr>
-        <p:cNvPr id="148" name="Shape 148"/>
+        <p:cNvPr id="297" name="Shape 297"/>
         <p:cNvGrpSpPr/>
         <p:nvPr/>
       </p:nvGrpSpPr>
@@ -3133,7 +3135,7 @@
       </p:grpSpPr>
       <p:sp>
         <p:nvSpPr>
-          <p:cNvPr id="149" name="Google Shape;149;g3ce994b93ca_0_75:notes"/>
+          <p:cNvPr id="298" name="Google Shape;298;g3ce994b93ca_8_25:notes"/>
           <p:cNvSpPr/>
           <p:nvPr>
             <p:ph idx="2" type="sldImg"/>
@@ -3168,7 +3170,7 @@
       </p:sp>
       <p:sp>
         <p:nvSpPr>
-          <p:cNvPr id="150" name="Google Shape;150;g3ce994b93ca_0_75:notes"/>
+          <p:cNvPr id="299" name="Google Shape;299;g3ce994b93ca_8_25:notes"/>
           <p:cNvSpPr txBox="1"/>
           <p:nvPr>
             <p:ph idx="1" type="body"/>
@@ -3213,12 +3215,12 @@
 </p:notes>
 </file>
 
-<file path=ppt/notesSlides/notesSlide5.xml><?xml version="1.0" encoding="utf-8"?>
+<file path=ppt/notesSlides/notesSlide32.xml><?xml version="1.0" encoding="utf-8"?>
 <p:notes xmlns:a="http://schemas.openxmlformats.org/drawingml/2006/main" xmlns:r="http://schemas.openxmlformats.org/officeDocument/2006/relationships" xmlns:mc="http://schemas.openxmlformats.org/markup-compatibility/2006" xmlns:mv="urn:schemas-microsoft-com:mac:vml" xmlns:p="http://schemas.openxmlformats.org/presentationml/2006/main" xmlns:c="http://schemas.openxmlformats.org/drawingml/2006/chart" xmlns:dgm="http://schemas.openxmlformats.org/drawingml/2006/diagram" xmlns:o="urn:schemas-microsoft-com:office:office" xmlns:v="urn:schemas-microsoft-com:vml" xmlns:pvml="urn:schemas-microsoft-com:office:powerpoint" xmlns:com="http://schemas.openxmlformats.org/drawingml/2006/compatibility" xmlns:p14="http://schemas.microsoft.com/office/powerpoint/2010/main" xmlns:p15="http://schemas.microsoft.com/office/powerpoint/2012/main" xmlns:ahyp="http://schemas.microsoft.com/office/drawing/2018/hyperlinkcolor" showMasterPhAnim="0" showMasterSp="0">
   <p:cSld>
     <p:spTree>
       <p:nvGrpSpPr>
-        <p:cNvPr id="153" name="Shape 153"/>
+        <p:cNvPr id="303" name="Shape 303"/>
         <p:cNvGrpSpPr/>
         <p:nvPr/>
       </p:nvGrpSpPr>
@@ -3232,7 +3234,7 @@
       </p:grpSpPr>
       <p:sp>
         <p:nvSpPr>
-          <p:cNvPr id="154" name="Google Shape;154;g3ce994b93ca_18_1:notes"/>
+          <p:cNvPr id="304" name="Google Shape;304;g3ce994b93ca_0_67:notes"/>
           <p:cNvSpPr/>
           <p:nvPr>
             <p:ph idx="2" type="sldImg"/>
@@ -3267,7 +3269,7 @@
       </p:sp>
       <p:sp>
         <p:nvSpPr>
-          <p:cNvPr id="155" name="Google Shape;155;g3ce994b93ca_18_1:notes"/>
+          <p:cNvPr id="305" name="Google Shape;305;g3ce994b93ca_0_67:notes"/>
           <p:cNvSpPr txBox="1"/>
           <p:nvPr>
             <p:ph idx="1" type="body"/>
@@ -3312,12 +3314,12 @@
 </p:notes>
 </file>
 
-<file path=ppt/notesSlides/notesSlide6.xml><?xml version="1.0" encoding="utf-8"?>
+<file path=ppt/notesSlides/notesSlide4.xml><?xml version="1.0" encoding="utf-8"?>
 <p:notes xmlns:a="http://schemas.openxmlformats.org/drawingml/2006/main" xmlns:r="http://schemas.openxmlformats.org/officeDocument/2006/relationships" xmlns:mc="http://schemas.openxmlformats.org/markup-compatibility/2006" xmlns:mv="urn:schemas-microsoft-com:mac:vml" xmlns:p="http://schemas.openxmlformats.org/presentationml/2006/main" xmlns:c="http://schemas.openxmlformats.org/drawingml/2006/chart" xmlns:dgm="http://schemas.openxmlformats.org/drawingml/2006/diagram" xmlns:o="urn:schemas-microsoft-com:office:office" xmlns:v="urn:schemas-microsoft-com:vml" xmlns:pvml="urn:schemas-microsoft-com:office:powerpoint" xmlns:com="http://schemas.openxmlformats.org/drawingml/2006/compatibility" xmlns:p14="http://schemas.microsoft.com/office/powerpoint/2010/main" xmlns:p15="http://schemas.microsoft.com/office/powerpoint/2012/main" xmlns:ahyp="http://schemas.microsoft.com/office/drawing/2018/hyperlinkcolor" showMasterPhAnim="0" showMasterSp="0">
   <p:cSld>
     <p:spTree>
       <p:nvGrpSpPr>
-        <p:cNvPr id="159" name="Shape 159"/>
+        <p:cNvPr id="149" name="Shape 149"/>
         <p:cNvGrpSpPr/>
         <p:nvPr/>
       </p:nvGrpSpPr>
@@ -3331,7 +3333,7 @@
       </p:grpSpPr>
       <p:sp>
         <p:nvSpPr>
-          <p:cNvPr id="160" name="Google Shape;160;g3ce994b93ca_0_83:notes"/>
+          <p:cNvPr id="150" name="Google Shape;150;g3ce994b93ca_0_114:notes"/>
           <p:cNvSpPr/>
           <p:nvPr>
             <p:ph idx="2" type="sldImg"/>
@@ -3366,7 +3368,7 @@
       </p:sp>
       <p:sp>
         <p:nvSpPr>
-          <p:cNvPr id="161" name="Google Shape;161;g3ce994b93ca_0_83:notes"/>
+          <p:cNvPr id="151" name="Google Shape;151;g3ce994b93ca_0_114:notes"/>
           <p:cNvSpPr txBox="1"/>
           <p:nvPr>
             <p:ph idx="1" type="body"/>
@@ -3411,12 +3413,12 @@
 </p:notes>
 </file>
 
-<file path=ppt/notesSlides/notesSlide7.xml><?xml version="1.0" encoding="utf-8"?>
+<file path=ppt/notesSlides/notesSlide5.xml><?xml version="1.0" encoding="utf-8"?>
 <p:notes xmlns:a="http://schemas.openxmlformats.org/drawingml/2006/main" xmlns:r="http://schemas.openxmlformats.org/officeDocument/2006/relationships" xmlns:mc="http://schemas.openxmlformats.org/markup-compatibility/2006" xmlns:mv="urn:schemas-microsoft-com:mac:vml" xmlns:p="http://schemas.openxmlformats.org/presentationml/2006/main" xmlns:c="http://schemas.openxmlformats.org/drawingml/2006/chart" xmlns:dgm="http://schemas.openxmlformats.org/drawingml/2006/diagram" xmlns:o="urn:schemas-microsoft-com:office:office" xmlns:v="urn:schemas-microsoft-com:vml" xmlns:pvml="urn:schemas-microsoft-com:office:powerpoint" xmlns:com="http://schemas.openxmlformats.org/drawingml/2006/compatibility" xmlns:p14="http://schemas.microsoft.com/office/powerpoint/2010/main" xmlns:p15="http://schemas.microsoft.com/office/powerpoint/2012/main" xmlns:ahyp="http://schemas.microsoft.com/office/drawing/2018/hyperlinkcolor" showMasterPhAnim="0" showMasterSp="0">
   <p:cSld>
     <p:spTree>
       <p:nvGrpSpPr>
-        <p:cNvPr id="164" name="Shape 164"/>
+        <p:cNvPr id="154" name="Shape 154"/>
         <p:cNvGrpSpPr/>
         <p:nvPr/>
       </p:nvGrpSpPr>
@@ -3430,7 +3432,7 @@
       </p:grpSpPr>
       <p:sp>
         <p:nvSpPr>
-          <p:cNvPr id="165" name="Google Shape;165;g3ce994b93ca_18_11:notes"/>
+          <p:cNvPr id="155" name="Google Shape;155;g3ce994b93ca_5_0:notes"/>
           <p:cNvSpPr/>
           <p:nvPr>
             <p:ph idx="2" type="sldImg"/>
@@ -3465,7 +3467,7 @@
       </p:sp>
       <p:sp>
         <p:nvSpPr>
-          <p:cNvPr id="166" name="Google Shape;166;g3ce994b93ca_18_11:notes"/>
+          <p:cNvPr id="156" name="Google Shape;156;g3ce994b93ca_5_0:notes"/>
           <p:cNvSpPr txBox="1"/>
           <p:nvPr>
             <p:ph idx="1" type="body"/>
@@ -3510,12 +3512,12 @@
 </p:notes>
 </file>
 
-<file path=ppt/notesSlides/notesSlide8.xml><?xml version="1.0" encoding="utf-8"?>
+<file path=ppt/notesSlides/notesSlide6.xml><?xml version="1.0" encoding="utf-8"?>
 <p:notes xmlns:a="http://schemas.openxmlformats.org/drawingml/2006/main" xmlns:r="http://schemas.openxmlformats.org/officeDocument/2006/relationships" xmlns:mc="http://schemas.openxmlformats.org/markup-compatibility/2006" xmlns:mv="urn:schemas-microsoft-com:mac:vml" xmlns:p="http://schemas.openxmlformats.org/presentationml/2006/main" xmlns:c="http://schemas.openxmlformats.org/drawingml/2006/chart" xmlns:dgm="http://schemas.openxmlformats.org/drawingml/2006/diagram" xmlns:o="urn:schemas-microsoft-com:office:office" xmlns:v="urn:schemas-microsoft-com:vml" xmlns:pvml="urn:schemas-microsoft-com:office:powerpoint" xmlns:com="http://schemas.openxmlformats.org/drawingml/2006/compatibility" xmlns:p14="http://schemas.microsoft.com/office/powerpoint/2010/main" xmlns:p15="http://schemas.microsoft.com/office/powerpoint/2012/main" xmlns:ahyp="http://schemas.microsoft.com/office/drawing/2018/hyperlinkcolor" showMasterPhAnim="0" showMasterSp="0">
   <p:cSld>
     <p:spTree>
       <p:nvGrpSpPr>
-        <p:cNvPr id="170" name="Shape 170"/>
+        <p:cNvPr id="160" name="Shape 160"/>
         <p:cNvGrpSpPr/>
         <p:nvPr/>
       </p:nvGrpSpPr>
@@ -3529,7 +3531,7 @@
       </p:grpSpPr>
       <p:sp>
         <p:nvSpPr>
-          <p:cNvPr id="171" name="Google Shape;171;g3ce994b93ca_0_87:notes"/>
+          <p:cNvPr id="161" name="Google Shape;161;g3ce994b93ca_0_75:notes"/>
           <p:cNvSpPr/>
           <p:nvPr>
             <p:ph idx="2" type="sldImg"/>
@@ -3564,7 +3566,7 @@
       </p:sp>
       <p:sp>
         <p:nvSpPr>
-          <p:cNvPr id="172" name="Google Shape;172;g3ce994b93ca_0_87:notes"/>
+          <p:cNvPr id="162" name="Google Shape;162;g3ce994b93ca_0_75:notes"/>
           <p:cNvSpPr txBox="1"/>
           <p:nvPr>
             <p:ph idx="1" type="body"/>
@@ -3609,12 +3611,12 @@
 </p:notes>
 </file>
 
-<file path=ppt/notesSlides/notesSlide9.xml><?xml version="1.0" encoding="utf-8"?>
+<file path=ppt/notesSlides/notesSlide7.xml><?xml version="1.0" encoding="utf-8"?>
 <p:notes xmlns:a="http://schemas.openxmlformats.org/drawingml/2006/main" xmlns:r="http://schemas.openxmlformats.org/officeDocument/2006/relationships" xmlns:mc="http://schemas.openxmlformats.org/markup-compatibility/2006" xmlns:mv="urn:schemas-microsoft-com:mac:vml" xmlns:p="http://schemas.openxmlformats.org/presentationml/2006/main" xmlns:c="http://schemas.openxmlformats.org/drawingml/2006/chart" xmlns:dgm="http://schemas.openxmlformats.org/drawingml/2006/diagram" xmlns:o="urn:schemas-microsoft-com:office:office" xmlns:v="urn:schemas-microsoft-com:vml" xmlns:pvml="urn:schemas-microsoft-com:office:powerpoint" xmlns:com="http://schemas.openxmlformats.org/drawingml/2006/compatibility" xmlns:p14="http://schemas.microsoft.com/office/powerpoint/2010/main" xmlns:p15="http://schemas.microsoft.com/office/powerpoint/2012/main" xmlns:ahyp="http://schemas.microsoft.com/office/drawing/2018/hyperlinkcolor" showMasterPhAnim="0" showMasterSp="0">
   <p:cSld>
     <p:spTree>
       <p:nvGrpSpPr>
-        <p:cNvPr id="175" name="Shape 175"/>
+        <p:cNvPr id="165" name="Shape 165"/>
         <p:cNvGrpSpPr/>
         <p:nvPr/>
       </p:nvGrpSpPr>
@@ -3628,7 +3630,7 @@
       </p:grpSpPr>
       <p:sp>
         <p:nvSpPr>
-          <p:cNvPr id="176" name="Google Shape;176;g3ce994b93ca_0_8:notes"/>
+          <p:cNvPr id="166" name="Google Shape;166;g3ce994b93ca_18_1:notes"/>
           <p:cNvSpPr/>
           <p:nvPr>
             <p:ph idx="2" type="sldImg"/>
@@ -3663,7 +3665,205 @@
       </p:sp>
       <p:sp>
         <p:nvSpPr>
-          <p:cNvPr id="177" name="Google Shape;177;g3ce994b93ca_0_8:notes"/>
+          <p:cNvPr id="167" name="Google Shape;167;g3ce994b93ca_18_1:notes"/>
+          <p:cNvSpPr txBox="1"/>
+          <p:nvPr>
+            <p:ph idx="1" type="body"/>
+          </p:nvPr>
+        </p:nvSpPr>
+        <p:spPr>
+          <a:xfrm>
+            <a:off x="685800" y="4343400"/>
+            <a:ext cx="5486400" cy="4114800"/>
+          </a:xfrm>
+          <a:prstGeom prst="rect">
+            <a:avLst/>
+          </a:prstGeom>
+        </p:spPr>
+        <p:txBody>
+          <a:bodyPr anchorCtr="0" anchor="t" bIns="91425" lIns="91425" spcFirstLastPara="1" rIns="91425" wrap="square" tIns="91425">
+            <a:noAutofit/>
+          </a:bodyPr>
+          <a:lstStyle/>
+          <a:p>
+            <a:pPr indent="0" lvl="0" marL="0" rtl="0" algn="l">
+              <a:spcBef>
+                <a:spcPts val="0"/>
+              </a:spcBef>
+              <a:spcAft>
+                <a:spcPts val="0"/>
+              </a:spcAft>
+              <a:buNone/>
+            </a:pPr>
+            <a:r>
+              <a:t/>
+            </a:r>
+            <a:endParaRPr/>
+          </a:p>
+        </p:txBody>
+      </p:sp>
+    </p:spTree>
+  </p:cSld>
+  <p:clrMapOvr>
+    <a:masterClrMapping/>
+  </p:clrMapOvr>
+</p:notes>
+</file>
+
+<file path=ppt/notesSlides/notesSlide8.xml><?xml version="1.0" encoding="utf-8"?>
+<p:notes xmlns:a="http://schemas.openxmlformats.org/drawingml/2006/main" xmlns:r="http://schemas.openxmlformats.org/officeDocument/2006/relationships" xmlns:mc="http://schemas.openxmlformats.org/markup-compatibility/2006" xmlns:mv="urn:schemas-microsoft-com:mac:vml" xmlns:p="http://schemas.openxmlformats.org/presentationml/2006/main" xmlns:c="http://schemas.openxmlformats.org/drawingml/2006/chart" xmlns:dgm="http://schemas.openxmlformats.org/drawingml/2006/diagram" xmlns:o="urn:schemas-microsoft-com:office:office" xmlns:v="urn:schemas-microsoft-com:vml" xmlns:pvml="urn:schemas-microsoft-com:office:powerpoint" xmlns:com="http://schemas.openxmlformats.org/drawingml/2006/compatibility" xmlns:p14="http://schemas.microsoft.com/office/powerpoint/2010/main" xmlns:p15="http://schemas.microsoft.com/office/powerpoint/2012/main" xmlns:ahyp="http://schemas.microsoft.com/office/drawing/2018/hyperlinkcolor" showMasterPhAnim="0" showMasterSp="0">
+  <p:cSld>
+    <p:spTree>
+      <p:nvGrpSpPr>
+        <p:cNvPr id="171" name="Shape 171"/>
+        <p:cNvGrpSpPr/>
+        <p:nvPr/>
+      </p:nvGrpSpPr>
+      <p:grpSpPr>
+        <a:xfrm>
+          <a:off x="0" y="0"/>
+          <a:ext cx="0" cy="0"/>
+          <a:chOff x="0" y="0"/>
+          <a:chExt cx="0" cy="0"/>
+        </a:xfrm>
+      </p:grpSpPr>
+      <p:sp>
+        <p:nvSpPr>
+          <p:cNvPr id="172" name="Google Shape;172;g3ce994b93ca_0_83:notes"/>
+          <p:cNvSpPr/>
+          <p:nvPr>
+            <p:ph idx="2" type="sldImg"/>
+          </p:nvPr>
+        </p:nvSpPr>
+        <p:spPr>
+          <a:xfrm>
+            <a:off x="381300" y="685800"/>
+            <a:ext cx="6096000" cy="3429000"/>
+          </a:xfrm>
+          <a:custGeom>
+            <a:rect b="b" l="l" r="r" t="t"/>
+            <a:pathLst>
+              <a:path extrusionOk="0" h="120000" w="120000">
+                <a:moveTo>
+                  <a:pt x="0" y="0"/>
+                </a:moveTo>
+                <a:lnTo>
+                  <a:pt x="120000" y="0"/>
+                </a:lnTo>
+                <a:lnTo>
+                  <a:pt x="120000" y="120000"/>
+                </a:lnTo>
+                <a:lnTo>
+                  <a:pt x="0" y="120000"/>
+                </a:lnTo>
+                <a:close/>
+              </a:path>
+            </a:pathLst>
+          </a:custGeom>
+        </p:spPr>
+      </p:sp>
+      <p:sp>
+        <p:nvSpPr>
+          <p:cNvPr id="173" name="Google Shape;173;g3ce994b93ca_0_83:notes"/>
+          <p:cNvSpPr txBox="1"/>
+          <p:nvPr>
+            <p:ph idx="1" type="body"/>
+          </p:nvPr>
+        </p:nvSpPr>
+        <p:spPr>
+          <a:xfrm>
+            <a:off x="685800" y="4343400"/>
+            <a:ext cx="5486400" cy="4114800"/>
+          </a:xfrm>
+          <a:prstGeom prst="rect">
+            <a:avLst/>
+          </a:prstGeom>
+        </p:spPr>
+        <p:txBody>
+          <a:bodyPr anchorCtr="0" anchor="t" bIns="91425" lIns="91425" spcFirstLastPara="1" rIns="91425" wrap="square" tIns="91425">
+            <a:noAutofit/>
+          </a:bodyPr>
+          <a:lstStyle/>
+          <a:p>
+            <a:pPr indent="0" lvl="0" marL="0" rtl="0" algn="l">
+              <a:spcBef>
+                <a:spcPts val="0"/>
+              </a:spcBef>
+              <a:spcAft>
+                <a:spcPts val="0"/>
+              </a:spcAft>
+              <a:buNone/>
+            </a:pPr>
+            <a:r>
+              <a:t/>
+            </a:r>
+            <a:endParaRPr/>
+          </a:p>
+        </p:txBody>
+      </p:sp>
+    </p:spTree>
+  </p:cSld>
+  <p:clrMapOvr>
+    <a:masterClrMapping/>
+  </p:clrMapOvr>
+</p:notes>
+</file>
+
+<file path=ppt/notesSlides/notesSlide9.xml><?xml version="1.0" encoding="utf-8"?>
+<p:notes xmlns:a="http://schemas.openxmlformats.org/drawingml/2006/main" xmlns:r="http://schemas.openxmlformats.org/officeDocument/2006/relationships" xmlns:mc="http://schemas.openxmlformats.org/markup-compatibility/2006" xmlns:mv="urn:schemas-microsoft-com:mac:vml" xmlns:p="http://schemas.openxmlformats.org/presentationml/2006/main" xmlns:c="http://schemas.openxmlformats.org/drawingml/2006/chart" xmlns:dgm="http://schemas.openxmlformats.org/drawingml/2006/diagram" xmlns:o="urn:schemas-microsoft-com:office:office" xmlns:v="urn:schemas-microsoft-com:vml" xmlns:pvml="urn:schemas-microsoft-com:office:powerpoint" xmlns:com="http://schemas.openxmlformats.org/drawingml/2006/compatibility" xmlns:p14="http://schemas.microsoft.com/office/powerpoint/2010/main" xmlns:p15="http://schemas.microsoft.com/office/powerpoint/2012/main" xmlns:ahyp="http://schemas.microsoft.com/office/drawing/2018/hyperlinkcolor" showMasterPhAnim="0" showMasterSp="0">
+  <p:cSld>
+    <p:spTree>
+      <p:nvGrpSpPr>
+        <p:cNvPr id="176" name="Shape 176"/>
+        <p:cNvGrpSpPr/>
+        <p:nvPr/>
+      </p:nvGrpSpPr>
+      <p:grpSpPr>
+        <a:xfrm>
+          <a:off x="0" y="0"/>
+          <a:ext cx="0" cy="0"/>
+          <a:chOff x="0" y="0"/>
+          <a:chExt cx="0" cy="0"/>
+        </a:xfrm>
+      </p:grpSpPr>
+      <p:sp>
+        <p:nvSpPr>
+          <p:cNvPr id="177" name="Google Shape;177;g3ce994b93ca_18_11:notes"/>
+          <p:cNvSpPr/>
+          <p:nvPr>
+            <p:ph idx="2" type="sldImg"/>
+          </p:nvPr>
+        </p:nvSpPr>
+        <p:spPr>
+          <a:xfrm>
+            <a:off x="381300" y="685800"/>
+            <a:ext cx="6096000" cy="3429000"/>
+          </a:xfrm>
+          <a:custGeom>
+            <a:rect b="b" l="l" r="r" t="t"/>
+            <a:pathLst>
+              <a:path extrusionOk="0" h="120000" w="120000">
+                <a:moveTo>
+                  <a:pt x="0" y="0"/>
+                </a:moveTo>
+                <a:lnTo>
+                  <a:pt x="120000" y="0"/>
+                </a:lnTo>
+                <a:lnTo>
+                  <a:pt x="120000" y="120000"/>
+                </a:lnTo>
+                <a:lnTo>
+                  <a:pt x="0" y="120000"/>
+                </a:lnTo>
+                <a:close/>
+              </a:path>
+            </a:pathLst>
+          </a:custGeom>
+        </p:spPr>
+      </p:sp>
+      <p:sp>
+        <p:nvSpPr>
+          <p:cNvPr id="178" name="Google Shape;178;g3ce994b93ca_18_11:notes"/>
           <p:cNvSpPr txBox="1"/>
           <p:nvPr>
             <p:ph idx="1" type="body"/>
@@ -12116,7 +12316,7 @@
   <p:cSld>
     <p:spTree>
       <p:nvGrpSpPr>
-        <p:cNvPr id="184" name="Shape 184"/>
+        <p:cNvPr id="185" name="Shape 185"/>
         <p:cNvGrpSpPr/>
         <p:nvPr/>
       </p:nvGrpSpPr>
@@ -12130,7 +12330,7 @@
       </p:grpSpPr>
       <p:pic>
         <p:nvPicPr>
-          <p:cNvPr descr="Beautify this slide" id="185" name="Google Shape;185;p22"/>
+          <p:cNvPr descr="Beautify this slide" id="186" name="Google Shape;186;p22"/>
           <p:cNvPicPr preferRelativeResize="0"/>
           <p:nvPr/>
         </p:nvPicPr>
@@ -12169,7 +12369,7 @@
   <p:cSld>
     <p:spTree>
       <p:nvGrpSpPr>
-        <p:cNvPr id="189" name="Shape 189"/>
+        <p:cNvPr id="190" name="Shape 190"/>
         <p:cNvGrpSpPr/>
         <p:nvPr/>
       </p:nvGrpSpPr>
@@ -12183,7 +12383,7 @@
       </p:grpSpPr>
       <p:sp>
         <p:nvSpPr>
-          <p:cNvPr id="190" name="Google Shape;190;p23"/>
+          <p:cNvPr id="191" name="Google Shape;191;p23"/>
           <p:cNvSpPr txBox="1"/>
           <p:nvPr>
             <p:ph type="title"/>
@@ -12200,7 +12400,7 @@
         </p:spPr>
         <p:txBody>
           <a:bodyPr anchorCtr="0" anchor="ctr" bIns="91425" lIns="91425" spcFirstLastPara="1" rIns="91425" wrap="square" tIns="91425">
-            <a:normAutofit/>
+            <a:normAutofit fontScale="90000"/>
           </a:bodyPr>
           <a:lstStyle/>
           <a:p>
@@ -12215,7 +12415,7 @@
             </a:pPr>
             <a:r>
               <a:rPr lang="en-GB"/>
-              <a:t>Mars Memory Cache: The Real-Time State </a:t>
+              <a:t>Mars Message Consumer: The Event Processor </a:t>
             </a:r>
             <a:endParaRPr/>
           </a:p>
@@ -12223,7 +12423,7 @@
       </p:sp>
       <p:sp>
         <p:nvSpPr>
-          <p:cNvPr id="191" name="Google Shape;191;p23"/>
+          <p:cNvPr id="192" name="Google Shape;192;p23"/>
           <p:cNvSpPr txBox="1"/>
           <p:nvPr>
             <p:ph idx="1" type="body"/>
@@ -12259,11 +12459,7 @@
             </a:r>
             <a:r>
               <a:rPr lang="en-GB" sz="1600"/>
-              <a:t>: </a:t>
-            </a:r>
-            <a:r>
-              <a:rPr lang="en-GB" sz="1600"/>
-              <a:t>The ultra-fast holder of the facility's current status.</a:t>
+              <a:t>: The background worker handling high-throughput telemetry data.</a:t>
             </a:r>
             <a:br>
               <a:rPr lang="en-GB" sz="1600"/>
@@ -12274,11 +12470,7 @@
             </a:r>
             <a:r>
               <a:rPr lang="en-GB" sz="1600"/>
-              <a:t>: </a:t>
-            </a:r>
-            <a:r>
-              <a:rPr lang="en-GB" sz="1600"/>
-              <a:t>Python, FastAPI, Redis</a:t>
+              <a:t>: Python, confluent-kafka</a:t>
             </a:r>
             <a:endParaRPr sz="1600"/>
           </a:p>
@@ -12295,7 +12487,7 @@
             </a:pPr>
             <a:r>
               <a:rPr lang="en-GB" sz="1600"/>
-              <a:t>Redis stores data entirely in RAM. It eliminates slow disk reads when checking the last known value of a sensor.</a:t>
+              <a:t>Listens to the mars-telemetry-events Kafka topic in an infinite loop. Kafka acts as a shock-absorber, preventing system crashes during data spikes.</a:t>
             </a:r>
             <a:endParaRPr sz="1600"/>
           </a:p>
@@ -12312,7 +12504,7 @@
             </a:pPr>
             <a:r>
               <a:rPr lang="en-GB" sz="1600"/>
-              <a:t>It only stores the absolute latest state of every sensor. (e.g., it overwrites temp: 22 with temp: 23).</a:t>
+              <a:t>For every reading, it queries the DB Manager (PostgreSQL) to check if the new value triggers any Automation Rules (e.g., "if temp &gt; 35, turn on fan").</a:t>
             </a:r>
             <a:endParaRPr sz="1600"/>
           </a:p>
@@ -12329,11 +12521,7 @@
             </a:pPr>
             <a:r>
               <a:rPr lang="en-GB" sz="1600"/>
-              <a:t>If rules trigger, it commands the API Gateway to physically toggle the actuator. </a:t>
-            </a:r>
-            <a:r>
-              <a:rPr lang="en-GB" sz="1600"/>
-              <a:t>When a user opens the dashboard, the Gateway fetches this entire cache instantly. This makes the UI feel infinitely responsive without hammering a traditional database.</a:t>
+              <a:t>If rules trigger, it commands the API Gateway to physically toggle the actuator. It then saves the new reading to the Cache and tells the Gateway to broadcast it.</a:t>
             </a:r>
             <a:endParaRPr sz="1600"/>
           </a:p>
@@ -12352,7 +12540,7 @@
   <p:cSld>
     <p:spTree>
       <p:nvGrpSpPr>
-        <p:cNvPr id="195" name="Shape 195"/>
+        <p:cNvPr id="196" name="Shape 196"/>
         <p:cNvGrpSpPr/>
         <p:nvPr/>
       </p:nvGrpSpPr>
@@ -12366,7 +12554,7 @@
       </p:grpSpPr>
       <p:pic>
         <p:nvPicPr>
-          <p:cNvPr descr="Beautify this slide" id="196" name="Google Shape;196;p24"/>
+          <p:cNvPr descr="Beautify this slide" id="197" name="Google Shape;197;p24"/>
           <p:cNvPicPr preferRelativeResize="0"/>
           <p:nvPr/>
         </p:nvPicPr>
@@ -12405,7 +12593,7 @@
   <p:cSld>
     <p:spTree>
       <p:nvGrpSpPr>
-        <p:cNvPr id="200" name="Shape 200"/>
+        <p:cNvPr id="201" name="Shape 201"/>
         <p:cNvGrpSpPr/>
         <p:nvPr/>
       </p:nvGrpSpPr>
@@ -12419,7 +12607,7 @@
       </p:grpSpPr>
       <p:sp>
         <p:nvSpPr>
-          <p:cNvPr id="201" name="Google Shape;201;p25"/>
+          <p:cNvPr id="202" name="Google Shape;202;p25"/>
           <p:cNvSpPr txBox="1"/>
           <p:nvPr>
             <p:ph type="title"/>
@@ -12435,8 +12623,8 @@
           </a:prstGeom>
         </p:spPr>
         <p:txBody>
-          <a:bodyPr anchorCtr="0" anchor="t" bIns="91425" lIns="91425" spcFirstLastPara="1" rIns="91425" wrap="square" tIns="91425">
-            <a:normAutofit fontScale="90000"/>
+          <a:bodyPr anchorCtr="0" anchor="ctr" bIns="91425" lIns="91425" spcFirstLastPara="1" rIns="91425" wrap="square" tIns="91425">
+            <a:normAutofit/>
           </a:bodyPr>
           <a:lstStyle/>
           <a:p>
@@ -12451,7 +12639,7 @@
             </a:pPr>
             <a:r>
               <a:rPr lang="en-GB"/>
-              <a:t>Relational DB implementation with Postgres 15</a:t>
+              <a:t>Mars Memory Cache: The Real-Time State </a:t>
             </a:r>
             <a:endParaRPr/>
           </a:p>
@@ -12459,7 +12647,7 @@
       </p:sp>
       <p:sp>
         <p:nvSpPr>
-          <p:cNvPr id="202" name="Google Shape;202;p25"/>
+          <p:cNvPr id="203" name="Google Shape;203;p25"/>
           <p:cNvSpPr txBox="1"/>
           <p:nvPr>
             <p:ph idx="1" type="body"/>
@@ -12467,8 +12655,8 @@
         </p:nvSpPr>
         <p:spPr>
           <a:xfrm>
-            <a:off x="1297500" y="1567550"/>
-            <a:ext cx="7038900" cy="2911200"/>
+            <a:off x="1297500" y="1241050"/>
+            <a:ext cx="7348500" cy="3546300"/>
           </a:xfrm>
           <a:prstGeom prst="rect">
             <a:avLst/>
@@ -12476,95 +12664,102 @@
         </p:spPr>
         <p:txBody>
           <a:bodyPr anchorCtr="0" anchor="t" bIns="91425" lIns="91425" spcFirstLastPara="1" rIns="91425" wrap="square" tIns="91425">
-            <a:normAutofit/>
+            <a:noAutofit/>
           </a:bodyPr>
           <a:lstStyle/>
           <a:p>
-            <a:pPr indent="-311150" lvl="0" marL="457200" rtl="0" algn="l">
-              <a:spcBef>
-                <a:spcPts val="0"/>
-              </a:spcBef>
-              <a:spcAft>
-                <a:spcPts val="0"/>
-              </a:spcAft>
-              <a:buSzPts val="1300"/>
-              <a:buChar char="-"/>
+            <a:pPr indent="0" lvl="0" marL="0" rtl="0" algn="l">
+              <a:spcBef>
+                <a:spcPts val="0"/>
+              </a:spcBef>
+              <a:spcAft>
+                <a:spcPts val="0"/>
+              </a:spcAft>
+              <a:buNone/>
             </a:pPr>
             <a:r>
-              <a:rPr lang="en-GB"/>
-              <a:t>Rule schema designed to natively map the automation rules </a:t>
-            </a:r>
-            <a:r>
-              <a:rPr lang="en-GB"/>
-              <a:t>expressed by IF-THEN-ELSE conditions</a:t>
-            </a:r>
-            <a:endParaRPr/>
+              <a:rPr b="1" lang="en-GB" sz="1600"/>
+              <a:t>Role</a:t>
+            </a:r>
+            <a:r>
+              <a:rPr lang="en-GB" sz="1600"/>
+              <a:t>: </a:t>
+            </a:r>
+            <a:r>
+              <a:rPr lang="en-GB" sz="1600"/>
+              <a:t>The ultra-fast holder of the facility's current status.</a:t>
+            </a:r>
+            <a:br>
+              <a:rPr lang="en-GB" sz="1600"/>
+            </a:br>
+            <a:r>
+              <a:rPr b="1" lang="en-GB" sz="1600"/>
+              <a:t>Tech</a:t>
+            </a:r>
+            <a:r>
+              <a:rPr lang="en-GB" sz="1600"/>
+              <a:t>: </a:t>
+            </a:r>
+            <a:r>
+              <a:rPr lang="en-GB" sz="1600"/>
+              <a:t>Python, FastAPI, Redis</a:t>
+            </a:r>
+            <a:endParaRPr sz="1600"/>
           </a:p>
           <a:p>
-            <a:pPr indent="0" lvl="0" marL="0" rtl="0" algn="l">
+            <a:pPr indent="-330200" lvl="0" marL="457200" rtl="0" algn="l">
               <a:spcBef>
                 <a:spcPts val="1200"/>
               </a:spcBef>
               <a:spcAft>
                 <a:spcPts val="0"/>
               </a:spcAft>
-              <a:buNone/>
+              <a:buSzPts val="1600"/>
+              <a:buChar char="●"/>
             </a:pPr>
             <a:r>
-              <a:rPr lang="en-GB"/>
-              <a:t>Table: | sensor_name | operator | threshold_value | actuator_device | actuator_state |</a:t>
-            </a:r>
-            <a:endParaRPr/>
+              <a:rPr lang="en-GB" sz="1600"/>
+              <a:t>Redis stores data entirely in RAM. It eliminates slow disk reads when checking the last known value of a sensor.</a:t>
+            </a:r>
+            <a:endParaRPr sz="1600"/>
           </a:p>
           <a:p>
-            <a:pPr indent="0" lvl="0" marL="0" rtl="0" algn="l">
-              <a:spcBef>
-                <a:spcPts val="1200"/>
-              </a:spcBef>
-              <a:spcAft>
-                <a:spcPts val="0"/>
-              </a:spcAft>
-              <a:buNone/>
+            <a:pPr indent="-330200" lvl="0" marL="457200" rtl="0" algn="l">
+              <a:spcBef>
+                <a:spcPts val="0"/>
+              </a:spcBef>
+              <a:spcAft>
+                <a:spcPts val="0"/>
+              </a:spcAft>
+              <a:buSzPts val="1600"/>
+              <a:buChar char="●"/>
             </a:pPr>
             <a:r>
-              <a:rPr lang="en-GB"/>
-              <a:t>Row: |temperature | &gt; | 30 °C | cooling fan | ON |</a:t>
-            </a:r>
-            <a:endParaRPr/>
+              <a:rPr lang="en-GB" sz="1600"/>
+              <a:t>It only stores the absolute latest state of every sensor. (e.g., it overwrites temp: 22 with temp: 23).</a:t>
+            </a:r>
+            <a:endParaRPr sz="1600"/>
           </a:p>
           <a:p>
-            <a:pPr indent="-311150" lvl="0" marL="457200" rtl="0" algn="l">
-              <a:spcBef>
-                <a:spcPts val="1200"/>
-              </a:spcBef>
-              <a:spcAft>
-                <a:spcPts val="0"/>
-              </a:spcAft>
-              <a:buSzPts val="1300"/>
-              <a:buChar char="-"/>
+            <a:pPr indent="-330200" lvl="0" marL="457200" rtl="0" algn="l">
+              <a:spcBef>
+                <a:spcPts val="0"/>
+              </a:spcBef>
+              <a:spcAft>
+                <a:spcPts val="0"/>
+              </a:spcAft>
+              <a:buSzPts val="1600"/>
+              <a:buChar char="●"/>
             </a:pPr>
             <a:r>
-              <a:rPr lang="en-GB"/>
-              <a:t>Dedicated microservice (with Python/FastAPI) to separate database logic from the rest of the system</a:t>
-            </a:r>
-            <a:endParaRPr/>
-          </a:p>
-          <a:p>
-            <a:pPr indent="-311150" lvl="0" marL="457200" rtl="0" algn="l">
-              <a:spcBef>
-                <a:spcPts val="0"/>
-              </a:spcBef>
-              <a:spcAft>
-                <a:spcPts val="0"/>
-              </a:spcAft>
-              <a:buSzPts val="1300"/>
-              <a:buChar char="-"/>
-            </a:pPr>
-            <a:r>
-              <a:rPr lang="en-GB"/>
-              <a:t>Secure endpoints exposed for data operations</a:t>
-            </a:r>
-            <a:endParaRPr/>
+              <a:rPr lang="en-GB" sz="1600"/>
+              <a:t>If rules trigger, it commands the API Gateway to physically toggle the actuator. </a:t>
+            </a:r>
+            <a:r>
+              <a:rPr lang="en-GB" sz="1600"/>
+              <a:t>When a user opens the dashboard, the Gateway fetches this entire cache instantly. This makes the UI feel infinitely responsive without hammering a traditional database.</a:t>
+            </a:r>
+            <a:endParaRPr sz="1600"/>
           </a:p>
         </p:txBody>
       </p:sp>
@@ -12581,7 +12776,7 @@
   <p:cSld>
     <p:spTree>
       <p:nvGrpSpPr>
-        <p:cNvPr id="206" name="Shape 206"/>
+        <p:cNvPr id="207" name="Shape 207"/>
         <p:cNvGrpSpPr/>
         <p:nvPr/>
       </p:nvGrpSpPr>
@@ -12595,7 +12790,7 @@
       </p:grpSpPr>
       <p:pic>
         <p:nvPicPr>
-          <p:cNvPr descr="Beautify this slide" id="207" name="Google Shape;207;p26"/>
+          <p:cNvPr descr="Beautify this slide" id="208" name="Google Shape;208;p26"/>
           <p:cNvPicPr preferRelativeResize="0"/>
           <p:nvPr/>
         </p:nvPicPr>
@@ -12634,7 +12829,7 @@
   <p:cSld>
     <p:spTree>
       <p:nvGrpSpPr>
-        <p:cNvPr id="211" name="Shape 211"/>
+        <p:cNvPr id="212" name="Shape 212"/>
         <p:cNvGrpSpPr/>
         <p:nvPr/>
       </p:nvGrpSpPr>
@@ -12648,7 +12843,7 @@
       </p:grpSpPr>
       <p:sp>
         <p:nvSpPr>
-          <p:cNvPr id="212" name="Google Shape;212;p27"/>
+          <p:cNvPr id="213" name="Google Shape;213;p27"/>
           <p:cNvSpPr txBox="1"/>
           <p:nvPr>
             <p:ph type="title"/>
@@ -12665,7 +12860,7 @@
         </p:spPr>
         <p:txBody>
           <a:bodyPr anchorCtr="0" anchor="t" bIns="91425" lIns="91425" spcFirstLastPara="1" rIns="91425" wrap="square" tIns="91425">
-            <a:normAutofit/>
+            <a:normAutofit fontScale="90000"/>
           </a:bodyPr>
           <a:lstStyle/>
           <a:p>
@@ -12680,7 +12875,7 @@
             </a:pPr>
             <a:r>
               <a:rPr lang="en-GB"/>
-              <a:t>Rule Evaluation &amp; Actuation</a:t>
+              <a:t>Relational DB implementation with Postgres 15</a:t>
             </a:r>
             <a:endParaRPr/>
           </a:p>
@@ -12688,7 +12883,7 @@
       </p:sp>
       <p:sp>
         <p:nvSpPr>
-          <p:cNvPr id="213" name="Google Shape;213;p27"/>
+          <p:cNvPr id="214" name="Google Shape;214;p27"/>
           <p:cNvSpPr txBox="1"/>
           <p:nvPr>
             <p:ph idx="1" type="body"/>
@@ -12721,14 +12916,50 @@
             </a:pPr>
             <a:r>
               <a:rPr lang="en-GB"/>
-              <a:t>Event driven automation engine</a:t>
+              <a:t>Rule schema designed to natively map the automation rules </a:t>
+            </a:r>
+            <a:r>
+              <a:rPr lang="en-GB"/>
+              <a:t>expressed by IF-THEN-ELSE conditions</a:t>
+            </a:r>
+            <a:endParaRPr/>
+          </a:p>
+          <a:p>
+            <a:pPr indent="0" lvl="0" marL="0" rtl="0" algn="l">
+              <a:spcBef>
+                <a:spcPts val="1200"/>
+              </a:spcBef>
+              <a:spcAft>
+                <a:spcPts val="0"/>
+              </a:spcAft>
+              <a:buNone/>
+            </a:pPr>
+            <a:r>
+              <a:rPr lang="en-GB"/>
+              <a:t>Table: | sensor_name | operator | threshold_value | actuator_device | actuator_state |</a:t>
+            </a:r>
+            <a:endParaRPr/>
+          </a:p>
+          <a:p>
+            <a:pPr indent="0" lvl="0" marL="0" rtl="0" algn="l">
+              <a:spcBef>
+                <a:spcPts val="1200"/>
+              </a:spcBef>
+              <a:spcAft>
+                <a:spcPts val="0"/>
+              </a:spcAft>
+              <a:buNone/>
+            </a:pPr>
+            <a:r>
+              <a:rPr lang="en-GB"/>
+              <a:t>Row: |temperature | &gt; | 30 °C | cooling fan | ON |</a:t>
             </a:r>
             <a:endParaRPr/>
           </a:p>
           <a:p>
             <a:pPr indent="-311150" lvl="0" marL="457200" rtl="0" algn="l">
               <a:spcBef>
-                <a:spcPts val="0"/>
+                <a:spcPts val="1200"/>
               </a:spcBef>
               <a:spcAft>
                 <a:spcPts val="0"/>
@@ -12738,7 +12969,7 @@
             </a:pPr>
             <a:r>
               <a:rPr lang="en-GB"/>
-              <a:t>Continuous and asynchronous listening to normalized telemetry streams arriving from Kafka</a:t>
+              <a:t>Dedicated microservice (with Python/FastAPI) to separate database logic from the rest of the system</a:t>
             </a:r>
             <a:endParaRPr/>
           </a:p>
@@ -12755,24 +12986,7 @@
             </a:pPr>
             <a:r>
               <a:rPr lang="en-GB"/>
-              <a:t>Real time rule evaluation with dynamic db queries</a:t>
-            </a:r>
-            <a:endParaRPr/>
-          </a:p>
-          <a:p>
-            <a:pPr indent="-311150" lvl="0" marL="457200" rtl="0" algn="l">
-              <a:spcBef>
-                <a:spcPts val="0"/>
-              </a:spcBef>
-              <a:spcAft>
-                <a:spcPts val="0"/>
-              </a:spcAft>
-              <a:buSzPts val="1300"/>
-              <a:buChar char="-"/>
-            </a:pPr>
-            <a:r>
-              <a:rPr lang="en-GB"/>
-              <a:t>Actuator triggering: When a threshold is breached, the consumer instantly sends an execution command to the API Gateway to change the habitat's  parameters.</a:t>
+              <a:t>Secure endpoints exposed for data operations</a:t>
             </a:r>
             <a:endParaRPr/>
           </a:p>
@@ -12791,7 +13005,7 @@
   <p:cSld>
     <p:spTree>
       <p:nvGrpSpPr>
-        <p:cNvPr id="217" name="Shape 217"/>
+        <p:cNvPr id="218" name="Shape 218"/>
         <p:cNvGrpSpPr/>
         <p:nvPr/>
       </p:nvGrpSpPr>
@@ -12805,7 +13019,7 @@
       </p:grpSpPr>
       <p:pic>
         <p:nvPicPr>
-          <p:cNvPr descr="Beautify this slide" id="218" name="Google Shape;218;p28"/>
+          <p:cNvPr descr="Beautify this slide" id="219" name="Google Shape;219;p28"/>
           <p:cNvPicPr preferRelativeResize="0"/>
           <p:nvPr/>
         </p:nvPicPr>
@@ -12844,7 +13058,7 @@
   <p:cSld>
     <p:spTree>
       <p:nvGrpSpPr>
-        <p:cNvPr id="222" name="Shape 222"/>
+        <p:cNvPr id="223" name="Shape 223"/>
         <p:cNvGrpSpPr/>
         <p:nvPr/>
       </p:nvGrpSpPr>
@@ -12858,7 +13072,7 @@
       </p:grpSpPr>
       <p:sp>
         <p:nvSpPr>
-          <p:cNvPr id="223" name="Google Shape;223;p29"/>
+          <p:cNvPr id="224" name="Google Shape;224;p29"/>
           <p:cNvSpPr txBox="1"/>
           <p:nvPr>
             <p:ph type="title"/>
@@ -12890,7 +13104,7 @@
             </a:pPr>
             <a:r>
               <a:rPr lang="en-GB"/>
-              <a:t>Middleware &amp; API Gateway</a:t>
+              <a:t>Rule Evaluation &amp; Actuation</a:t>
             </a:r>
             <a:endParaRPr/>
           </a:p>
@@ -12898,7 +13112,7 @@
       </p:sp>
       <p:sp>
         <p:nvSpPr>
-          <p:cNvPr id="224" name="Google Shape;224;p29"/>
+          <p:cNvPr id="225" name="Google Shape;225;p29"/>
           <p:cNvSpPr txBox="1"/>
           <p:nvPr>
             <p:ph idx="1" type="body"/>
@@ -12930,148 +13144,61 @@
               <a:buChar char="-"/>
             </a:pPr>
             <a:r>
-              <a:rPr lang="en-GB" sz="1100">
-                <a:latin typeface="Roboto Mono"/>
-                <a:ea typeface="Roboto Mono"/>
-                <a:cs typeface="Roboto Mono"/>
-                <a:sym typeface="Roboto Mono"/>
-              </a:rPr>
-              <a:t>mars_api_gateway</a:t>
-            </a:r>
-            <a:r>
-              <a:rPr lang="en-GB" sz="1100">
-                <a:latin typeface="Arial"/>
-                <a:ea typeface="Arial"/>
-                <a:cs typeface="Arial"/>
-                <a:sym typeface="Arial"/>
-              </a:rPr>
-              <a:t> as the sole middleware routing traffic between the React Dashboard and internal services</a:t>
-            </a:r>
-            <a:endParaRPr sz="1100">
-              <a:latin typeface="Arial"/>
-              <a:ea typeface="Arial"/>
-              <a:cs typeface="Arial"/>
-              <a:sym typeface="Arial"/>
-            </a:endParaRPr>
+              <a:rPr lang="en-GB"/>
+              <a:t>Event driven automation engine</a:t>
+            </a:r>
+            <a:endParaRPr/>
           </a:p>
           <a:p>
-            <a:pPr indent="0" lvl="0" marL="457200" rtl="0" algn="l">
-              <a:spcBef>
-                <a:spcPts val="1200"/>
-              </a:spcBef>
-              <a:spcAft>
-                <a:spcPts val="0"/>
-              </a:spcAft>
-              <a:buNone/>
+            <a:pPr indent="-311150" lvl="0" marL="457200" rtl="0" algn="l">
+              <a:spcBef>
+                <a:spcPts val="0"/>
+              </a:spcBef>
+              <a:spcAft>
+                <a:spcPts val="0"/>
+              </a:spcAft>
+              <a:buSzPts val="1300"/>
+              <a:buChar char="-"/>
             </a:pPr>
             <a:r>
-              <a:t/>
-            </a:r>
-            <a:endParaRPr sz="1100">
-              <a:latin typeface="Arial"/>
-              <a:ea typeface="Arial"/>
-              <a:cs typeface="Arial"/>
-              <a:sym typeface="Arial"/>
-            </a:endParaRPr>
+              <a:rPr lang="en-GB"/>
+              <a:t>Continuous and asynchronous listening to normalized telemetry streams arriving from Kafka</a:t>
+            </a:r>
+            <a:endParaRPr/>
           </a:p>
           <a:p>
-            <a:pPr indent="-298450" lvl="0" marL="457200" rtl="0" algn="l">
-              <a:spcBef>
-                <a:spcPts val="1200"/>
-              </a:spcBef>
-              <a:spcAft>
-                <a:spcPts val="0"/>
-              </a:spcAft>
-              <a:buSzPts val="1100"/>
-              <a:buFont typeface="Arial"/>
+            <a:pPr indent="-311150" lvl="0" marL="457200" rtl="0" algn="l">
+              <a:spcBef>
+                <a:spcPts val="0"/>
+              </a:spcBef>
+              <a:spcAft>
+                <a:spcPts val="0"/>
+              </a:spcAft>
+              <a:buSzPts val="1300"/>
               <a:buChar char="-"/>
             </a:pPr>
             <a:r>
-              <a:rPr lang="en-GB" sz="1100">
-                <a:latin typeface="Arial"/>
-                <a:ea typeface="Arial"/>
-                <a:cs typeface="Arial"/>
-                <a:sym typeface="Arial"/>
-              </a:rPr>
-              <a:t>Implemented routing functions for creating (POST), reading (GET), and deleting (DELETE) rules</a:t>
-            </a:r>
-            <a:endParaRPr sz="1100">
-              <a:latin typeface="Arial"/>
-              <a:ea typeface="Arial"/>
-              <a:cs typeface="Arial"/>
-              <a:sym typeface="Arial"/>
-            </a:endParaRPr>
+              <a:rPr lang="en-GB"/>
+              <a:t>Real time rule evaluation with dynamic db queries</a:t>
+            </a:r>
+            <a:endParaRPr/>
           </a:p>
           <a:p>
-            <a:pPr indent="0" lvl="0" marL="0" rtl="0" algn="l">
-              <a:spcBef>
-                <a:spcPts val="1200"/>
-              </a:spcBef>
-              <a:spcAft>
-                <a:spcPts val="0"/>
-              </a:spcAft>
-              <a:buNone/>
-            </a:pPr>
-            <a:r>
-              <a:t/>
-            </a:r>
-            <a:endParaRPr sz="1100">
-              <a:latin typeface="Arial"/>
-              <a:ea typeface="Arial"/>
-              <a:cs typeface="Arial"/>
-              <a:sym typeface="Arial"/>
-            </a:endParaRPr>
-          </a:p>
-          <a:p>
-            <a:pPr indent="-298450" lvl="0" marL="457200" rtl="0" algn="l">
-              <a:spcBef>
-                <a:spcPts val="1200"/>
-              </a:spcBef>
-              <a:spcAft>
-                <a:spcPts val="0"/>
-              </a:spcAft>
-              <a:buSzPts val="1100"/>
-              <a:buFont typeface="Arial"/>
+            <a:pPr indent="-311150" lvl="0" marL="457200" rtl="0" algn="l">
+              <a:spcBef>
+                <a:spcPts val="0"/>
+              </a:spcBef>
+              <a:spcAft>
+                <a:spcPts val="0"/>
+              </a:spcAft>
+              <a:buSzPts val="1300"/>
               <a:buChar char="-"/>
             </a:pPr>
             <a:r>
-              <a:rPr lang="en-GB" sz="1100">
-                <a:latin typeface="Arial"/>
-                <a:ea typeface="Arial"/>
-                <a:cs typeface="Arial"/>
-                <a:sym typeface="Arial"/>
-              </a:rPr>
-              <a:t>Core services protected: the gateway is the only endpoint exposed!</a:t>
-            </a:r>
-            <a:endParaRPr sz="1100">
-              <a:latin typeface="Arial"/>
-              <a:ea typeface="Arial"/>
-              <a:cs typeface="Arial"/>
-              <a:sym typeface="Arial"/>
-            </a:endParaRPr>
-          </a:p>
-          <a:p>
-            <a:pPr indent="0" lvl="0" marL="0" rtl="0" algn="l">
-              <a:spcBef>
-                <a:spcPts val="1200"/>
-              </a:spcBef>
-              <a:spcAft>
-                <a:spcPts val="1200"/>
-              </a:spcAft>
-              <a:buNone/>
-            </a:pPr>
-            <a:r>
-              <a:t/>
-            </a:r>
-            <a:endParaRPr sz="1100">
-              <a:solidFill>
-                <a:srgbClr val="000000"/>
-              </a:solidFill>
-              <a:latin typeface="Arial"/>
-              <a:ea typeface="Arial"/>
-              <a:cs typeface="Arial"/>
-              <a:sym typeface="Arial"/>
-            </a:endParaRPr>
+              <a:rPr lang="en-GB"/>
+              <a:t>Actuator triggering: When a threshold is breached, the consumer instantly sends an execution command to the API Gateway to change the habitat's  parameters.</a:t>
+            </a:r>
+            <a:endParaRPr/>
           </a:p>
         </p:txBody>
       </p:sp>
@@ -13088,7 +13215,7 @@
   <p:cSld>
     <p:spTree>
       <p:nvGrpSpPr>
-        <p:cNvPr id="228" name="Shape 228"/>
+        <p:cNvPr id="229" name="Shape 229"/>
         <p:cNvGrpSpPr/>
         <p:nvPr/>
       </p:nvGrpSpPr>
@@ -13102,7 +13229,7 @@
       </p:grpSpPr>
       <p:pic>
         <p:nvPicPr>
-          <p:cNvPr descr="Beautify this slide" id="229" name="Google Shape;229;p30"/>
+          <p:cNvPr descr="Beautify this slide" id="230" name="Google Shape;230;p30"/>
           <p:cNvPicPr preferRelativeResize="0"/>
           <p:nvPr/>
         </p:nvPicPr>
@@ -13141,7 +13268,7 @@
   <p:cSld>
     <p:spTree>
       <p:nvGrpSpPr>
-        <p:cNvPr id="233" name="Shape 233"/>
+        <p:cNvPr id="234" name="Shape 234"/>
         <p:cNvGrpSpPr/>
         <p:nvPr/>
       </p:nvGrpSpPr>
@@ -13155,7 +13282,7 @@
       </p:grpSpPr>
       <p:sp>
         <p:nvSpPr>
-          <p:cNvPr id="234" name="Google Shape;234;p31"/>
+          <p:cNvPr id="235" name="Google Shape;235;p31"/>
           <p:cNvSpPr txBox="1"/>
           <p:nvPr>
             <p:ph type="title"/>
@@ -13171,7 +13298,7 @@
           </a:prstGeom>
         </p:spPr>
         <p:txBody>
-          <a:bodyPr anchorCtr="0" anchor="ctr" bIns="91425" lIns="91425" spcFirstLastPara="1" rIns="91425" wrap="square" tIns="91425">
+          <a:bodyPr anchorCtr="0" anchor="t" bIns="91425" lIns="91425" spcFirstLastPara="1" rIns="91425" wrap="square" tIns="91425">
             <a:normAutofit/>
           </a:bodyPr>
           <a:lstStyle/>
@@ -13187,7 +13314,7 @@
             </a:pPr>
             <a:r>
               <a:rPr lang="en-GB"/>
-              <a:t>Mars API Gateway: The Frontend BFF </a:t>
+              <a:t>Middleware &amp; API Gateway</a:t>
             </a:r>
             <a:endParaRPr/>
           </a:p>
@@ -13195,7 +13322,7 @@
       </p:sp>
       <p:sp>
         <p:nvSpPr>
-          <p:cNvPr id="235" name="Google Shape;235;p31"/>
+          <p:cNvPr id="236" name="Google Shape;236;p31"/>
           <p:cNvSpPr txBox="1"/>
           <p:nvPr>
             <p:ph idx="1" type="body"/>
@@ -13203,8 +13330,8 @@
         </p:nvSpPr>
         <p:spPr>
           <a:xfrm>
-            <a:off x="1297500" y="1241050"/>
-            <a:ext cx="7348500" cy="3546300"/>
+            <a:off x="1297500" y="1567550"/>
+            <a:ext cx="7038900" cy="2911200"/>
           </a:xfrm>
           <a:prstGeom prst="rect">
             <a:avLst/>
@@ -13212,98 +13339,163 @@
         </p:spPr>
         <p:txBody>
           <a:bodyPr anchorCtr="0" anchor="t" bIns="91425" lIns="91425" spcFirstLastPara="1" rIns="91425" wrap="square" tIns="91425">
-            <a:noAutofit/>
+            <a:normAutofit/>
           </a:bodyPr>
           <a:lstStyle/>
           <a:p>
-            <a:pPr indent="0" lvl="0" marL="0" rtl="0" algn="l">
-              <a:spcBef>
-                <a:spcPts val="0"/>
-              </a:spcBef>
-              <a:spcAft>
-                <a:spcPts val="0"/>
-              </a:spcAft>
-              <a:buNone/>
+            <a:pPr indent="-311150" lvl="0" marL="457200" rtl="0" algn="l">
+              <a:spcBef>
+                <a:spcPts val="0"/>
+              </a:spcBef>
+              <a:spcAft>
+                <a:spcPts val="0"/>
+              </a:spcAft>
+              <a:buSzPts val="1300"/>
+              <a:buChar char="-"/>
             </a:pPr>
             <a:r>
-              <a:rPr b="1" lang="en-GB" sz="1600"/>
-              <a:t>Role</a:t>
-            </a:r>
-            <a:r>
-              <a:rPr lang="en-GB" sz="1600"/>
-              <a:t>: </a:t>
-            </a:r>
-            <a:r>
-              <a:rPr lang="en-GB" sz="1600"/>
-              <a:t>The central hub ("Backend-for-Frontend") connecting React to the microservices.</a:t>
-            </a:r>
-            <a:br>
-              <a:rPr lang="en-GB" sz="1600"/>
-            </a:br>
-            <a:r>
-              <a:rPr b="1" lang="en-GB" sz="1600"/>
-              <a:t>Tech</a:t>
-            </a:r>
-            <a:r>
-              <a:rPr lang="en-GB" sz="1600"/>
-              <a:t>: </a:t>
-            </a:r>
-            <a:r>
-              <a:rPr lang="en-GB" sz="1600"/>
-              <a:t>Python, FastAPI, WebSockets</a:t>
-            </a:r>
-            <a:endParaRPr sz="1600"/>
+              <a:rPr lang="en-GB" sz="1100">
+                <a:latin typeface="Roboto Mono"/>
+                <a:ea typeface="Roboto Mono"/>
+                <a:cs typeface="Roboto Mono"/>
+                <a:sym typeface="Roboto Mono"/>
+              </a:rPr>
+              <a:t>mars_api_gateway</a:t>
+            </a:r>
+            <a:r>
+              <a:rPr lang="en-GB" sz="1100">
+                <a:latin typeface="Arial"/>
+                <a:ea typeface="Arial"/>
+                <a:cs typeface="Arial"/>
+                <a:sym typeface="Arial"/>
+              </a:rPr>
+              <a:t> as the sole middleware routing traffic between the React Dashboard and internal services</a:t>
+            </a:r>
+            <a:endParaRPr sz="1100">
+              <a:latin typeface="Arial"/>
+              <a:ea typeface="Arial"/>
+              <a:cs typeface="Arial"/>
+              <a:sym typeface="Arial"/>
+            </a:endParaRPr>
           </a:p>
           <a:p>
-            <a:pPr indent="-330200" lvl="0" marL="457200" rtl="0" algn="l">
+            <a:pPr indent="0" lvl="0" marL="457200" rtl="0" algn="l">
               <a:spcBef>
                 <a:spcPts val="1200"/>
               </a:spcBef>
               <a:spcAft>
                 <a:spcPts val="0"/>
               </a:spcAft>
-              <a:buSzPts val="1600"/>
-              <a:buChar char="●"/>
+              <a:buNone/>
             </a:pPr>
             <a:r>
-              <a:rPr lang="en-GB" sz="1600"/>
-              <a:t>Consolidates access to the DB, Cache, and Simulator under one localhost:8000 roof, solving difficult browser CORS issues.</a:t>
-            </a:r>
-            <a:endParaRPr sz="1600"/>
+              <a:t/>
+            </a:r>
+            <a:endParaRPr sz="1100">
+              <a:latin typeface="Arial"/>
+              <a:ea typeface="Arial"/>
+              <a:cs typeface="Arial"/>
+              <a:sym typeface="Arial"/>
+            </a:endParaRPr>
           </a:p>
           <a:p>
-            <a:pPr indent="-330200" lvl="0" marL="457200" rtl="0" algn="l">
-              <a:spcBef>
-                <a:spcPts val="0"/>
-              </a:spcBef>
-              <a:spcAft>
-                <a:spcPts val="0"/>
-              </a:spcAft>
-              <a:buSzPts val="1600"/>
-              <a:buChar char="●"/>
+            <a:pPr indent="-298450" lvl="0" marL="457200" rtl="0" algn="l">
+              <a:spcBef>
+                <a:spcPts val="1200"/>
+              </a:spcBef>
+              <a:spcAft>
+                <a:spcPts val="0"/>
+              </a:spcAft>
+              <a:buSzPts val="1100"/>
+              <a:buFont typeface="Arial"/>
+              <a:buChar char="-"/>
             </a:pPr>
             <a:r>
-              <a:rPr lang="en-GB" sz="1600"/>
-              <a:t>Maintains open WebSockets with all active users. When the Consumer broadcasts a new event, the Gateway pushes it instantly to the React app.</a:t>
-            </a:r>
-            <a:endParaRPr sz="1600"/>
+              <a:rPr lang="en-GB" sz="1100">
+                <a:latin typeface="Arial"/>
+                <a:ea typeface="Arial"/>
+                <a:cs typeface="Arial"/>
+                <a:sym typeface="Arial"/>
+              </a:rPr>
+              <a:t>Implemented routing functions for creating (POST), reading (GET), and deleting (DELETE) rules</a:t>
+            </a:r>
+            <a:endParaRPr sz="1100">
+              <a:latin typeface="Arial"/>
+              <a:ea typeface="Arial"/>
+              <a:cs typeface="Arial"/>
+              <a:sym typeface="Arial"/>
+            </a:endParaRPr>
           </a:p>
           <a:p>
-            <a:pPr indent="-330200" lvl="0" marL="457200" rtl="0" algn="l">
-              <a:spcBef>
-                <a:spcPts val="0"/>
-              </a:spcBef>
-              <a:spcAft>
-                <a:spcPts val="0"/>
-              </a:spcAft>
-              <a:buSzPts val="1600"/>
-              <a:buChar char="●"/>
+            <a:pPr indent="0" lvl="0" marL="0" rtl="0" algn="l">
+              <a:spcBef>
+                <a:spcPts val="1200"/>
+              </a:spcBef>
+              <a:spcAft>
+                <a:spcPts val="0"/>
+              </a:spcAft>
+              <a:buNone/>
             </a:pPr>
             <a:r>
-              <a:rPr lang="en-GB" sz="1600"/>
-              <a:t>Proxies frontend requests (like creating or deleting automation rules) to the isolated DB Manager, enforcing strict separation of concerns.</a:t>
-            </a:r>
-            <a:endParaRPr sz="1600"/>
+              <a:t/>
+            </a:r>
+            <a:endParaRPr sz="1100">
+              <a:latin typeface="Arial"/>
+              <a:ea typeface="Arial"/>
+              <a:cs typeface="Arial"/>
+              <a:sym typeface="Arial"/>
+            </a:endParaRPr>
+          </a:p>
+          <a:p>
+            <a:pPr indent="-298450" lvl="0" marL="457200" rtl="0" algn="l">
+              <a:spcBef>
+                <a:spcPts val="1200"/>
+              </a:spcBef>
+              <a:spcAft>
+                <a:spcPts val="0"/>
+              </a:spcAft>
+              <a:buSzPts val="1100"/>
+              <a:buFont typeface="Arial"/>
+              <a:buChar char="-"/>
+            </a:pPr>
+            <a:r>
+              <a:rPr lang="en-GB" sz="1100">
+                <a:latin typeface="Arial"/>
+                <a:ea typeface="Arial"/>
+                <a:cs typeface="Arial"/>
+                <a:sym typeface="Arial"/>
+              </a:rPr>
+              <a:t>Core services protected: the gateway is the only endpoint exposed!</a:t>
+            </a:r>
+            <a:endParaRPr sz="1100">
+              <a:latin typeface="Arial"/>
+              <a:ea typeface="Arial"/>
+              <a:cs typeface="Arial"/>
+              <a:sym typeface="Arial"/>
+            </a:endParaRPr>
+          </a:p>
+          <a:p>
+            <a:pPr indent="0" lvl="0" marL="0" rtl="0" algn="l">
+              <a:spcBef>
+                <a:spcPts val="1200"/>
+              </a:spcBef>
+              <a:spcAft>
+                <a:spcPts val="1200"/>
+              </a:spcAft>
+              <a:buNone/>
+            </a:pPr>
+            <a:r>
+              <a:t/>
+            </a:r>
+            <a:endParaRPr sz="1100">
+              <a:solidFill>
+                <a:srgbClr val="000000"/>
+              </a:solidFill>
+              <a:latin typeface="Arial"/>
+              <a:ea typeface="Arial"/>
+              <a:cs typeface="Arial"/>
+              <a:sym typeface="Arial"/>
+            </a:endParaRPr>
           </a:p>
         </p:txBody>
       </p:sp>
@@ -13373,7 +13565,7 @@
   <p:cSld>
     <p:spTree>
       <p:nvGrpSpPr>
-        <p:cNvPr id="239" name="Shape 239"/>
+        <p:cNvPr id="240" name="Shape 240"/>
         <p:cNvGrpSpPr/>
         <p:nvPr/>
       </p:nvGrpSpPr>
@@ -13387,7 +13579,7 @@
       </p:grpSpPr>
       <p:pic>
         <p:nvPicPr>
-          <p:cNvPr descr="Beautify this slide" id="240" name="Google Shape;240;p32"/>
+          <p:cNvPr descr="Beautify this slide" id="241" name="Google Shape;241;p32"/>
           <p:cNvPicPr preferRelativeResize="0"/>
           <p:nvPr/>
         </p:nvPicPr>
@@ -13426,7 +13618,7 @@
   <p:cSld>
     <p:spTree>
       <p:nvGrpSpPr>
-        <p:cNvPr id="244" name="Shape 244"/>
+        <p:cNvPr id="245" name="Shape 245"/>
         <p:cNvGrpSpPr/>
         <p:nvPr/>
       </p:nvGrpSpPr>
@@ -13440,7 +13632,7 @@
       </p:grpSpPr>
       <p:sp>
         <p:nvSpPr>
-          <p:cNvPr id="245" name="Google Shape;245;p33"/>
+          <p:cNvPr id="246" name="Google Shape;246;p33"/>
           <p:cNvSpPr txBox="1"/>
           <p:nvPr>
             <p:ph type="title"/>
@@ -13449,7 +13641,7 @@
         <p:spPr>
           <a:xfrm>
             <a:off x="1297500" y="393750"/>
-            <a:ext cx="7308600" cy="914100"/>
+            <a:ext cx="7038900" cy="914100"/>
           </a:xfrm>
           <a:prstGeom prst="rect">
             <a:avLst/>
@@ -13457,7 +13649,7 @@
         </p:spPr>
         <p:txBody>
           <a:bodyPr anchorCtr="0" anchor="ctr" bIns="91425" lIns="91425" spcFirstLastPara="1" rIns="91425" wrap="square" tIns="91425">
-            <a:normAutofit fontScale="90000"/>
+            <a:normAutofit/>
           </a:bodyPr>
           <a:lstStyle/>
           <a:p>
@@ -13471,32 +13663,16 @@
               <a:buNone/>
             </a:pPr>
             <a:r>
-              <a:rPr b="1" lang="en-GB"/>
-              <a:t>MARS_OS Command Center: </a:t>
-            </a:r>
-            <a:endParaRPr b="1"/>
-          </a:p>
-          <a:p>
-            <a:pPr indent="0" lvl="0" marL="0" rtl="0" algn="l">
-              <a:spcBef>
-                <a:spcPts val="0"/>
-              </a:spcBef>
-              <a:spcAft>
-                <a:spcPts val="0"/>
-              </a:spcAft>
-              <a:buNone/>
-            </a:pPr>
-            <a:r>
-              <a:rPr b="1" lang="en-GB"/>
-              <a:t>Frontend Architecture</a:t>
-            </a:r>
-            <a:endParaRPr b="1"/>
+              <a:rPr lang="en-GB"/>
+              <a:t>Mars API Gateway: The Frontend BFF </a:t>
+            </a:r>
+            <a:endParaRPr/>
           </a:p>
         </p:txBody>
       </p:sp>
       <p:sp>
         <p:nvSpPr>
-          <p:cNvPr id="246" name="Google Shape;246;p33"/>
+          <p:cNvPr id="247" name="Google Shape;247;p33"/>
           <p:cNvSpPr txBox="1"/>
           <p:nvPr>
             <p:ph idx="1" type="body"/>
@@ -13527,7 +13703,31 @@
               <a:buNone/>
             </a:pPr>
             <a:r>
-              <a:t/>
+              <a:rPr b="1" lang="en-GB" sz="1600"/>
+              <a:t>Role</a:t>
+            </a:r>
+            <a:r>
+              <a:rPr lang="en-GB" sz="1600"/>
+              <a:t>: </a:t>
+            </a:r>
+            <a:r>
+              <a:rPr lang="en-GB" sz="1600"/>
+              <a:t>The central hub ("Backend-for-Frontend") connecting React to the microservices.</a:t>
+            </a:r>
+            <a:br>
+              <a:rPr lang="en-GB" sz="1600"/>
+            </a:br>
+            <a:r>
+              <a:rPr b="1" lang="en-GB" sz="1600"/>
+              <a:t>Tech</a:t>
+            </a:r>
+            <a:r>
+              <a:rPr lang="en-GB" sz="1600"/>
+              <a:t>: </a:t>
+            </a:r>
+            <a:r>
+              <a:rPr lang="en-GB" sz="1600"/>
+              <a:t>Python, FastAPI, WebSockets</a:t>
             </a:r>
             <a:endParaRPr sz="1600"/>
           </a:p>
@@ -13543,12 +13743,8 @@
               <a:buChar char="●"/>
             </a:pPr>
             <a:r>
-              <a:rPr b="1" lang="en-GB" sz="1600"/>
-              <a:t>Objective</a:t>
-            </a:r>
-            <a:r>
               <a:rPr lang="en-GB" sz="1600"/>
-              <a:t>: develop an operational Head-Up Display (HUD) for real-time monitoring and control of the Mars base.</a:t>
+              <a:t>Consolidates access to the DB, Cache, and Simulator under one localhost:8000 roof, solving difficult browser CORS issues.</a:t>
             </a:r>
             <a:endParaRPr sz="1600"/>
           </a:p>
@@ -13564,12 +13760,25 @@
               <a:buChar char="●"/>
             </a:pPr>
             <a:r>
-              <a:rPr b="1" lang="en-GB" sz="1600"/>
-              <a:t>Key Requirements</a:t>
-            </a:r>
-            <a:r>
               <a:rPr lang="en-GB" sz="1600"/>
-              <a:t>: instant reactivity, zero page reloads (Single Page Application), and complete decoupling from the backend services.</a:t>
+              <a:t>Maintains open WebSockets with all active users. When the Consumer broadcasts a new event, the Gateway pushes it instantly to the React app.</a:t>
+            </a:r>
+            <a:endParaRPr sz="1600"/>
+          </a:p>
+          <a:p>
+            <a:pPr indent="-330200" lvl="0" marL="457200" rtl="0" algn="l">
+              <a:spcBef>
+                <a:spcPts val="0"/>
+              </a:spcBef>
+              <a:spcAft>
+                <a:spcPts val="0"/>
+              </a:spcAft>
+              <a:buSzPts val="1600"/>
+              <a:buChar char="●"/>
+            </a:pPr>
+            <a:r>
+              <a:rPr lang="en-GB" sz="1600"/>
+              <a:t>Proxies frontend requests (like creating or deleting automation rules) to the isolated DB Manager, enforcing strict separation of concerns.</a:t>
             </a:r>
             <a:endParaRPr sz="1600"/>
           </a:p>
@@ -13588,7 +13797,7 @@
   <p:cSld>
     <p:spTree>
       <p:nvGrpSpPr>
-        <p:cNvPr id="250" name="Shape 250"/>
+        <p:cNvPr id="251" name="Shape 251"/>
         <p:cNvGrpSpPr/>
         <p:nvPr/>
       </p:nvGrpSpPr>
@@ -13602,7 +13811,7 @@
       </p:grpSpPr>
       <p:pic>
         <p:nvPicPr>
-          <p:cNvPr descr="Beautify this slide" id="251" name="Google Shape;251;p34"/>
+          <p:cNvPr descr="Beautify this slide" id="252" name="Google Shape;252;p34"/>
           <p:cNvPicPr preferRelativeResize="0"/>
           <p:nvPr/>
         </p:nvPicPr>
@@ -13641,7 +13850,7 @@
   <p:cSld>
     <p:spTree>
       <p:nvGrpSpPr>
-        <p:cNvPr id="255" name="Shape 255"/>
+        <p:cNvPr id="256" name="Shape 256"/>
         <p:cNvGrpSpPr/>
         <p:nvPr/>
       </p:nvGrpSpPr>
@@ -13655,7 +13864,7 @@
       </p:grpSpPr>
       <p:sp>
         <p:nvSpPr>
-          <p:cNvPr id="256" name="Google Shape;256;p35"/>
+          <p:cNvPr id="257" name="Google Shape;257;p35"/>
           <p:cNvSpPr txBox="1"/>
           <p:nvPr>
             <p:ph type="title"/>
@@ -13672,7 +13881,7 @@
         </p:spPr>
         <p:txBody>
           <a:bodyPr anchorCtr="0" anchor="ctr" bIns="91425" lIns="91425" spcFirstLastPara="1" rIns="91425" wrap="square" tIns="91425">
-            <a:normAutofit/>
+            <a:normAutofit fontScale="90000"/>
           </a:bodyPr>
           <a:lstStyle/>
           <a:p>
@@ -13687,7 +13896,23 @@
             </a:pPr>
             <a:r>
               <a:rPr b="1" lang="en-GB"/>
-              <a:t>Data Flow: From Sensor to Screen</a:t>
+              <a:t>MARS_OS Command Center: </a:t>
+            </a:r>
+            <a:endParaRPr b="1"/>
+          </a:p>
+          <a:p>
+            <a:pPr indent="0" lvl="0" marL="0" rtl="0" algn="l">
+              <a:spcBef>
+                <a:spcPts val="0"/>
+              </a:spcBef>
+              <a:spcAft>
+                <a:spcPts val="0"/>
+              </a:spcAft>
+              <a:buNone/>
+            </a:pPr>
+            <a:r>
+              <a:rPr b="1" lang="en-GB"/>
+              <a:t>Frontend Architecture</a:t>
             </a:r>
             <a:endParaRPr b="1"/>
           </a:p>
@@ -13695,7 +13920,7 @@
       </p:sp>
       <p:sp>
         <p:nvSpPr>
-          <p:cNvPr id="257" name="Google Shape;257;p35"/>
+          <p:cNvPr id="258" name="Google Shape;258;p35"/>
           <p:cNvSpPr txBox="1"/>
           <p:nvPr>
             <p:ph idx="1" type="body"/>
@@ -13743,11 +13968,11 @@
             </a:pPr>
             <a:r>
               <a:rPr b="1" lang="en-GB" sz="1600"/>
-              <a:t>No Polling, Just Push:</a:t>
+              <a:t>Objective</a:t>
             </a:r>
             <a:r>
               <a:rPr lang="en-GB" sz="1600"/>
-              <a:t> leveraging WebSockets for a persistent, bidirectional connection with the API Gateway.</a:t>
+              <a:t>: develop an operational Head-Up Display (HUD) for real-time monitoring and control of the Mars base.</a:t>
             </a:r>
             <a:endParaRPr sz="1600"/>
           </a:p>
@@ -13764,32 +13989,11 @@
             </a:pPr>
             <a:r>
               <a:rPr b="1" lang="en-GB" sz="1600"/>
-              <a:t>Zero Latency:</a:t>
+              <a:t>Key Requirements</a:t>
             </a:r>
             <a:r>
               <a:rPr lang="en-GB" sz="1600"/>
-              <a:t> Kafka-processed events are pushed instantly to the React client.</a:t>
-            </a:r>
-            <a:endParaRPr sz="1600"/>
-          </a:p>
-          <a:p>
-            <a:pPr indent="-330200" lvl="0" marL="457200" rtl="0" algn="l">
-              <a:spcBef>
-                <a:spcPts val="0"/>
-              </a:spcBef>
-              <a:spcAft>
-                <a:spcPts val="0"/>
-              </a:spcAft>
-              <a:buSzPts val="1600"/>
-              <a:buChar char="●"/>
-            </a:pPr>
-            <a:r>
-              <a:rPr b="1" lang="en-GB" sz="1600"/>
-              <a:t>Dynamic Data Mapping:</a:t>
-            </a:r>
-            <a:r>
-              <a:rPr lang="en-GB" sz="1600"/>
-              <a:t> Runtime formatting function to translate raw sensor paths into clean UI labels, preserving original data integrity for the backend.</a:t>
+              <a:t>: instant reactivity, zero page reloads (Single Page Application), and complete decoupling from the backend services.</a:t>
             </a:r>
             <a:endParaRPr sz="1600"/>
           </a:p>
@@ -13808,7 +14012,7 @@
   <p:cSld>
     <p:spTree>
       <p:nvGrpSpPr>
-        <p:cNvPr id="261" name="Shape 261"/>
+        <p:cNvPr id="262" name="Shape 262"/>
         <p:cNvGrpSpPr/>
         <p:nvPr/>
       </p:nvGrpSpPr>
@@ -13822,7 +14026,7 @@
       </p:grpSpPr>
       <p:pic>
         <p:nvPicPr>
-          <p:cNvPr descr="Beautify this slide" id="262" name="Google Shape;262;p36"/>
+          <p:cNvPr descr="Beautify this slide" id="263" name="Google Shape;263;p36"/>
           <p:cNvPicPr preferRelativeResize="0"/>
           <p:nvPr/>
         </p:nvPicPr>
@@ -13861,7 +14065,7 @@
   <p:cSld>
     <p:spTree>
       <p:nvGrpSpPr>
-        <p:cNvPr id="266" name="Shape 266"/>
+        <p:cNvPr id="267" name="Shape 267"/>
         <p:cNvGrpSpPr/>
         <p:nvPr/>
       </p:nvGrpSpPr>
@@ -13875,7 +14079,7 @@
       </p:grpSpPr>
       <p:sp>
         <p:nvSpPr>
-          <p:cNvPr id="267" name="Google Shape;267;p37"/>
+          <p:cNvPr id="268" name="Google Shape;268;p37"/>
           <p:cNvSpPr txBox="1"/>
           <p:nvPr>
             <p:ph type="title"/>
@@ -13907,7 +14111,7 @@
             </a:pPr>
             <a:r>
               <a:rPr b="1" lang="en-GB"/>
-              <a:t>Optimizing User Experience (UX)</a:t>
+              <a:t>Data Flow: From Sensor to Screen</a:t>
             </a:r>
             <a:endParaRPr b="1"/>
           </a:p>
@@ -13915,7 +14119,7 @@
       </p:sp>
       <p:sp>
         <p:nvSpPr>
-          <p:cNvPr id="268" name="Google Shape;268;p37"/>
+          <p:cNvPr id="269" name="Google Shape;269;p37"/>
           <p:cNvSpPr txBox="1"/>
           <p:nvPr>
             <p:ph idx="1" type="body"/>
@@ -13963,11 +14167,11 @@
             </a:pPr>
             <a:r>
               <a:rPr b="1" lang="en-GB" sz="1600"/>
-              <a:t>Live Historical Charting (Recharts):</a:t>
+              <a:t>No Polling, Just Push:</a:t>
             </a:r>
             <a:r>
               <a:rPr lang="en-GB" sz="1600"/>
-              <a:t> sliding time window (last 20 samples) for Greenhouse Temperature, updating dynamically on every WebSocket event.</a:t>
+              <a:t> leveraging WebSockets for a persistent, bidirectional connection with the API Gateway.</a:t>
             </a:r>
             <a:endParaRPr sz="1600"/>
           </a:p>
@@ -13984,16 +14188,16 @@
             </a:pPr>
             <a:r>
               <a:rPr b="1" lang="en-GB" sz="1600"/>
-              <a:t>Optimistic UI for Actuators:</a:t>
+              <a:t>Zero Latency:</a:t>
             </a:r>
             <a:r>
               <a:rPr lang="en-GB" sz="1600"/>
-              <a:t> immediate visual feedback upon operator click.</a:t>
+              <a:t> Kafka-processed events are pushed instantly to the React client.</a:t>
             </a:r>
             <a:endParaRPr sz="1600"/>
           </a:p>
           <a:p>
-            <a:pPr indent="-330200" lvl="1" marL="914400" rtl="0" algn="l">
+            <a:pPr indent="-330200" lvl="0" marL="457200" rtl="0" algn="l">
               <a:spcBef>
                 <a:spcPts val="0"/>
               </a:spcBef>
@@ -14001,28 +14205,15 @@
                 <a:spcPts val="0"/>
               </a:spcAft>
               <a:buSzPts val="1600"/>
-              <a:buChar char="○"/>
+              <a:buChar char="●"/>
             </a:pPr>
             <a:r>
+              <a:rPr b="1" lang="en-GB" sz="1600"/>
+              <a:t>Dynamic Data Mapping:</a:t>
+            </a:r>
+            <a:r>
               <a:rPr lang="en-GB" sz="1600"/>
-              <a:t>Asynchronous REST API (POST) execution in the background.</a:t>
-            </a:r>
-            <a:endParaRPr sz="1600"/>
-          </a:p>
-          <a:p>
-            <a:pPr indent="-330200" lvl="1" marL="914400" rtl="0" algn="l">
-              <a:spcBef>
-                <a:spcPts val="0"/>
-              </a:spcBef>
-              <a:spcAft>
-                <a:spcPts val="0"/>
-              </a:spcAft>
-              <a:buSzPts val="1600"/>
-              <a:buChar char="○"/>
-            </a:pPr>
-            <a:r>
-              <a:rPr lang="en-GB" sz="1600"/>
-              <a:t>Automatic Rollback mechanism to revert UI state in case of network or server failure.</a:t>
+              <a:t> Runtime formatting function to translate raw sensor paths into clean UI labels, preserving original data integrity for the backend.</a:t>
             </a:r>
             <a:endParaRPr sz="1600"/>
           </a:p>
@@ -14041,7 +14232,7 @@
   <p:cSld>
     <p:spTree>
       <p:nvGrpSpPr>
-        <p:cNvPr id="272" name="Shape 272"/>
+        <p:cNvPr id="273" name="Shape 273"/>
         <p:cNvGrpSpPr/>
         <p:nvPr/>
       </p:nvGrpSpPr>
@@ -14055,7 +14246,7 @@
       </p:grpSpPr>
       <p:pic>
         <p:nvPicPr>
-          <p:cNvPr descr="Beautify this slide" id="273" name="Google Shape;273;p38"/>
+          <p:cNvPr descr="Beautify this slide" id="274" name="Google Shape;274;p38"/>
           <p:cNvPicPr preferRelativeResize="0"/>
           <p:nvPr/>
         </p:nvPicPr>
@@ -14094,7 +14285,7 @@
   <p:cSld>
     <p:spTree>
       <p:nvGrpSpPr>
-        <p:cNvPr id="277" name="Shape 277"/>
+        <p:cNvPr id="278" name="Shape 278"/>
         <p:cNvGrpSpPr/>
         <p:nvPr/>
       </p:nvGrpSpPr>
@@ -14108,7 +14299,7 @@
       </p:grpSpPr>
       <p:sp>
         <p:nvSpPr>
-          <p:cNvPr id="278" name="Google Shape;278;p39"/>
+          <p:cNvPr id="279" name="Google Shape;279;p39"/>
           <p:cNvSpPr txBox="1"/>
           <p:nvPr>
             <p:ph type="title"/>
@@ -14140,7 +14331,7 @@
             </a:pPr>
             <a:r>
               <a:rPr b="1" lang="en-GB"/>
-              <a:t>Dynamic Automation Engine</a:t>
+              <a:t>Optimizing User Experience (UX)</a:t>
             </a:r>
             <a:endParaRPr b="1"/>
           </a:p>
@@ -14148,7 +14339,7 @@
       </p:sp>
       <p:sp>
         <p:nvSpPr>
-          <p:cNvPr id="279" name="Google Shape;279;p39"/>
+          <p:cNvPr id="280" name="Google Shape;280;p39"/>
           <p:cNvSpPr txBox="1"/>
           <p:nvPr>
             <p:ph idx="1" type="body"/>
@@ -14196,11 +14387,11 @@
             </a:pPr>
             <a:r>
               <a:rPr b="1" lang="en-GB" sz="1600"/>
-              <a:t>Dynamic UI Components:</a:t>
+              <a:t>Live Historical Charting (Recharts):</a:t>
             </a:r>
             <a:r>
               <a:rPr lang="en-GB" sz="1600"/>
-              <a:t> IF/THEN dropdowns automatically populate by extracting keys from the live application state.</a:t>
+              <a:t> sliding time window (last 20 samples) for Greenhouse Temperature, updating dynamically on every WebSocket event.</a:t>
             </a:r>
             <a:endParaRPr sz="1600"/>
           </a:p>
@@ -14217,16 +14408,16 @@
             </a:pPr>
             <a:r>
               <a:rPr b="1" lang="en-GB" sz="1600"/>
-              <a:t>Future-Proof Scalability:</a:t>
+              <a:t>Optimistic UI for Actuators:</a:t>
             </a:r>
             <a:r>
               <a:rPr lang="en-GB" sz="1600"/>
-              <a:t> New backend sensors are instantly integrated into the rules menu without any frontend code changes.</a:t>
+              <a:t> immediate visual feedback upon operator click.</a:t>
             </a:r>
             <a:endParaRPr sz="1600"/>
           </a:p>
           <a:p>
-            <a:pPr indent="-330200" lvl="0" marL="457200" rtl="0" algn="l">
+            <a:pPr indent="-330200" lvl="1" marL="914400" rtl="0" algn="l">
               <a:spcBef>
                 <a:spcPts val="0"/>
               </a:spcBef>
@@ -14234,15 +14425,28 @@
                 <a:spcPts val="0"/>
               </a:spcAft>
               <a:buSzPts val="1600"/>
-              <a:buChar char="●"/>
+              <a:buChar char="○"/>
             </a:pPr>
             <a:r>
-              <a:rPr b="1" lang="en-GB" sz="1600"/>
-              <a:t>Full API Integration:</a:t>
-            </a:r>
-            <a:r>
               <a:rPr lang="en-GB" sz="1600"/>
-              <a:t> Complete rule lifecycle management (Initial Fetch, POST for creation, DELETE for removal) fully synced with the PostgreSQL database.</a:t>
+              <a:t>Asynchronous REST API (POST) execution in the background.</a:t>
+            </a:r>
+            <a:endParaRPr sz="1600"/>
+          </a:p>
+          <a:p>
+            <a:pPr indent="-330200" lvl="1" marL="914400" rtl="0" algn="l">
+              <a:spcBef>
+                <a:spcPts val="0"/>
+              </a:spcBef>
+              <a:spcAft>
+                <a:spcPts val="0"/>
+              </a:spcAft>
+              <a:buSzPts val="1600"/>
+              <a:buChar char="○"/>
+            </a:pPr>
+            <a:r>
+              <a:rPr lang="en-GB" sz="1600"/>
+              <a:t>Automatic Rollback mechanism to revert UI state in case of network or server failure.</a:t>
             </a:r>
             <a:endParaRPr sz="1600"/>
           </a:p>
@@ -14261,7 +14465,7 @@
   <p:cSld>
     <p:spTree>
       <p:nvGrpSpPr>
-        <p:cNvPr id="283" name="Shape 283"/>
+        <p:cNvPr id="284" name="Shape 284"/>
         <p:cNvGrpSpPr/>
         <p:nvPr/>
       </p:nvGrpSpPr>
@@ -14275,7 +14479,7 @@
       </p:grpSpPr>
       <p:pic>
         <p:nvPicPr>
-          <p:cNvPr descr="Beautify this slide" id="284" name="Google Shape;284;p40"/>
+          <p:cNvPr descr="Beautify this slide" id="285" name="Google Shape;285;p40"/>
           <p:cNvPicPr preferRelativeResize="0"/>
           <p:nvPr/>
         </p:nvPicPr>
@@ -14314,7 +14518,7 @@
   <p:cSld>
     <p:spTree>
       <p:nvGrpSpPr>
-        <p:cNvPr id="288" name="Shape 288"/>
+        <p:cNvPr id="289" name="Shape 289"/>
         <p:cNvGrpSpPr/>
         <p:nvPr/>
       </p:nvGrpSpPr>
@@ -14328,7 +14532,7 @@
       </p:grpSpPr>
       <p:sp>
         <p:nvSpPr>
-          <p:cNvPr id="289" name="Google Shape;289;p41"/>
+          <p:cNvPr id="290" name="Google Shape;290;p41"/>
           <p:cNvSpPr txBox="1"/>
           <p:nvPr>
             <p:ph type="title"/>
@@ -14360,7 +14564,7 @@
             </a:pPr>
             <a:r>
               <a:rPr b="1" lang="en-GB"/>
-              <a:t>Tech Stack &amp; Deployment</a:t>
+              <a:t>Dynamic Automation Engine</a:t>
             </a:r>
             <a:endParaRPr b="1"/>
           </a:p>
@@ -14368,7 +14572,7 @@
       </p:sp>
       <p:sp>
         <p:nvSpPr>
-          <p:cNvPr id="290" name="Google Shape;290;p41"/>
+          <p:cNvPr id="291" name="Google Shape;291;p41"/>
           <p:cNvSpPr txBox="1"/>
           <p:nvPr>
             <p:ph idx="1" type="body"/>
@@ -14416,11 +14620,11 @@
             </a:pPr>
             <a:r>
               <a:rPr b="1" lang="en-GB" sz="1600"/>
-              <a:t>Core:</a:t>
+              <a:t>Dynamic UI Components:</a:t>
             </a:r>
             <a:r>
               <a:rPr lang="en-GB" sz="1600"/>
-              <a:t> React.js + Vite (for ultra-fast builds and hot-reloading).</a:t>
+              <a:t> IF/THEN dropdowns automatically populate by extracting keys from the live application state.</a:t>
             </a:r>
             <a:endParaRPr sz="1600"/>
           </a:p>
@@ -14437,11 +14641,11 @@
             </a:pPr>
             <a:r>
               <a:rPr b="1" lang="en-GB" sz="1600"/>
-              <a:t>Styling:</a:t>
+              <a:t>Future-Proof Scalability:</a:t>
             </a:r>
             <a:r>
               <a:rPr lang="en-GB" sz="1600"/>
-              <a:t> TailwindCSS (Dark/Sci-Fi design system, responsive, utility-first).</a:t>
+              <a:t> New backend sensors are instantly integrated into the rules menu without any frontend code changes.</a:t>
             </a:r>
             <a:endParaRPr sz="1600"/>
           </a:p>
@@ -14458,32 +14662,11 @@
             </a:pPr>
             <a:r>
               <a:rPr b="1" lang="en-GB" sz="1600"/>
-              <a:t>Deployment:</a:t>
+              <a:t>Full API Integration:</a:t>
             </a:r>
             <a:r>
               <a:rPr lang="en-GB" sz="1600"/>
-              <a:t> Containerized via Docker.</a:t>
-            </a:r>
-            <a:endParaRPr sz="1600"/>
-          </a:p>
-          <a:p>
-            <a:pPr indent="-330200" lvl="0" marL="457200" rtl="0" algn="l">
-              <a:spcBef>
-                <a:spcPts val="0"/>
-              </a:spcBef>
-              <a:spcAft>
-                <a:spcPts val="0"/>
-              </a:spcAft>
-              <a:buSzPts val="1600"/>
-              <a:buChar char="●"/>
-            </a:pPr>
-            <a:r>
-              <a:rPr b="1" lang="en-GB" sz="1600"/>
-              <a:t>Configuration:</a:t>
-            </a:r>
-            <a:r>
-              <a:rPr lang="en-GB" sz="1600"/>
-              <a:t> Environment variables (VITE_API_URL) injected via docker-compose.yml for "Plug &amp; Play" microservices integration.</a:t>
+              <a:t> Complete rule lifecycle management (Initial Fetch, POST for creation, DELETE for removal) fully synced with the PostgreSQL database.</a:t>
             </a:r>
             <a:endParaRPr sz="1600"/>
           </a:p>
@@ -14514,18 +14697,44 @@
           <a:chExt cx="0" cy="0"/>
         </a:xfrm>
       </p:grpSpPr>
+      <p:pic>
+        <p:nvPicPr>
+          <p:cNvPr id="146" name="Google Shape;146;p15"/>
+          <p:cNvPicPr preferRelativeResize="0"/>
+          <p:nvPr/>
+        </p:nvPicPr>
+        <p:blipFill>
+          <a:blip r:embed="rId3">
+            <a:alphaModFix/>
+          </a:blip>
+          <a:stretch>
+            <a:fillRect/>
+          </a:stretch>
+        </p:blipFill>
+        <p:spPr>
+          <a:xfrm>
+            <a:off x="3144975" y="152400"/>
+            <a:ext cx="3420356" cy="4838700"/>
+          </a:xfrm>
+          <a:prstGeom prst="rect">
+            <a:avLst/>
+          </a:prstGeom>
+          <a:noFill/>
+          <a:ln>
+            <a:noFill/>
+          </a:ln>
+        </p:spPr>
+      </p:pic>
       <p:sp>
         <p:nvSpPr>
-          <p:cNvPr id="146" name="Google Shape;146;p15"/>
+          <p:cNvPr id="147" name="Google Shape;147;p15"/>
           <p:cNvSpPr txBox="1"/>
-          <p:nvPr>
-            <p:ph type="ctrTitle"/>
-          </p:nvPr>
+          <p:nvPr/>
         </p:nvSpPr>
         <p:spPr>
           <a:xfrm>
-            <a:off x="32100" y="37925"/>
-            <a:ext cx="8574000" cy="639300"/>
+            <a:off x="550050" y="1354025"/>
+            <a:ext cx="2097600" cy="2618400"/>
           </a:xfrm>
           <a:prstGeom prst="rect">
             <a:avLst/>
@@ -14537,14 +14746,11 @@
         </p:spPr>
         <p:txBody>
           <a:bodyPr anchorCtr="0" anchor="t" bIns="91425" lIns="91425" spcFirstLastPara="1" rIns="91425" wrap="square" tIns="91425">
-            <a:normAutofit fontScale="90000"/>
+            <a:noAutofit/>
           </a:bodyPr>
           <a:lstStyle/>
           <a:p>
             <a:pPr indent="0" lvl="0" marL="0" rtl="0" algn="l">
-              <a:lnSpc>
-                <a:spcPct val="115000"/>
-              </a:lnSpc>
               <a:spcBef>
                 <a:spcPts val="0"/>
               </a:spcBef>
@@ -14554,44 +14760,202 @@
               <a:buNone/>
             </a:pPr>
             <a:r>
-              <a:rPr lang="en-GB">
-                <a:latin typeface="Calibri"/>
-                <a:ea typeface="Calibri"/>
-                <a:cs typeface="Calibri"/>
-                <a:sym typeface="Calibri"/>
-              </a:rPr>
-              <a:t>Mars Ingestion Service : Steaming &amp; Polling</a:t>
-            </a:r>
-            <a:endParaRPr>
-              <a:latin typeface="Calibri"/>
-              <a:ea typeface="Calibri"/>
-              <a:cs typeface="Calibri"/>
-              <a:sym typeface="Calibri"/>
+              <a:t/>
+            </a:r>
+            <a:endParaRPr sz="1300">
+              <a:solidFill>
+                <a:schemeClr val="lt1"/>
+              </a:solidFill>
+              <a:latin typeface="Lato"/>
+              <a:ea typeface="Lato"/>
+              <a:cs typeface="Lato"/>
+              <a:sym typeface="Lato"/>
             </a:endParaRPr>
-          </a:p>
-          <a:p>
-            <a:pPr indent="0" lvl="0" marL="0" rtl="0" algn="l">
-              <a:spcBef>
-                <a:spcPts val="0"/>
-              </a:spcBef>
-              <a:spcAft>
-                <a:spcPts val="0"/>
-              </a:spcAft>
-              <a:buNone/>
-            </a:pPr>
-            <a:r>
-              <a:t/>
-            </a:r>
-            <a:endParaRPr/>
           </a:p>
         </p:txBody>
       </p:sp>
       <p:sp>
         <p:nvSpPr>
-          <p:cNvPr id="147" name="Google Shape;147;p15"/>
+          <p:cNvPr id="148" name="Google Shape;148;p15"/>
+          <p:cNvSpPr txBox="1"/>
+          <p:nvPr/>
+        </p:nvSpPr>
+        <p:spPr>
+          <a:xfrm>
+            <a:off x="630200" y="1260500"/>
+            <a:ext cx="2097600" cy="2190900"/>
+          </a:xfrm>
+          <a:prstGeom prst="rect">
+            <a:avLst/>
+          </a:prstGeom>
+          <a:noFill/>
+          <a:ln>
+            <a:noFill/>
+          </a:ln>
+        </p:spPr>
+        <p:txBody>
+          <a:bodyPr anchorCtr="0" anchor="t" bIns="91425" lIns="91425" spcFirstLastPara="1" rIns="91425" wrap="square" tIns="91425">
+            <a:noAutofit/>
+          </a:bodyPr>
+          <a:lstStyle/>
+          <a:p>
+            <a:pPr indent="0" lvl="0" marL="0" rtl="0" algn="l">
+              <a:spcBef>
+                <a:spcPts val="0"/>
+              </a:spcBef>
+              <a:spcAft>
+                <a:spcPts val="0"/>
+              </a:spcAft>
+              <a:buNone/>
+            </a:pPr>
+            <a:r>
+              <a:rPr lang="en-GB" sz="1300">
+                <a:solidFill>
+                  <a:schemeClr val="lt1"/>
+                </a:solidFill>
+                <a:latin typeface="Lato"/>
+                <a:ea typeface="Lato"/>
+                <a:cs typeface="Lato"/>
+                <a:sym typeface="Lato"/>
+              </a:rPr>
+              <a:t>system architecture diagram</a:t>
+            </a:r>
+            <a:endParaRPr sz="1300">
+              <a:solidFill>
+                <a:schemeClr val="lt1"/>
+              </a:solidFill>
+              <a:latin typeface="Lato"/>
+              <a:ea typeface="Lato"/>
+              <a:cs typeface="Lato"/>
+              <a:sym typeface="Lato"/>
+            </a:endParaRPr>
+          </a:p>
+        </p:txBody>
+      </p:sp>
+    </p:spTree>
+  </p:cSld>
+  <p:clrMapOvr>
+    <a:masterClrMapping/>
+  </p:clrMapOvr>
+</p:sld>
+</file>
+
+<file path=ppt/slides/slide30.xml><?xml version="1.0" encoding="utf-8"?>
+<p:sld xmlns:a="http://schemas.openxmlformats.org/drawingml/2006/main" xmlns:r="http://schemas.openxmlformats.org/officeDocument/2006/relationships" xmlns:mc="http://schemas.openxmlformats.org/markup-compatibility/2006" xmlns:mv="urn:schemas-microsoft-com:mac:vml" xmlns:p="http://schemas.openxmlformats.org/presentationml/2006/main" xmlns:c="http://schemas.openxmlformats.org/drawingml/2006/chart" xmlns:dgm="http://schemas.openxmlformats.org/drawingml/2006/diagram" xmlns:o="urn:schemas-microsoft-com:office:office" xmlns:v="urn:schemas-microsoft-com:vml" xmlns:pvml="urn:schemas-microsoft-com:office:powerpoint" xmlns:com="http://schemas.openxmlformats.org/drawingml/2006/compatibility" xmlns:p14="http://schemas.microsoft.com/office/powerpoint/2010/main" xmlns:p15="http://schemas.microsoft.com/office/powerpoint/2012/main" xmlns:ahyp="http://schemas.microsoft.com/office/drawing/2018/hyperlinkcolor">
+  <p:cSld>
+    <p:spTree>
+      <p:nvGrpSpPr>
+        <p:cNvPr id="295" name="Shape 295"/>
+        <p:cNvGrpSpPr/>
+        <p:nvPr/>
+      </p:nvGrpSpPr>
+      <p:grpSpPr>
+        <a:xfrm>
+          <a:off x="0" y="0"/>
+          <a:ext cx="0" cy="0"/>
+          <a:chOff x="0" y="0"/>
+          <a:chExt cx="0" cy="0"/>
+        </a:xfrm>
+      </p:grpSpPr>
+      <p:pic>
+        <p:nvPicPr>
+          <p:cNvPr descr="Beautify this slide" id="296" name="Google Shape;296;p42"/>
+          <p:cNvPicPr preferRelativeResize="0"/>
+          <p:nvPr/>
+        </p:nvPicPr>
+        <p:blipFill>
+          <a:blip r:embed="rId3">
+            <a:alphaModFix/>
+          </a:blip>
+          <a:stretch>
+            <a:fillRect/>
+          </a:stretch>
+        </p:blipFill>
+        <p:spPr>
+          <a:xfrm>
+            <a:off x="-35700" y="0"/>
+            <a:ext cx="9210675" cy="5143500"/>
+          </a:xfrm>
+          <a:prstGeom prst="rect">
+            <a:avLst/>
+          </a:prstGeom>
+          <a:noFill/>
+          <a:ln>
+            <a:noFill/>
+          </a:ln>
+        </p:spPr>
+      </p:pic>
+    </p:spTree>
+  </p:cSld>
+  <p:clrMapOvr>
+    <a:masterClrMapping/>
+  </p:clrMapOvr>
+</p:sld>
+</file>
+
+<file path=ppt/slides/slide31.xml><?xml version="1.0" encoding="utf-8"?>
+<p:sld xmlns:a="http://schemas.openxmlformats.org/drawingml/2006/main" xmlns:r="http://schemas.openxmlformats.org/officeDocument/2006/relationships" xmlns:mc="http://schemas.openxmlformats.org/markup-compatibility/2006" xmlns:mv="urn:schemas-microsoft-com:mac:vml" xmlns:p="http://schemas.openxmlformats.org/presentationml/2006/main" xmlns:c="http://schemas.openxmlformats.org/drawingml/2006/chart" xmlns:dgm="http://schemas.openxmlformats.org/drawingml/2006/diagram" xmlns:o="urn:schemas-microsoft-com:office:office" xmlns:v="urn:schemas-microsoft-com:vml" xmlns:pvml="urn:schemas-microsoft-com:office:powerpoint" xmlns:com="http://schemas.openxmlformats.org/drawingml/2006/compatibility" xmlns:p14="http://schemas.microsoft.com/office/powerpoint/2010/main" xmlns:p15="http://schemas.microsoft.com/office/powerpoint/2012/main" xmlns:ahyp="http://schemas.microsoft.com/office/drawing/2018/hyperlinkcolor" show="0">
+  <p:cSld>
+    <p:spTree>
+      <p:nvGrpSpPr>
+        <p:cNvPr id="300" name="Shape 300"/>
+        <p:cNvGrpSpPr/>
+        <p:nvPr/>
+      </p:nvGrpSpPr>
+      <p:grpSpPr>
+        <a:xfrm>
+          <a:off x="0" y="0"/>
+          <a:ext cx="0" cy="0"/>
+          <a:chOff x="0" y="0"/>
+          <a:chExt cx="0" cy="0"/>
+        </a:xfrm>
+      </p:grpSpPr>
+      <p:sp>
+        <p:nvSpPr>
+          <p:cNvPr id="301" name="Google Shape;301;p43"/>
           <p:cNvSpPr txBox="1"/>
           <p:nvPr>
-            <p:ph idx="4294967295" type="body"/>
+            <p:ph type="title"/>
+          </p:nvPr>
+        </p:nvSpPr>
+        <p:spPr>
+          <a:xfrm>
+            <a:off x="1297500" y="393750"/>
+            <a:ext cx="7308600" cy="914100"/>
+          </a:xfrm>
+          <a:prstGeom prst="rect">
+            <a:avLst/>
+          </a:prstGeom>
+        </p:spPr>
+        <p:txBody>
+          <a:bodyPr anchorCtr="0" anchor="ctr" bIns="91425" lIns="91425" spcFirstLastPara="1" rIns="91425" wrap="square" tIns="91425">
+            <a:normAutofit/>
+          </a:bodyPr>
+          <a:lstStyle/>
+          <a:p>
+            <a:pPr indent="0" lvl="0" marL="0" rtl="0" algn="l">
+              <a:spcBef>
+                <a:spcPts val="0"/>
+              </a:spcBef>
+              <a:spcAft>
+                <a:spcPts val="0"/>
+              </a:spcAft>
+              <a:buNone/>
+            </a:pPr>
+            <a:r>
+              <a:rPr b="1" lang="en-GB"/>
+              <a:t>Tech Stack &amp; Deployment</a:t>
+            </a:r>
+            <a:endParaRPr b="1"/>
+          </a:p>
+        </p:txBody>
+      </p:sp>
+      <p:sp>
+        <p:nvSpPr>
+          <p:cNvPr id="302" name="Google Shape;302;p43"/>
+          <p:cNvSpPr txBox="1"/>
+          <p:nvPr>
+            <p:ph idx="1" type="body"/>
           </p:nvPr>
         </p:nvSpPr>
         <p:spPr>
@@ -14619,403 +14983,35 @@
               <a:buNone/>
             </a:pPr>
             <a:r>
-              <a:rPr b="1" lang="en-GB" sz="1600"/>
-              <a:t>Role</a:t>
-            </a:r>
-            <a:r>
-              <a:rPr lang="en-GB" sz="1600"/>
-              <a:t>: </a:t>
-            </a:r>
-            <a:r>
-              <a:rPr lang="en-GB" sz="1000">
-                <a:solidFill>
-                  <a:srgbClr val="DFE1E5"/>
-                </a:solidFill>
-                <a:latin typeface="Arial"/>
-                <a:ea typeface="Arial"/>
-                <a:cs typeface="Arial"/>
-                <a:sym typeface="Arial"/>
-              </a:rPr>
-              <a:t>Primary bridge between Mars IoT sensors and downstream processing</a:t>
-            </a:r>
-            <a:br>
-              <a:rPr lang="en-GB" sz="1600"/>
-            </a:br>
-            <a:r>
-              <a:rPr b="1" lang="en-GB" sz="1600"/>
-              <a:t>Tech</a:t>
-            </a:r>
-            <a:r>
-              <a:rPr lang="en-GB" sz="1600"/>
-              <a:t>: </a:t>
-            </a:r>
-            <a:r>
-              <a:rPr lang="en-GB" sz="1000">
-                <a:solidFill>
-                  <a:srgbClr val="DFE1E5"/>
-                </a:solidFill>
-                <a:latin typeface="Arial"/>
-                <a:ea typeface="Arial"/>
-                <a:cs typeface="Arial"/>
-                <a:sym typeface="Arial"/>
-              </a:rPr>
-              <a:t>Spring Boot , Java HTTP Client , Jackson JSON</a:t>
+              <a:t/>
             </a:r>
             <a:endParaRPr sz="1600"/>
           </a:p>
           <a:p>
-            <a:pPr indent="-298450" lvl="0" marL="457200" rtl="0" algn="l">
-              <a:lnSpc>
-                <a:spcPct val="150000"/>
-              </a:lnSpc>
+            <a:pPr indent="-330200" lvl="0" marL="457200" rtl="0" algn="l">
               <a:spcBef>
                 <a:spcPts val="1200"/>
               </a:spcBef>
               <a:spcAft>
                 <a:spcPts val="0"/>
               </a:spcAft>
-              <a:buClr>
-                <a:srgbClr val="DFE1E5"/>
-              </a:buClr>
-              <a:buSzPts val="1100"/>
-              <a:buFont typeface="Arial"/>
+              <a:buSzPts val="1600"/>
               <a:buChar char="●"/>
             </a:pPr>
             <a:r>
-              <a:rPr lang="en-GB" sz="1100">
-                <a:solidFill>
-                  <a:srgbClr val="DFE1E5"/>
-                </a:solidFill>
-                <a:latin typeface="Arial"/>
-                <a:ea typeface="Arial"/>
-                <a:cs typeface="Arial"/>
-                <a:sym typeface="Arial"/>
-              </a:rPr>
-              <a:t>MarsScheduledIngestionService (API Polling):</a:t>
-            </a:r>
-            <a:endParaRPr sz="1100">
-              <a:solidFill>
-                <a:srgbClr val="DFE1E5"/>
-              </a:solidFill>
-              <a:latin typeface="Arial"/>
-              <a:ea typeface="Arial"/>
-              <a:cs typeface="Arial"/>
-              <a:sym typeface="Arial"/>
-            </a:endParaRPr>
-          </a:p>
-          <a:p>
-            <a:pPr indent="-298450" lvl="1" marL="914400" rtl="0" algn="l">
-              <a:lnSpc>
-                <a:spcPct val="150000"/>
-              </a:lnSpc>
-              <a:spcBef>
-                <a:spcPts val="0"/>
-              </a:spcBef>
-              <a:spcAft>
-                <a:spcPts val="0"/>
-              </a:spcAft>
-              <a:buClr>
-                <a:srgbClr val="DFE1E5"/>
-              </a:buClr>
-              <a:buSzPts val="1100"/>
-              <a:buFont typeface="Arial"/>
-              <a:buChar char="○"/>
-            </a:pPr>
-            <a:r>
-              <a:rPr lang="en-GB">
-                <a:solidFill>
-                  <a:srgbClr val="DFE1E5"/>
-                </a:solidFill>
-                <a:latin typeface="Arial"/>
-                <a:ea typeface="Arial"/>
-                <a:cs typeface="Arial"/>
-                <a:sym typeface="Arial"/>
-              </a:rPr>
-              <a:t>@Scheduled HTTP polling every 5 seconds</a:t>
-            </a:r>
-            <a:endParaRPr>
-              <a:solidFill>
-                <a:srgbClr val="DFE1E5"/>
-              </a:solidFill>
-              <a:latin typeface="Arial"/>
-              <a:ea typeface="Arial"/>
-              <a:cs typeface="Arial"/>
-              <a:sym typeface="Arial"/>
-            </a:endParaRPr>
-          </a:p>
-          <a:p>
-            <a:pPr indent="-298450" lvl="1" marL="914400" rtl="0" algn="l">
-              <a:lnSpc>
-                <a:spcPct val="150000"/>
-              </a:lnSpc>
-              <a:spcBef>
-                <a:spcPts val="0"/>
-              </a:spcBef>
-              <a:spcAft>
-                <a:spcPts val="0"/>
-              </a:spcAft>
-              <a:buClr>
-                <a:srgbClr val="DFE1E5"/>
-              </a:buClr>
-              <a:buSzPts val="1100"/>
-              <a:buFont typeface="Arial"/>
-              <a:buChar char="○"/>
-            </a:pPr>
-            <a:r>
-              <a:rPr lang="en-GB">
-                <a:solidFill>
-                  <a:srgbClr val="DFE1E5"/>
-                </a:solidFill>
-                <a:latin typeface="Arial"/>
-                <a:ea typeface="Arial"/>
-                <a:cs typeface="Arial"/>
-                <a:sym typeface="Arial"/>
-              </a:rPr>
-              <a:t>8 IoT sensors (Temperature, Humidity, CO2, pH, Water Level, Pressure, Air Quality)</a:t>
-            </a:r>
-            <a:endParaRPr>
-              <a:solidFill>
-                <a:srgbClr val="DFE1E5"/>
-              </a:solidFill>
-              <a:latin typeface="Arial"/>
-              <a:ea typeface="Arial"/>
-              <a:cs typeface="Arial"/>
-              <a:sym typeface="Arial"/>
-            </a:endParaRPr>
-          </a:p>
-          <a:p>
-            <a:pPr indent="-298450" lvl="1" marL="914400" rtl="0" algn="l">
-              <a:lnSpc>
-                <a:spcPct val="150000"/>
-              </a:lnSpc>
-              <a:spcBef>
-                <a:spcPts val="0"/>
-              </a:spcBef>
-              <a:spcAft>
-                <a:spcPts val="0"/>
-              </a:spcAft>
-              <a:buClr>
-                <a:srgbClr val="DFE1E5"/>
-              </a:buClr>
-              <a:buSzPts val="1100"/>
-              <a:buFont typeface="Arial"/>
-              <a:buChar char="○"/>
-            </a:pPr>
-            <a:r>
-              <a:rPr lang="en-GB" sz="1000">
-                <a:solidFill>
-                  <a:srgbClr val="DFE1E5"/>
-                </a:solidFill>
-                <a:highlight>
-                  <a:srgbClr val="2B2D30"/>
-                </a:highlight>
-                <a:latin typeface="Arial"/>
-                <a:ea typeface="Arial"/>
-                <a:cs typeface="Arial"/>
-                <a:sym typeface="Arial"/>
-              </a:rPr>
-              <a:t>Synchronous health checks → sensor polling → JSON mapping → Kafka publish</a:t>
-            </a:r>
-            <a:endParaRPr>
-              <a:solidFill>
-                <a:srgbClr val="DFE1E5"/>
-              </a:solidFill>
-              <a:latin typeface="Arial"/>
-              <a:ea typeface="Arial"/>
-              <a:cs typeface="Arial"/>
-              <a:sym typeface="Arial"/>
-            </a:endParaRPr>
-          </a:p>
-          <a:p>
-            <a:pPr indent="-298450" lvl="0" marL="457200" rtl="0" algn="l">
-              <a:lnSpc>
-                <a:spcPct val="150000"/>
-              </a:lnSpc>
-              <a:spcBef>
-                <a:spcPts val="0"/>
-              </a:spcBef>
-              <a:spcAft>
-                <a:spcPts val="0"/>
-              </a:spcAft>
-              <a:buClr>
-                <a:srgbClr val="DFE1E5"/>
-              </a:buClr>
-              <a:buSzPts val="1100"/>
-              <a:buFont typeface="Arial"/>
-              <a:buChar char="●"/>
-            </a:pPr>
-            <a:r>
-              <a:rPr lang="en-GB" sz="1100">
-                <a:solidFill>
-                  <a:srgbClr val="DFE1E5"/>
-                </a:solidFill>
-                <a:latin typeface="Arial"/>
-                <a:ea typeface="Arial"/>
-                <a:cs typeface="Arial"/>
-                <a:sym typeface="Arial"/>
-              </a:rPr>
-              <a:t>MarsTelemetryStreamService (Server-Sent Events Streaming):</a:t>
-            </a:r>
-            <a:endParaRPr sz="1100">
-              <a:solidFill>
-                <a:srgbClr val="DFE1E5"/>
-              </a:solidFill>
-              <a:latin typeface="Arial"/>
-              <a:ea typeface="Arial"/>
-              <a:cs typeface="Arial"/>
-              <a:sym typeface="Arial"/>
-            </a:endParaRPr>
-          </a:p>
-          <a:p>
-            <a:pPr indent="-298450" lvl="1" marL="914400" rtl="0" algn="l">
-              <a:lnSpc>
-                <a:spcPct val="150000"/>
-              </a:lnSpc>
-              <a:spcBef>
-                <a:spcPts val="0"/>
-              </a:spcBef>
-              <a:spcAft>
-                <a:spcPts val="0"/>
-              </a:spcAft>
-              <a:buClr>
-                <a:srgbClr val="DFE1E5"/>
-              </a:buClr>
-              <a:buSzPts val="1100"/>
-              <a:buFont typeface="Arial"/>
-              <a:buChar char="○"/>
-            </a:pPr>
-            <a:r>
-              <a:rPr lang="en-GB">
-                <a:solidFill>
-                  <a:srgbClr val="DFE1E5"/>
-                </a:solidFill>
-                <a:latin typeface="Arial"/>
-                <a:ea typeface="Arial"/>
-                <a:cs typeface="Arial"/>
-                <a:sym typeface="Arial"/>
-              </a:rPr>
-              <a:t>Approach: Real-time SSE streaming with persistent HTTP connections</a:t>
-            </a:r>
-            <a:endParaRPr>
-              <a:solidFill>
-                <a:srgbClr val="DFE1E5"/>
-              </a:solidFill>
-              <a:latin typeface="Arial"/>
-              <a:ea typeface="Arial"/>
-              <a:cs typeface="Arial"/>
-              <a:sym typeface="Arial"/>
-            </a:endParaRPr>
-          </a:p>
-          <a:p>
-            <a:pPr indent="-298450" lvl="1" marL="914400" rtl="0" algn="l">
-              <a:lnSpc>
-                <a:spcPct val="150000"/>
-              </a:lnSpc>
-              <a:spcBef>
-                <a:spcPts val="0"/>
-              </a:spcBef>
-              <a:spcAft>
-                <a:spcPts val="0"/>
-              </a:spcAft>
-              <a:buClr>
-                <a:srgbClr val="DFE1E5"/>
-              </a:buClr>
-              <a:buSzPts val="1100"/>
-              <a:buFont typeface="Arial"/>
-              <a:buChar char="○"/>
-            </a:pPr>
-            <a:r>
-              <a:rPr lang="en-GB">
-                <a:solidFill>
-                  <a:srgbClr val="DFE1E5"/>
-                </a:solidFill>
-                <a:latin typeface="Arial"/>
-                <a:ea typeface="Arial"/>
-                <a:cs typeface="Arial"/>
-                <a:sym typeface="Arial"/>
-              </a:rPr>
-              <a:t>7 telemetry streams (Solar Array, Power Bus, Power Consumption, Radiation, Life Support, Thermal Loop, Airlock)</a:t>
-            </a:r>
-            <a:endParaRPr>
-              <a:solidFill>
-                <a:srgbClr val="DFE1E5"/>
-              </a:solidFill>
-              <a:latin typeface="Arial"/>
-              <a:ea typeface="Arial"/>
-              <a:cs typeface="Arial"/>
-              <a:sym typeface="Arial"/>
-            </a:endParaRPr>
-          </a:p>
-          <a:p>
-            <a:pPr indent="-298450" lvl="1" marL="914400" rtl="0" algn="l">
-              <a:lnSpc>
-                <a:spcPct val="150000"/>
-              </a:lnSpc>
-              <a:spcBef>
-                <a:spcPts val="0"/>
-              </a:spcBef>
-              <a:spcAft>
-                <a:spcPts val="0"/>
-              </a:spcAft>
-              <a:buClr>
-                <a:srgbClr val="DFE1E5"/>
-              </a:buClr>
-              <a:buSzPts val="1100"/>
-              <a:buFont typeface="Arial"/>
-              <a:buChar char="○"/>
-            </a:pPr>
-            <a:r>
-              <a:rPr lang="en-GB">
-                <a:solidFill>
-                  <a:srgbClr val="DFE1E5"/>
-                </a:solidFill>
-                <a:latin typeface="Arial"/>
-                <a:ea typeface="Arial"/>
-                <a:cs typeface="Arial"/>
-                <a:sym typeface="Arial"/>
-              </a:rPr>
-              <a:t>Mechanism: @PostConstruct startup → async stream connections → continuous event reading → real-time Kafka publish</a:t>
-            </a:r>
-            <a:endParaRPr>
-              <a:solidFill>
-                <a:srgbClr val="DFE1E5"/>
-              </a:solidFill>
-              <a:latin typeface="Arial"/>
-              <a:ea typeface="Arial"/>
-              <a:cs typeface="Arial"/>
-              <a:sym typeface="Arial"/>
-            </a:endParaRPr>
-          </a:p>
-          <a:p>
-            <a:pPr indent="0" lvl="0" marL="0" rtl="0" algn="l">
-              <a:lnSpc>
-                <a:spcPct val="150000"/>
-              </a:lnSpc>
-              <a:spcBef>
-                <a:spcPts val="1200"/>
-              </a:spcBef>
-              <a:spcAft>
-                <a:spcPts val="0"/>
-              </a:spcAft>
-              <a:buNone/>
-            </a:pPr>
-            <a:r>
-              <a:t/>
-            </a:r>
-            <a:endParaRPr sz="1100">
-              <a:solidFill>
-                <a:srgbClr val="DFE1E5"/>
-              </a:solidFill>
-              <a:latin typeface="Arial"/>
-              <a:ea typeface="Arial"/>
-              <a:cs typeface="Arial"/>
-              <a:sym typeface="Arial"/>
-            </a:endParaRPr>
+              <a:rPr b="1" lang="en-GB" sz="1600"/>
+              <a:t>Core:</a:t>
+            </a:r>
+            <a:r>
+              <a:rPr lang="en-GB" sz="1600"/>
+              <a:t> React.js + Vite (for ultra-fast builds and hot-reloading).</a:t>
+            </a:r>
+            <a:endParaRPr sz="1600"/>
           </a:p>
           <a:p>
             <a:pPr indent="-330200" lvl="0" marL="457200" rtl="0" algn="l">
               <a:spcBef>
-                <a:spcPts val="1200"/>
+                <a:spcPts val="0"/>
               </a:spcBef>
               <a:spcAft>
                 <a:spcPts val="0"/>
@@ -15024,22 +15020,54 @@
               <a:buChar char="●"/>
             </a:pPr>
             <a:r>
-              <a:t/>
+              <a:rPr b="1" lang="en-GB" sz="1600"/>
+              <a:t>Styling:</a:t>
+            </a:r>
+            <a:r>
+              <a:rPr lang="en-GB" sz="1600"/>
+              <a:t> TailwindCSS (Dark/Sci-Fi design system, responsive, utility-first).</a:t>
             </a:r>
             <a:endParaRPr sz="1600"/>
           </a:p>
           <a:p>
-            <a:pPr indent="0" lvl="0" marL="0" rtl="0" algn="l">
-              <a:spcBef>
-                <a:spcPts val="1200"/>
-              </a:spcBef>
-              <a:spcAft>
-                <a:spcPts val="1200"/>
-              </a:spcAft>
-              <a:buNone/>
+            <a:pPr indent="-330200" lvl="0" marL="457200" rtl="0" algn="l">
+              <a:spcBef>
+                <a:spcPts val="0"/>
+              </a:spcBef>
+              <a:spcAft>
+                <a:spcPts val="0"/>
+              </a:spcAft>
+              <a:buSzPts val="1600"/>
+              <a:buChar char="●"/>
             </a:pPr>
             <a:r>
-              <a:t/>
+              <a:rPr b="1" lang="en-GB" sz="1600"/>
+              <a:t>Deployment:</a:t>
+            </a:r>
+            <a:r>
+              <a:rPr lang="en-GB" sz="1600"/>
+              <a:t> Containerized via Docker.</a:t>
+            </a:r>
+            <a:endParaRPr sz="1600"/>
+          </a:p>
+          <a:p>
+            <a:pPr indent="-330200" lvl="0" marL="457200" rtl="0" algn="l">
+              <a:spcBef>
+                <a:spcPts val="0"/>
+              </a:spcBef>
+              <a:spcAft>
+                <a:spcPts val="0"/>
+              </a:spcAft>
+              <a:buSzPts val="1600"/>
+              <a:buChar char="●"/>
+            </a:pPr>
+            <a:r>
+              <a:rPr b="1" lang="en-GB" sz="1600"/>
+              <a:t>Configuration:</a:t>
+            </a:r>
+            <a:r>
+              <a:rPr lang="en-GB" sz="1600"/>
+              <a:t> Environment variables (VITE_API_URL) injected via docker-compose.yml for "Plug &amp; Play" microservices integration.</a:t>
             </a:r>
             <a:endParaRPr sz="1600"/>
           </a:p>
@@ -15053,12 +15081,12 @@
 </p:sld>
 </file>
 
-<file path=ppt/slides/slide30.xml><?xml version="1.0" encoding="utf-8"?>
+<file path=ppt/slides/slide32.xml><?xml version="1.0" encoding="utf-8"?>
 <p:sld xmlns:a="http://schemas.openxmlformats.org/drawingml/2006/main" xmlns:r="http://schemas.openxmlformats.org/officeDocument/2006/relationships" xmlns:mc="http://schemas.openxmlformats.org/markup-compatibility/2006" xmlns:mv="urn:schemas-microsoft-com:mac:vml" xmlns:p="http://schemas.openxmlformats.org/presentationml/2006/main" xmlns:c="http://schemas.openxmlformats.org/drawingml/2006/chart" xmlns:dgm="http://schemas.openxmlformats.org/drawingml/2006/diagram" xmlns:o="urn:schemas-microsoft-com:office:office" xmlns:v="urn:schemas-microsoft-com:vml" xmlns:pvml="urn:schemas-microsoft-com:office:powerpoint" xmlns:com="http://schemas.openxmlformats.org/drawingml/2006/compatibility" xmlns:p14="http://schemas.microsoft.com/office/powerpoint/2010/main" xmlns:p15="http://schemas.microsoft.com/office/powerpoint/2012/main" xmlns:ahyp="http://schemas.microsoft.com/office/drawing/2018/hyperlinkcolor">
   <p:cSld>
     <p:spTree>
       <p:nvGrpSpPr>
-        <p:cNvPr id="294" name="Shape 294"/>
+        <p:cNvPr id="306" name="Shape 306"/>
         <p:cNvGrpSpPr/>
         <p:nvPr/>
       </p:nvGrpSpPr>
@@ -15072,7 +15100,7 @@
       </p:grpSpPr>
       <p:pic>
         <p:nvPicPr>
-          <p:cNvPr descr="Beautify this slide" id="295" name="Google Shape;295;p42"/>
+          <p:cNvPr descr="Beautify this slide" id="307" name="Google Shape;307;p44"/>
           <p:cNvPicPr preferRelativeResize="0"/>
           <p:nvPr/>
         </p:nvPicPr>
@@ -15111,7 +15139,7 @@
   <p:cSld>
     <p:spTree>
       <p:nvGrpSpPr>
-        <p:cNvPr id="151" name="Shape 151"/>
+        <p:cNvPr id="152" name="Shape 152"/>
         <p:cNvGrpSpPr/>
         <p:nvPr/>
       </p:nvGrpSpPr>
@@ -15125,7 +15153,7 @@
       </p:grpSpPr>
       <p:pic>
         <p:nvPicPr>
-          <p:cNvPr descr="do the same style as last ones that i liked" id="152" name="Google Shape;152;p16"/>
+          <p:cNvPr descr="Beautify this slide" id="153" name="Google Shape;153;p16"/>
           <p:cNvPicPr preferRelativeResize="0"/>
           <p:nvPr/>
         </p:nvPicPr>
@@ -15164,7 +15192,7 @@
   <p:cSld>
     <p:spTree>
       <p:nvGrpSpPr>
-        <p:cNvPr id="156" name="Shape 156"/>
+        <p:cNvPr id="157" name="Shape 157"/>
         <p:cNvGrpSpPr/>
         <p:nvPr/>
       </p:nvGrpSpPr>
@@ -15178,7 +15206,7 @@
       </p:grpSpPr>
       <p:sp>
         <p:nvSpPr>
-          <p:cNvPr id="157" name="Google Shape;157;p17"/>
+          <p:cNvPr id="158" name="Google Shape;158;p17"/>
           <p:cNvSpPr txBox="1"/>
           <p:nvPr>
             <p:ph type="ctrTitle"/>
@@ -15186,16 +15214,20 @@
         </p:nvSpPr>
         <p:spPr>
           <a:xfrm>
-            <a:off x="30425" y="129100"/>
-            <a:ext cx="8986200" cy="872700"/>
+            <a:off x="32100" y="37925"/>
+            <a:ext cx="8574000" cy="639300"/>
           </a:xfrm>
           <a:prstGeom prst="rect">
             <a:avLst/>
           </a:prstGeom>
+          <a:noFill/>
+          <a:ln>
+            <a:noFill/>
+          </a:ln>
         </p:spPr>
         <p:txBody>
           <a:bodyPr anchorCtr="0" anchor="t" bIns="91425" lIns="91425" spcFirstLastPara="1" rIns="91425" wrap="square" tIns="91425">
-            <a:normAutofit/>
+            <a:normAutofit fontScale="90000"/>
           </a:bodyPr>
           <a:lstStyle/>
           <a:p>
@@ -15218,7 +15250,27 @@
                 <a:cs typeface="Calibri"/>
                 <a:sym typeface="Calibri"/>
               </a:rPr>
-              <a:t>Mars Ingestion Service : Normalization</a:t>
+              <a:t>Mars Ingestion Service : Steaming &amp; Polling</a:t>
+            </a:r>
+            <a:endParaRPr>
+              <a:latin typeface="Calibri"/>
+              <a:ea typeface="Calibri"/>
+              <a:cs typeface="Calibri"/>
+              <a:sym typeface="Calibri"/>
+            </a:endParaRPr>
+          </a:p>
+          <a:p>
+            <a:pPr indent="0" lvl="0" marL="0" rtl="0" algn="l">
+              <a:spcBef>
+                <a:spcPts val="0"/>
+              </a:spcBef>
+              <a:spcAft>
+                <a:spcPts val="0"/>
+              </a:spcAft>
+              <a:buNone/>
+            </a:pPr>
+            <a:r>
+              <a:t/>
             </a:r>
             <a:endParaRPr/>
           </a:p>
@@ -15226,7 +15278,7 @@
       </p:sp>
       <p:sp>
         <p:nvSpPr>
-          <p:cNvPr id="158" name="Google Shape;158;p17"/>
+          <p:cNvPr id="159" name="Google Shape;159;p17"/>
           <p:cNvSpPr txBox="1"/>
           <p:nvPr>
             <p:ph idx="4294967295" type="body"/>
@@ -15262,17 +15314,6 @@
             </a:r>
             <a:r>
               <a:rPr lang="en-GB" sz="1600"/>
-              <a:t>: Transform raw sensor data into a unified event schema</a:t>
-            </a:r>
-            <a:br>
-              <a:rPr lang="en-GB" sz="1600"/>
-            </a:br>
-            <a:r>
-              <a:rPr b="1" lang="en-GB" sz="1600"/>
-              <a:t>Tech</a:t>
-            </a:r>
-            <a:r>
-              <a:rPr lang="en-GB" sz="1600"/>
               <a:t>: </a:t>
             </a:r>
             <a:r>
@@ -15285,28 +15326,19 @@
                 <a:cs typeface="Arial"/>
                 <a:sym typeface="Arial"/>
               </a:rPr>
-              <a:t>Java + Object mapper</a:t>
-            </a:r>
-            <a:endParaRPr sz="1600"/>
-          </a:p>
-          <a:p>
-            <a:pPr indent="-298450" lvl="0" marL="457200" rtl="0" algn="l">
-              <a:lnSpc>
-                <a:spcPct val="150000"/>
-              </a:lnSpc>
-              <a:spcBef>
-                <a:spcPts val="1200"/>
-              </a:spcBef>
-              <a:spcAft>
-                <a:spcPts val="0"/>
-              </a:spcAft>
-              <a:buClr>
-                <a:srgbClr val="DFE1E5"/>
-              </a:buClr>
-              <a:buSzPts val="1100"/>
-              <a:buFont typeface="Arial"/>
-              <a:buChar char="●"/>
-            </a:pPr>
+              <a:t>Primary bridge between Mars IoT sensors and downstream processing</a:t>
+            </a:r>
+            <a:br>
+              <a:rPr lang="en-GB" sz="1600"/>
+            </a:br>
+            <a:r>
+              <a:rPr b="1" lang="en-GB" sz="1600"/>
+              <a:t>Tech</a:t>
+            </a:r>
+            <a:r>
+              <a:rPr lang="en-GB" sz="1600"/>
+              <a:t>: </a:t>
+            </a:r>
             <a:r>
               <a:rPr lang="en-GB" sz="1000">
                 <a:solidFill>
@@ -15317,10 +15349,30 @@
                 <a:cs typeface="Arial"/>
                 <a:sym typeface="Arial"/>
               </a:rPr>
-              <a:t>Its fundamental purpose is to solve the heterogeneity problem - we receive data from 10+ different sensor types with varying formats. The Normalizer acts as a universal translator, converting these  formats into a single standardized </a:t>
-            </a:r>
-            <a:r>
-              <a:rPr lang="en-GB" sz="1000">
+              <a:t>Spring Boot , Java HTTP Client , Jackson JSON</a:t>
+            </a:r>
+            <a:endParaRPr sz="1600"/>
+          </a:p>
+          <a:p>
+            <a:pPr indent="-298450" lvl="0" marL="457200" rtl="0" algn="l">
+              <a:lnSpc>
+                <a:spcPct val="150000"/>
+              </a:lnSpc>
+              <a:spcBef>
+                <a:spcPts val="1200"/>
+              </a:spcBef>
+              <a:spcAft>
+                <a:spcPts val="0"/>
+              </a:spcAft>
+              <a:buClr>
+                <a:srgbClr val="DFE1E5"/>
+              </a:buClr>
+              <a:buSzPts val="1100"/>
+              <a:buFont typeface="Arial"/>
+              <a:buChar char="●"/>
+            </a:pPr>
+            <a:r>
+              <a:rPr lang="en-GB" sz="1100">
                 <a:solidFill>
                   <a:srgbClr val="DFE1E5"/>
                 </a:solidFill>
@@ -15329,21 +15381,9 @@
                 <a:cs typeface="Arial"/>
                 <a:sym typeface="Arial"/>
               </a:rPr>
-              <a:t>Event</a:t>
-            </a:r>
-            <a:r>
-              <a:rPr lang="en-GB" sz="1000">
-                <a:solidFill>
-                  <a:srgbClr val="DFE1E5"/>
-                </a:solidFill>
-                <a:latin typeface="Arial"/>
-                <a:ea typeface="Arial"/>
-                <a:cs typeface="Arial"/>
-                <a:sym typeface="Arial"/>
-              </a:rPr>
-              <a:t> schema with consistent fields: timestamp, sensor name, value, unit, and status.</a:t>
-            </a:r>
-            <a:endParaRPr sz="1000">
+              <a:t>MarsScheduledIngestionService (API Polling):</a:t>
+            </a:r>
+            <a:endParaRPr sz="1100">
               <a:solidFill>
                 <a:srgbClr val="DFE1E5"/>
               </a:solidFill>
@@ -15354,7 +15394,7 @@
             </a:endParaRPr>
           </a:p>
           <a:p>
-            <a:pPr indent="-292100" lvl="0" marL="457200" rtl="0" algn="l">
+            <a:pPr indent="-298450" lvl="1" marL="914400" rtl="0" algn="l">
               <a:lnSpc>
                 <a:spcPct val="150000"/>
               </a:lnSpc>
@@ -15367,12 +15407,12 @@
               <a:buClr>
                 <a:srgbClr val="DFE1E5"/>
               </a:buClr>
-              <a:buSzPts val="1000"/>
+              <a:buSzPts val="1100"/>
               <a:buFont typeface="Arial"/>
-              <a:buChar char="●"/>
+              <a:buChar char="○"/>
             </a:pPr>
             <a:r>
-              <a:rPr lang="en-GB" sz="1000">
+              <a:rPr lang="en-GB">
                 <a:solidFill>
                   <a:srgbClr val="DFE1E5"/>
                 </a:solidFill>
@@ -15381,9 +15421,9 @@
                 <a:cs typeface="Arial"/>
                 <a:sym typeface="Arial"/>
               </a:rPr>
-              <a:t>It's intelligent about transformations too - simple scalar sensors map 1:1, but complex sensors like particulate monitors expand into multiple events (PM1, PM2.5, PM10). The chemistry sensor splits into individual metric events, and water level sensors generate both percentage and liter readings. </a:t>
-            </a:r>
-            <a:endParaRPr sz="1000">
+              <a:t>@Scheduled HTTP polling every 5 seconds</a:t>
+            </a:r>
+            <a:endParaRPr>
               <a:solidFill>
                 <a:srgbClr val="DFE1E5"/>
               </a:solidFill>
@@ -15394,7 +15434,7 @@
             </a:endParaRPr>
           </a:p>
           <a:p>
-            <a:pPr indent="-292100" lvl="0" marL="457200" rtl="0" algn="l">
+            <a:pPr indent="-298450" lvl="1" marL="914400" rtl="0" algn="l">
               <a:lnSpc>
                 <a:spcPct val="150000"/>
               </a:lnSpc>
@@ -15407,12 +15447,12 @@
               <a:buClr>
                 <a:srgbClr val="DFE1E5"/>
               </a:buClr>
-              <a:buSzPts val="1000"/>
+              <a:buSzPts val="1100"/>
               <a:buFont typeface="Arial"/>
-              <a:buChar char="●"/>
+              <a:buChar char="○"/>
             </a:pPr>
             <a:r>
-              <a:rPr lang="en-GB" sz="1000">
+              <a:rPr lang="en-GB">
                 <a:solidFill>
                   <a:srgbClr val="DFE1E5"/>
                 </a:solidFill>
@@ -15421,7 +15461,275 @@
                 <a:cs typeface="Arial"/>
                 <a:sym typeface="Arial"/>
               </a:rPr>
-              <a:t>This normalization layer is what enables downstream services to consume all Mars habitat data through a single, predictable interface. </a:t>
+              <a:t>8 IoT sensors (Temperature, Humidity, CO2, pH, Water Level, Pressure, Air Quality)</a:t>
+            </a:r>
+            <a:endParaRPr>
+              <a:solidFill>
+                <a:srgbClr val="DFE1E5"/>
+              </a:solidFill>
+              <a:latin typeface="Arial"/>
+              <a:ea typeface="Arial"/>
+              <a:cs typeface="Arial"/>
+              <a:sym typeface="Arial"/>
+            </a:endParaRPr>
+          </a:p>
+          <a:p>
+            <a:pPr indent="-298450" lvl="1" marL="914400" rtl="0" algn="l">
+              <a:lnSpc>
+                <a:spcPct val="150000"/>
+              </a:lnSpc>
+              <a:spcBef>
+                <a:spcPts val="0"/>
+              </a:spcBef>
+              <a:spcAft>
+                <a:spcPts val="0"/>
+              </a:spcAft>
+              <a:buClr>
+                <a:srgbClr val="DFE1E5"/>
+              </a:buClr>
+              <a:buSzPts val="1100"/>
+              <a:buFont typeface="Arial"/>
+              <a:buChar char="○"/>
+            </a:pPr>
+            <a:r>
+              <a:rPr lang="en-GB" sz="1000">
+                <a:solidFill>
+                  <a:srgbClr val="DFE1E5"/>
+                </a:solidFill>
+                <a:highlight>
+                  <a:srgbClr val="2B2D30"/>
+                </a:highlight>
+                <a:latin typeface="Arial"/>
+                <a:ea typeface="Arial"/>
+                <a:cs typeface="Arial"/>
+                <a:sym typeface="Arial"/>
+              </a:rPr>
+              <a:t>Synchronous health checks → sensor polling → JSON mapping → Kafka publish</a:t>
+            </a:r>
+            <a:endParaRPr>
+              <a:solidFill>
+                <a:srgbClr val="DFE1E5"/>
+              </a:solidFill>
+              <a:latin typeface="Arial"/>
+              <a:ea typeface="Arial"/>
+              <a:cs typeface="Arial"/>
+              <a:sym typeface="Arial"/>
+            </a:endParaRPr>
+          </a:p>
+          <a:p>
+            <a:pPr indent="-298450" lvl="0" marL="457200" rtl="0" algn="l">
+              <a:lnSpc>
+                <a:spcPct val="150000"/>
+              </a:lnSpc>
+              <a:spcBef>
+                <a:spcPts val="0"/>
+              </a:spcBef>
+              <a:spcAft>
+                <a:spcPts val="0"/>
+              </a:spcAft>
+              <a:buClr>
+                <a:srgbClr val="DFE1E5"/>
+              </a:buClr>
+              <a:buSzPts val="1100"/>
+              <a:buFont typeface="Arial"/>
+              <a:buChar char="●"/>
+            </a:pPr>
+            <a:r>
+              <a:rPr lang="en-GB" sz="1100">
+                <a:solidFill>
+                  <a:srgbClr val="DFE1E5"/>
+                </a:solidFill>
+                <a:latin typeface="Arial"/>
+                <a:ea typeface="Arial"/>
+                <a:cs typeface="Arial"/>
+                <a:sym typeface="Arial"/>
+              </a:rPr>
+              <a:t>MarsTelemetryStreamService (Server-Sent Events Streaming):</a:t>
+            </a:r>
+            <a:endParaRPr sz="1100">
+              <a:solidFill>
+                <a:srgbClr val="DFE1E5"/>
+              </a:solidFill>
+              <a:latin typeface="Arial"/>
+              <a:ea typeface="Arial"/>
+              <a:cs typeface="Arial"/>
+              <a:sym typeface="Arial"/>
+            </a:endParaRPr>
+          </a:p>
+          <a:p>
+            <a:pPr indent="-298450" lvl="1" marL="914400" rtl="0" algn="l">
+              <a:lnSpc>
+                <a:spcPct val="150000"/>
+              </a:lnSpc>
+              <a:spcBef>
+                <a:spcPts val="0"/>
+              </a:spcBef>
+              <a:spcAft>
+                <a:spcPts val="0"/>
+              </a:spcAft>
+              <a:buClr>
+                <a:srgbClr val="DFE1E5"/>
+              </a:buClr>
+              <a:buSzPts val="1100"/>
+              <a:buFont typeface="Arial"/>
+              <a:buChar char="○"/>
+            </a:pPr>
+            <a:r>
+              <a:rPr lang="en-GB">
+                <a:solidFill>
+                  <a:srgbClr val="DFE1E5"/>
+                </a:solidFill>
+                <a:latin typeface="Arial"/>
+                <a:ea typeface="Arial"/>
+                <a:cs typeface="Arial"/>
+                <a:sym typeface="Arial"/>
+              </a:rPr>
+              <a:t>Approach: Real-time SSE streaming with persistent HTTP connections</a:t>
+            </a:r>
+            <a:endParaRPr>
+              <a:solidFill>
+                <a:srgbClr val="DFE1E5"/>
+              </a:solidFill>
+              <a:latin typeface="Arial"/>
+              <a:ea typeface="Arial"/>
+              <a:cs typeface="Arial"/>
+              <a:sym typeface="Arial"/>
+            </a:endParaRPr>
+          </a:p>
+          <a:p>
+            <a:pPr indent="-298450" lvl="1" marL="914400" rtl="0" algn="l">
+              <a:lnSpc>
+                <a:spcPct val="150000"/>
+              </a:lnSpc>
+              <a:spcBef>
+                <a:spcPts val="0"/>
+              </a:spcBef>
+              <a:spcAft>
+                <a:spcPts val="0"/>
+              </a:spcAft>
+              <a:buClr>
+                <a:srgbClr val="DFE1E5"/>
+              </a:buClr>
+              <a:buSzPts val="1100"/>
+              <a:buFont typeface="Arial"/>
+              <a:buChar char="○"/>
+            </a:pPr>
+            <a:r>
+              <a:rPr lang="en-GB">
+                <a:solidFill>
+                  <a:srgbClr val="DFE1E5"/>
+                </a:solidFill>
+                <a:latin typeface="Arial"/>
+                <a:ea typeface="Arial"/>
+                <a:cs typeface="Arial"/>
+                <a:sym typeface="Arial"/>
+              </a:rPr>
+              <a:t>7 telemetry streams (Solar Array, Power Bus, Power Consumption, Radiation, Life Support, Thermal Loop, Airlock)</a:t>
+            </a:r>
+            <a:endParaRPr>
+              <a:solidFill>
+                <a:srgbClr val="DFE1E5"/>
+              </a:solidFill>
+              <a:latin typeface="Arial"/>
+              <a:ea typeface="Arial"/>
+              <a:cs typeface="Arial"/>
+              <a:sym typeface="Arial"/>
+            </a:endParaRPr>
+          </a:p>
+          <a:p>
+            <a:pPr indent="-298450" lvl="1" marL="914400" rtl="0" algn="l">
+              <a:lnSpc>
+                <a:spcPct val="150000"/>
+              </a:lnSpc>
+              <a:spcBef>
+                <a:spcPts val="0"/>
+              </a:spcBef>
+              <a:spcAft>
+                <a:spcPts val="0"/>
+              </a:spcAft>
+              <a:buClr>
+                <a:srgbClr val="DFE1E5"/>
+              </a:buClr>
+              <a:buSzPts val="1100"/>
+              <a:buFont typeface="Arial"/>
+              <a:buChar char="○"/>
+            </a:pPr>
+            <a:r>
+              <a:rPr lang="en-GB">
+                <a:solidFill>
+                  <a:srgbClr val="DFE1E5"/>
+                </a:solidFill>
+                <a:latin typeface="Arial"/>
+                <a:ea typeface="Arial"/>
+                <a:cs typeface="Arial"/>
+                <a:sym typeface="Arial"/>
+              </a:rPr>
+              <a:t>Mechanism: @PostConstruct startup → async stream connections → continuous event reading → real-time Kafka publish</a:t>
+            </a:r>
+            <a:endParaRPr>
+              <a:solidFill>
+                <a:srgbClr val="DFE1E5"/>
+              </a:solidFill>
+              <a:latin typeface="Arial"/>
+              <a:ea typeface="Arial"/>
+              <a:cs typeface="Arial"/>
+              <a:sym typeface="Arial"/>
+            </a:endParaRPr>
+          </a:p>
+          <a:p>
+            <a:pPr indent="0" lvl="0" marL="0" rtl="0" algn="l">
+              <a:lnSpc>
+                <a:spcPct val="150000"/>
+              </a:lnSpc>
+              <a:spcBef>
+                <a:spcPts val="1200"/>
+              </a:spcBef>
+              <a:spcAft>
+                <a:spcPts val="0"/>
+              </a:spcAft>
+              <a:buNone/>
+            </a:pPr>
+            <a:r>
+              <a:t/>
+            </a:r>
+            <a:endParaRPr sz="1100">
+              <a:solidFill>
+                <a:srgbClr val="DFE1E5"/>
+              </a:solidFill>
+              <a:latin typeface="Arial"/>
+              <a:ea typeface="Arial"/>
+              <a:cs typeface="Arial"/>
+              <a:sym typeface="Arial"/>
+            </a:endParaRPr>
+          </a:p>
+          <a:p>
+            <a:pPr indent="-330200" lvl="0" marL="457200" rtl="0" algn="l">
+              <a:spcBef>
+                <a:spcPts val="1200"/>
+              </a:spcBef>
+              <a:spcAft>
+                <a:spcPts val="0"/>
+              </a:spcAft>
+              <a:buSzPts val="1600"/>
+              <a:buChar char="●"/>
+            </a:pPr>
+            <a:r>
+              <a:t/>
+            </a:r>
+            <a:endParaRPr sz="1600"/>
+          </a:p>
+          <a:p>
+            <a:pPr indent="0" lvl="0" marL="0" rtl="0" algn="l">
+              <a:spcBef>
+                <a:spcPts val="1200"/>
+              </a:spcBef>
+              <a:spcAft>
+                <a:spcPts val="1200"/>
+              </a:spcAft>
+              <a:buNone/>
+            </a:pPr>
+            <a:r>
+              <a:t/>
             </a:r>
             <a:endParaRPr sz="1600"/>
           </a:p>
@@ -15440,7 +15748,7 @@
   <p:cSld>
     <p:spTree>
       <p:nvGrpSpPr>
-        <p:cNvPr id="162" name="Shape 162"/>
+        <p:cNvPr id="163" name="Shape 163"/>
         <p:cNvGrpSpPr/>
         <p:nvPr/>
       </p:nvGrpSpPr>
@@ -15454,7 +15762,7 @@
       </p:grpSpPr>
       <p:pic>
         <p:nvPicPr>
-          <p:cNvPr descr="Beautify this slide" id="163" name="Google Shape;163;p18"/>
+          <p:cNvPr descr="do the same style as last ones that i liked" id="164" name="Google Shape;164;p18"/>
           <p:cNvPicPr preferRelativeResize="0"/>
           <p:nvPr/>
         </p:nvPicPr>
@@ -15493,7 +15801,7 @@
   <p:cSld>
     <p:spTree>
       <p:nvGrpSpPr>
-        <p:cNvPr id="167" name="Shape 167"/>
+        <p:cNvPr id="168" name="Shape 168"/>
         <p:cNvGrpSpPr/>
         <p:nvPr/>
       </p:nvGrpSpPr>
@@ -15507,7 +15815,7 @@
       </p:grpSpPr>
       <p:sp>
         <p:nvSpPr>
-          <p:cNvPr id="168" name="Google Shape;168;p19"/>
+          <p:cNvPr id="169" name="Google Shape;169;p19"/>
           <p:cNvSpPr txBox="1"/>
           <p:nvPr>
             <p:ph type="ctrTitle"/>
@@ -15515,8 +15823,8 @@
         </p:nvSpPr>
         <p:spPr>
           <a:xfrm>
-            <a:off x="182475" y="113900"/>
-            <a:ext cx="8859600" cy="776400"/>
+            <a:off x="30425" y="129100"/>
+            <a:ext cx="8986200" cy="872700"/>
           </a:xfrm>
           <a:prstGeom prst="rect">
             <a:avLst/>
@@ -15524,7 +15832,7 @@
         </p:spPr>
         <p:txBody>
           <a:bodyPr anchorCtr="0" anchor="t" bIns="91425" lIns="91425" spcFirstLastPara="1" rIns="91425" wrap="square" tIns="91425">
-            <a:normAutofit fontScale="90000"/>
+            <a:normAutofit/>
           </a:bodyPr>
           <a:lstStyle/>
           <a:p>
@@ -15547,7 +15855,7 @@
                 <a:cs typeface="Calibri"/>
                 <a:sym typeface="Calibri"/>
               </a:rPr>
-              <a:t>Mars Ingestion Service : Kafka Producer</a:t>
+              <a:t>Mars Ingestion Service : Normalization</a:t>
             </a:r>
             <a:endParaRPr/>
           </a:p>
@@ -15555,7 +15863,7 @@
       </p:sp>
       <p:sp>
         <p:nvSpPr>
-          <p:cNvPr id="169" name="Google Shape;169;p19"/>
+          <p:cNvPr id="170" name="Google Shape;170;p19"/>
           <p:cNvSpPr txBox="1"/>
           <p:nvPr>
             <p:ph idx="4294967295" type="body"/>
@@ -15591,6 +15899,17 @@
             </a:r>
             <a:r>
               <a:rPr lang="en-GB" sz="1600"/>
+              <a:t>: Transform raw sensor data into a unified event schema</a:t>
+            </a:r>
+            <a:br>
+              <a:rPr lang="en-GB" sz="1600"/>
+            </a:br>
+            <a:r>
+              <a:rPr b="1" lang="en-GB" sz="1600"/>
+              <a:t>Tech</a:t>
+            </a:r>
+            <a:r>
+              <a:rPr lang="en-GB" sz="1600"/>
               <a:t>: </a:t>
             </a:r>
             <a:r>
@@ -15603,19 +15922,28 @@
                 <a:cs typeface="Arial"/>
                 <a:sym typeface="Arial"/>
               </a:rPr>
-              <a:t>Publishes normalized Mars telemetry data from the ingestion services to Kafka topics for downstream consumption</a:t>
-            </a:r>
-            <a:br>
-              <a:rPr lang="en-GB" sz="1600"/>
-            </a:br>
-            <a:r>
-              <a:rPr b="1" lang="en-GB" sz="1600"/>
-              <a:t>Tech</a:t>
-            </a:r>
-            <a:r>
-              <a:rPr lang="en-GB" sz="1600"/>
-              <a:t>: </a:t>
-            </a:r>
+              <a:t>Java + Object mapper</a:t>
+            </a:r>
+            <a:endParaRPr sz="1600"/>
+          </a:p>
+          <a:p>
+            <a:pPr indent="-298450" lvl="0" marL="457200" rtl="0" algn="l">
+              <a:lnSpc>
+                <a:spcPct val="150000"/>
+              </a:lnSpc>
+              <a:spcBef>
+                <a:spcPts val="1200"/>
+              </a:spcBef>
+              <a:spcAft>
+                <a:spcPts val="0"/>
+              </a:spcAft>
+              <a:buClr>
+                <a:srgbClr val="DFE1E5"/>
+              </a:buClr>
+              <a:buSzPts val="1100"/>
+              <a:buFont typeface="Arial"/>
+              <a:buChar char="●"/>
+            </a:pPr>
             <a:r>
               <a:rPr lang="en-GB" sz="1000">
                 <a:solidFill>
@@ -15626,7 +15954,7 @@
                 <a:cs typeface="Arial"/>
                 <a:sym typeface="Arial"/>
               </a:rPr>
-              <a:t>CompletableFuture</a:t>
+              <a:t>Its fundamental purpose is to solve the heterogeneity problem - we receive data from 10+ different sensor types with varying formats. The Normalizer acts as a universal translator, converting these  formats into a single standardized </a:t>
             </a:r>
             <a:r>
               <a:rPr lang="en-GB" sz="1000">
@@ -15638,7 +15966,7 @@
                 <a:cs typeface="Arial"/>
                 <a:sym typeface="Arial"/>
               </a:rPr>
-              <a:t> ,</a:t>
+              <a:t>Event</a:t>
             </a:r>
             <a:r>
               <a:rPr lang="en-GB" sz="1000">
@@ -15650,105 +15978,9 @@
                 <a:cs typeface="Arial"/>
                 <a:sym typeface="Arial"/>
               </a:rPr>
-              <a:t>Apache Kafka</a:t>
-            </a:r>
-            <a:endParaRPr sz="1600"/>
-          </a:p>
-          <a:p>
-            <a:pPr indent="-298450" lvl="0" marL="457200" rtl="0" algn="l">
-              <a:lnSpc>
-                <a:spcPct val="150000"/>
-              </a:lnSpc>
-              <a:spcBef>
-                <a:spcPts val="1200"/>
-              </a:spcBef>
-              <a:spcAft>
-                <a:spcPts val="0"/>
-              </a:spcAft>
-              <a:buClr>
-                <a:srgbClr val="DFE1E5"/>
-              </a:buClr>
-              <a:buSzPts val="1100"/>
-              <a:buFont typeface="Arial"/>
-              <a:buChar char="●"/>
-            </a:pPr>
-            <a:r>
-              <a:rPr lang="en-GB" sz="1000">
-                <a:solidFill>
-                  <a:srgbClr val="DFE1E5"/>
-                </a:solidFill>
-                <a:latin typeface="Arial"/>
-                <a:ea typeface="Arial"/>
-                <a:cs typeface="Arial"/>
-                <a:sym typeface="Arial"/>
-              </a:rPr>
-              <a:t>The now normalized events are now ready to be published into our topic </a:t>
-            </a:r>
-            <a:r>
-              <a:rPr lang="en-GB" sz="850">
-                <a:solidFill>
-                  <a:srgbClr val="DFE1E5"/>
-                </a:solidFill>
-                <a:latin typeface="Consolas"/>
-                <a:ea typeface="Consolas"/>
-                <a:cs typeface="Consolas"/>
-                <a:sym typeface="Consolas"/>
-              </a:rPr>
-              <a:t>mars-telemetry-events</a:t>
-            </a:r>
-            <a:endParaRPr sz="850">
-              <a:solidFill>
-                <a:srgbClr val="DFE1E5"/>
-              </a:solidFill>
-              <a:latin typeface="Consolas"/>
-              <a:ea typeface="Consolas"/>
-              <a:cs typeface="Consolas"/>
-              <a:sym typeface="Consolas"/>
-            </a:endParaRPr>
-          </a:p>
-          <a:p>
-            <a:pPr indent="-282575" lvl="0" marL="457200" rtl="0" algn="l">
-              <a:lnSpc>
-                <a:spcPct val="150000"/>
-              </a:lnSpc>
-              <a:spcBef>
-                <a:spcPts val="0"/>
-              </a:spcBef>
-              <a:spcAft>
-                <a:spcPts val="0"/>
-              </a:spcAft>
-              <a:buClr>
-                <a:srgbClr val="DFE1E5"/>
-              </a:buClr>
-              <a:buSzPts val="850"/>
-              <a:buFont typeface="Consolas"/>
-              <a:buChar char="●"/>
-            </a:pPr>
-            <a:r>
-              <a:rPr lang="en-GB" sz="850">
-                <a:solidFill>
-                  <a:srgbClr val="DFE1E5"/>
-                </a:solidFill>
-                <a:latin typeface="Consolas"/>
-                <a:ea typeface="Consolas"/>
-                <a:cs typeface="Consolas"/>
-                <a:sym typeface="Consolas"/>
-              </a:rPr>
-              <a:t>The events are published asynchronously </a:t>
-            </a:r>
-            <a:r>
-              <a:rPr lang="en-GB" sz="1100">
-                <a:solidFill>
-                  <a:srgbClr val="DFE1E5"/>
-                </a:solidFill>
-                <a:latin typeface="Arial"/>
-                <a:ea typeface="Arial"/>
-                <a:cs typeface="Arial"/>
-                <a:sym typeface="Arial"/>
-              </a:rPr>
-              <a:t>, this prevents Kafka I/O from blocking the 5-second polling cycles - the ingestion services continue collecting data while Kafka processes messages in the background</a:t>
-            </a:r>
-            <a:endParaRPr sz="1100">
+              <a:t> schema with consistent fields: timestamp, sensor name, value, unit, and status.</a:t>
+            </a:r>
+            <a:endParaRPr sz="1000">
               <a:solidFill>
                 <a:srgbClr val="DFE1E5"/>
               </a:solidFill>
@@ -15759,9 +15991,9 @@
             </a:endParaRPr>
           </a:p>
           <a:p>
-            <a:pPr indent="-282575" lvl="0" marL="457200" rtl="0" algn="l">
+            <a:pPr indent="-292100" lvl="0" marL="457200" rtl="0" algn="l">
               <a:lnSpc>
-                <a:spcPct val="160000"/>
+                <a:spcPct val="150000"/>
               </a:lnSpc>
               <a:spcBef>
                 <a:spcPts val="0"/>
@@ -15772,12 +16004,12 @@
               <a:buClr>
                 <a:srgbClr val="DFE1E5"/>
               </a:buClr>
-              <a:buSzPts val="850"/>
-              <a:buFont typeface="Consolas"/>
+              <a:buSzPts val="1000"/>
+              <a:buFont typeface="Arial"/>
               <a:buChar char="●"/>
             </a:pPr>
             <a:r>
-              <a:rPr lang="en-GB" sz="1100">
+              <a:rPr lang="en-GB" sz="1000">
                 <a:solidFill>
                   <a:srgbClr val="DFE1E5"/>
                 </a:solidFill>
@@ -15786,9 +16018,9 @@
                 <a:cs typeface="Arial"/>
                 <a:sym typeface="Arial"/>
               </a:rPr>
-              <a:t>We use sensor names as message keys to ensure consistent partitioning - all readings from the same sensor go to the same partition, maintaining chronological order.</a:t>
-            </a:r>
-            <a:endParaRPr sz="1100">
+              <a:t>It's intelligent about transformations too - simple scalar sensors map 1:1, but complex sensors like particulate monitors expand into multiple events (PM1, PM2.5, PM10). The chemistry sensor splits into individual metric events, and water level sensors generate both percentage and liter readings. </a:t>
+            </a:r>
+            <a:endParaRPr sz="1000">
               <a:solidFill>
                 <a:srgbClr val="DFE1E5"/>
               </a:solidFill>
@@ -15799,43 +16031,34 @@
             </a:endParaRPr>
           </a:p>
           <a:p>
-            <a:pPr indent="0" lvl="0" marL="0" rtl="0" algn="l">
-              <a:spcBef>
-                <a:spcPts val="900"/>
-              </a:spcBef>
-              <a:spcAft>
-                <a:spcPts val="0"/>
-              </a:spcAft>
-              <a:buNone/>
-            </a:pPr>
-            <a:r>
-              <a:t/>
-            </a:r>
-            <a:endParaRPr sz="850">
-              <a:solidFill>
-                <a:srgbClr val="DFE1E5"/>
-              </a:solidFill>
-              <a:latin typeface="Consolas"/>
-              <a:ea typeface="Consolas"/>
-              <a:cs typeface="Consolas"/>
-              <a:sym typeface="Consolas"/>
-            </a:endParaRPr>
-          </a:p>
-          <a:p>
-            <a:pPr indent="0" lvl="0" marL="457200" rtl="0" algn="l">
+            <a:pPr indent="-292100" lvl="0" marL="457200" rtl="0" algn="l">
               <a:lnSpc>
                 <a:spcPct val="150000"/>
               </a:lnSpc>
               <a:spcBef>
-                <a:spcPts val="500"/>
-              </a:spcBef>
-              <a:spcAft>
-                <a:spcPts val="600"/>
-              </a:spcAft>
-              <a:buNone/>
+                <a:spcPts val="0"/>
+              </a:spcBef>
+              <a:spcAft>
+                <a:spcPts val="0"/>
+              </a:spcAft>
+              <a:buClr>
+                <a:srgbClr val="DFE1E5"/>
+              </a:buClr>
+              <a:buSzPts val="1000"/>
+              <a:buFont typeface="Arial"/>
+              <a:buChar char="●"/>
             </a:pPr>
             <a:r>
-              <a:t/>
+              <a:rPr lang="en-GB" sz="1000">
+                <a:solidFill>
+                  <a:srgbClr val="DFE1E5"/>
+                </a:solidFill>
+                <a:latin typeface="Arial"/>
+                <a:ea typeface="Arial"/>
+                <a:cs typeface="Arial"/>
+                <a:sym typeface="Arial"/>
+              </a:rPr>
+              <a:t>This normalization layer is what enables downstream services to consume all Mars habitat data through a single, predictable interface. </a:t>
             </a:r>
             <a:endParaRPr sz="1600"/>
           </a:p>
@@ -15854,7 +16077,7 @@
   <p:cSld>
     <p:spTree>
       <p:nvGrpSpPr>
-        <p:cNvPr id="173" name="Shape 173"/>
+        <p:cNvPr id="174" name="Shape 174"/>
         <p:cNvGrpSpPr/>
         <p:nvPr/>
       </p:nvGrpSpPr>
@@ -15868,7 +16091,7 @@
       </p:grpSpPr>
       <p:pic>
         <p:nvPicPr>
-          <p:cNvPr descr="Beautify this slide" id="174" name="Google Shape;174;p20"/>
+          <p:cNvPr descr="Beautify this slide" id="175" name="Google Shape;175;p20"/>
           <p:cNvPicPr preferRelativeResize="0"/>
           <p:nvPr/>
         </p:nvPicPr>
@@ -15907,7 +16130,7 @@
   <p:cSld>
     <p:spTree>
       <p:nvGrpSpPr>
-        <p:cNvPr id="178" name="Shape 178"/>
+        <p:cNvPr id="179" name="Shape 179"/>
         <p:cNvGrpSpPr/>
         <p:nvPr/>
       </p:nvGrpSpPr>
@@ -15921,28 +16144,31 @@
       </p:grpSpPr>
       <p:sp>
         <p:nvSpPr>
-          <p:cNvPr id="179" name="Google Shape;179;p21"/>
+          <p:cNvPr id="180" name="Google Shape;180;p21"/>
           <p:cNvSpPr txBox="1"/>
           <p:nvPr>
-            <p:ph type="title"/>
+            <p:ph type="ctrTitle"/>
           </p:nvPr>
         </p:nvSpPr>
         <p:spPr>
           <a:xfrm>
-            <a:off x="1297500" y="393750"/>
-            <a:ext cx="7038900" cy="914100"/>
+            <a:off x="182475" y="113900"/>
+            <a:ext cx="8859600" cy="776400"/>
           </a:xfrm>
           <a:prstGeom prst="rect">
             <a:avLst/>
           </a:prstGeom>
         </p:spPr>
         <p:txBody>
-          <a:bodyPr anchorCtr="0" anchor="ctr" bIns="91425" lIns="91425" spcFirstLastPara="1" rIns="91425" wrap="square" tIns="91425">
+          <a:bodyPr anchorCtr="0" anchor="t" bIns="91425" lIns="91425" spcFirstLastPara="1" rIns="91425" wrap="square" tIns="91425">
             <a:normAutofit fontScale="90000"/>
           </a:bodyPr>
           <a:lstStyle/>
           <a:p>
             <a:pPr indent="0" lvl="0" marL="0" rtl="0" algn="l">
+              <a:lnSpc>
+                <a:spcPct val="115000"/>
+              </a:lnSpc>
               <a:spcBef>
                 <a:spcPts val="0"/>
               </a:spcBef>
@@ -15952,8 +16178,13 @@
               <a:buNone/>
             </a:pPr>
             <a:r>
-              <a:rPr lang="en-GB"/>
-              <a:t>Mars Message Consumer: The Event Processor </a:t>
+              <a:rPr lang="en-GB">
+                <a:latin typeface="Calibri"/>
+                <a:ea typeface="Calibri"/>
+                <a:cs typeface="Calibri"/>
+                <a:sym typeface="Calibri"/>
+              </a:rPr>
+              <a:t>Mars Ingestion Service : Kafka Producer</a:t>
             </a:r>
             <a:endParaRPr/>
           </a:p>
@@ -15961,10 +16192,10 @@
       </p:sp>
       <p:sp>
         <p:nvSpPr>
-          <p:cNvPr id="180" name="Google Shape;180;p21"/>
+          <p:cNvPr id="181" name="Google Shape;181;p21"/>
           <p:cNvSpPr txBox="1"/>
           <p:nvPr>
-            <p:ph idx="1" type="body"/>
+            <p:ph idx="4294967295" type="body"/>
           </p:nvPr>
         </p:nvSpPr>
         <p:spPr>
@@ -15997,7 +16228,19 @@
             </a:r>
             <a:r>
               <a:rPr lang="en-GB" sz="1600"/>
-              <a:t>: The background worker handling high-throughput telemetry data.</a:t>
+              <a:t>: </a:t>
+            </a:r>
+            <a:r>
+              <a:rPr lang="en-GB" sz="1000">
+                <a:solidFill>
+                  <a:srgbClr val="DFE1E5"/>
+                </a:solidFill>
+                <a:latin typeface="Arial"/>
+                <a:ea typeface="Arial"/>
+                <a:cs typeface="Arial"/>
+                <a:sym typeface="Arial"/>
+              </a:rPr>
+              <a:t>Publishes normalized Mars telemetry data from the ingestion services to Kafka topics for downstream consumption</a:t>
             </a:r>
             <a:br>
               <a:rPr lang="en-GB" sz="1600"/>
@@ -16008,58 +16251,228 @@
             </a:r>
             <a:r>
               <a:rPr lang="en-GB" sz="1600"/>
-              <a:t>: Python, confluent-kafka</a:t>
+              <a:t>: </a:t>
+            </a:r>
+            <a:r>
+              <a:rPr lang="en-GB" sz="1000">
+                <a:solidFill>
+                  <a:srgbClr val="DFE1E5"/>
+                </a:solidFill>
+                <a:latin typeface="Arial"/>
+                <a:ea typeface="Arial"/>
+                <a:cs typeface="Arial"/>
+                <a:sym typeface="Arial"/>
+              </a:rPr>
+              <a:t>CompletableFuture</a:t>
+            </a:r>
+            <a:r>
+              <a:rPr lang="en-GB" sz="1000">
+                <a:solidFill>
+                  <a:srgbClr val="DFE1E5"/>
+                </a:solidFill>
+                <a:latin typeface="Arial"/>
+                <a:ea typeface="Arial"/>
+                <a:cs typeface="Arial"/>
+                <a:sym typeface="Arial"/>
+              </a:rPr>
+              <a:t> ,</a:t>
+            </a:r>
+            <a:r>
+              <a:rPr lang="en-GB" sz="1000">
+                <a:solidFill>
+                  <a:srgbClr val="DFE1E5"/>
+                </a:solidFill>
+                <a:latin typeface="Arial"/>
+                <a:ea typeface="Arial"/>
+                <a:cs typeface="Arial"/>
+                <a:sym typeface="Arial"/>
+              </a:rPr>
+              <a:t>Apache Kafka</a:t>
             </a:r>
             <a:endParaRPr sz="1600"/>
           </a:p>
           <a:p>
-            <a:pPr indent="-330200" lvl="0" marL="457200" rtl="0" algn="l">
+            <a:pPr indent="-298450" lvl="0" marL="457200" rtl="0" algn="l">
+              <a:lnSpc>
+                <a:spcPct val="150000"/>
+              </a:lnSpc>
               <a:spcBef>
                 <a:spcPts val="1200"/>
               </a:spcBef>
               <a:spcAft>
                 <a:spcPts val="0"/>
               </a:spcAft>
-              <a:buSzPts val="1600"/>
+              <a:buClr>
+                <a:srgbClr val="DFE1E5"/>
+              </a:buClr>
+              <a:buSzPts val="1100"/>
+              <a:buFont typeface="Arial"/>
               <a:buChar char="●"/>
             </a:pPr>
             <a:r>
-              <a:rPr lang="en-GB" sz="1600"/>
-              <a:t>Listens to the mars-telemetry-events Kafka topic in an infinite loop. Kafka acts as a shock-absorber, preventing system crashes during data spikes.</a:t>
-            </a:r>
-            <a:endParaRPr sz="1600"/>
+              <a:rPr lang="en-GB" sz="1000">
+                <a:solidFill>
+                  <a:srgbClr val="DFE1E5"/>
+                </a:solidFill>
+                <a:latin typeface="Arial"/>
+                <a:ea typeface="Arial"/>
+                <a:cs typeface="Arial"/>
+                <a:sym typeface="Arial"/>
+              </a:rPr>
+              <a:t>The now normalized events are now ready to be published into our topic </a:t>
+            </a:r>
+            <a:r>
+              <a:rPr lang="en-GB" sz="850">
+                <a:solidFill>
+                  <a:srgbClr val="DFE1E5"/>
+                </a:solidFill>
+                <a:latin typeface="Consolas"/>
+                <a:ea typeface="Consolas"/>
+                <a:cs typeface="Consolas"/>
+                <a:sym typeface="Consolas"/>
+              </a:rPr>
+              <a:t>mars-telemetry-events</a:t>
+            </a:r>
+            <a:endParaRPr sz="850">
+              <a:solidFill>
+                <a:srgbClr val="DFE1E5"/>
+              </a:solidFill>
+              <a:latin typeface="Consolas"/>
+              <a:ea typeface="Consolas"/>
+              <a:cs typeface="Consolas"/>
+              <a:sym typeface="Consolas"/>
+            </a:endParaRPr>
           </a:p>
           <a:p>
-            <a:pPr indent="-330200" lvl="0" marL="457200" rtl="0" algn="l">
-              <a:spcBef>
-                <a:spcPts val="0"/>
-              </a:spcBef>
-              <a:spcAft>
-                <a:spcPts val="0"/>
-              </a:spcAft>
-              <a:buSzPts val="1600"/>
+            <a:pPr indent="-282575" lvl="0" marL="457200" rtl="0" algn="l">
+              <a:lnSpc>
+                <a:spcPct val="150000"/>
+              </a:lnSpc>
+              <a:spcBef>
+                <a:spcPts val="0"/>
+              </a:spcBef>
+              <a:spcAft>
+                <a:spcPts val="0"/>
+              </a:spcAft>
+              <a:buClr>
+                <a:srgbClr val="DFE1E5"/>
+              </a:buClr>
+              <a:buSzPts val="850"/>
+              <a:buFont typeface="Consolas"/>
               <a:buChar char="●"/>
             </a:pPr>
             <a:r>
-              <a:rPr lang="en-GB" sz="1600"/>
-              <a:t>For every reading, it queries the DB Manager (PostgreSQL) to check if the new value triggers any Automation Rules (e.g., "if temp &gt; 35, turn on fan").</a:t>
-            </a:r>
-            <a:endParaRPr sz="1600"/>
+              <a:rPr lang="en-GB" sz="850">
+                <a:solidFill>
+                  <a:srgbClr val="DFE1E5"/>
+                </a:solidFill>
+                <a:latin typeface="Consolas"/>
+                <a:ea typeface="Consolas"/>
+                <a:cs typeface="Consolas"/>
+                <a:sym typeface="Consolas"/>
+              </a:rPr>
+              <a:t>The events are published asynchronously </a:t>
+            </a:r>
+            <a:r>
+              <a:rPr lang="en-GB" sz="1100">
+                <a:solidFill>
+                  <a:srgbClr val="DFE1E5"/>
+                </a:solidFill>
+                <a:latin typeface="Arial"/>
+                <a:ea typeface="Arial"/>
+                <a:cs typeface="Arial"/>
+                <a:sym typeface="Arial"/>
+              </a:rPr>
+              <a:t>, this prevents Kafka I/O from blocking the 5-second polling cycles - the ingestion services continue collecting data while Kafka processes messages in the background</a:t>
+            </a:r>
+            <a:endParaRPr sz="1100">
+              <a:solidFill>
+                <a:srgbClr val="DFE1E5"/>
+              </a:solidFill>
+              <a:latin typeface="Arial"/>
+              <a:ea typeface="Arial"/>
+              <a:cs typeface="Arial"/>
+              <a:sym typeface="Arial"/>
+            </a:endParaRPr>
           </a:p>
           <a:p>
-            <a:pPr indent="-330200" lvl="0" marL="457200" rtl="0" algn="l">
-              <a:spcBef>
-                <a:spcPts val="0"/>
-              </a:spcBef>
-              <a:spcAft>
-                <a:spcPts val="0"/>
-              </a:spcAft>
-              <a:buSzPts val="1600"/>
+            <a:pPr indent="-282575" lvl="0" marL="457200" rtl="0" algn="l">
+              <a:lnSpc>
+                <a:spcPct val="160000"/>
+              </a:lnSpc>
+              <a:spcBef>
+                <a:spcPts val="0"/>
+              </a:spcBef>
+              <a:spcAft>
+                <a:spcPts val="0"/>
+              </a:spcAft>
+              <a:buClr>
+                <a:srgbClr val="DFE1E5"/>
+              </a:buClr>
+              <a:buSzPts val="850"/>
+              <a:buFont typeface="Consolas"/>
               <a:buChar char="●"/>
             </a:pPr>
             <a:r>
-              <a:rPr lang="en-GB" sz="1600"/>
-              <a:t>If rules trigger, it commands the API Gateway to physically toggle the actuator. It then saves the new reading to the Cache and tells the Gateway to broadcast it.</a:t>
+              <a:rPr lang="en-GB" sz="1100">
+                <a:solidFill>
+                  <a:srgbClr val="DFE1E5"/>
+                </a:solidFill>
+                <a:latin typeface="Arial"/>
+                <a:ea typeface="Arial"/>
+                <a:cs typeface="Arial"/>
+                <a:sym typeface="Arial"/>
+              </a:rPr>
+              <a:t>We use sensor names as message keys to ensure consistent partitioning - all readings from the same sensor go to the same partition, maintaining chronological order.</a:t>
+            </a:r>
+            <a:endParaRPr sz="1100">
+              <a:solidFill>
+                <a:srgbClr val="DFE1E5"/>
+              </a:solidFill>
+              <a:latin typeface="Arial"/>
+              <a:ea typeface="Arial"/>
+              <a:cs typeface="Arial"/>
+              <a:sym typeface="Arial"/>
+            </a:endParaRPr>
+          </a:p>
+          <a:p>
+            <a:pPr indent="0" lvl="0" marL="0" rtl="0" algn="l">
+              <a:spcBef>
+                <a:spcPts val="900"/>
+              </a:spcBef>
+              <a:spcAft>
+                <a:spcPts val="0"/>
+              </a:spcAft>
+              <a:buNone/>
+            </a:pPr>
+            <a:r>
+              <a:t/>
+            </a:r>
+            <a:endParaRPr sz="850">
+              <a:solidFill>
+                <a:srgbClr val="DFE1E5"/>
+              </a:solidFill>
+              <a:latin typeface="Consolas"/>
+              <a:ea typeface="Consolas"/>
+              <a:cs typeface="Consolas"/>
+              <a:sym typeface="Consolas"/>
+            </a:endParaRPr>
+          </a:p>
+          <a:p>
+            <a:pPr indent="0" lvl="0" marL="457200" rtl="0" algn="l">
+              <a:lnSpc>
+                <a:spcPct val="150000"/>
+              </a:lnSpc>
+              <a:spcBef>
+                <a:spcPts val="500"/>
+              </a:spcBef>
+              <a:spcAft>
+                <a:spcPts val="600"/>
+              </a:spcAft>
+              <a:buNone/>
+            </a:pPr>
+            <a:r>
+              <a:t/>
             </a:r>
             <a:endParaRPr sz="1600"/>
           </a:p>

</xml_diff>